<commit_message>
Make product and partnership discussion investor neutral
</commit_message>
<xml_diff>
--- a/research/insta360-frame-discussion/unseen-insta360-discussion.pptx
+++ b/research/insta360-frame-discussion/unseen-insta360-discussion.pptx
@@ -2,25 +2,25 @@
 <file path=ppt/presentation.xml><?xml version="1.0" encoding="utf-8"?>
 <p:presentation xmlns:p="http://schemas.openxmlformats.org/presentationml/2006/main">
   <p:sldMasterIdLst>
-    <p:sldMasterId xmlns:r="http://schemas.openxmlformats.org/officeDocument/2006/relationships" id="2147483648" r:id="R0f111ff803584d7b"/>
+    <p:sldMasterId xmlns:r="http://schemas.openxmlformats.org/officeDocument/2006/relationships" id="2147483648" r:id="R77b08d60ef00461c"/>
   </p:sldMasterIdLst>
   <p:notesMasterIdLst>
-    <p:notesMasterId xmlns:r="http://schemas.openxmlformats.org/officeDocument/2006/relationships" r:id="R62c5eb835d584675"/>
+    <p:notesMasterId xmlns:r="http://schemas.openxmlformats.org/officeDocument/2006/relationships" r:id="Re26259a0f0824f35"/>
   </p:notesMasterIdLst>
   <p:sldIdLst>
-    <p:sldId xmlns:r="http://schemas.openxmlformats.org/officeDocument/2006/relationships" id="256" r:id="Ra4a70e89c3564ce2"/>
-    <p:sldId xmlns:r="http://schemas.openxmlformats.org/officeDocument/2006/relationships" id="257" r:id="Rf1655d2620a14975"/>
-    <p:sldId xmlns:r="http://schemas.openxmlformats.org/officeDocument/2006/relationships" id="258" r:id="Ree0036fd95a14ed0"/>
-    <p:sldId xmlns:r="http://schemas.openxmlformats.org/officeDocument/2006/relationships" id="259" r:id="Rb1241d07eb8b4d6b"/>
-    <p:sldId xmlns:r="http://schemas.openxmlformats.org/officeDocument/2006/relationships" id="260" r:id="R88db57099c0149df"/>
-    <p:sldId xmlns:r="http://schemas.openxmlformats.org/officeDocument/2006/relationships" id="261" r:id="R69cc40d9bea5474d"/>
-    <p:sldId xmlns:r="http://schemas.openxmlformats.org/officeDocument/2006/relationships" id="262" r:id="R3a52369b8baf4751"/>
-    <p:sldId xmlns:r="http://schemas.openxmlformats.org/officeDocument/2006/relationships" id="263" r:id="Re739845d67244ae5"/>
-    <p:sldId xmlns:r="http://schemas.openxmlformats.org/officeDocument/2006/relationships" id="264" r:id="Reb05a6f6cd1645ad"/>
-    <p:sldId xmlns:r="http://schemas.openxmlformats.org/officeDocument/2006/relationships" id="265" r:id="R9426ec2daeb54e5d"/>
-    <p:sldId xmlns:r="http://schemas.openxmlformats.org/officeDocument/2006/relationships" id="266" r:id="R00738e250ac54fd2"/>
-    <p:sldId xmlns:r="http://schemas.openxmlformats.org/officeDocument/2006/relationships" id="267" r:id="R28b13cc5c0c14fc0"/>
-    <p:sldId xmlns:r="http://schemas.openxmlformats.org/officeDocument/2006/relationships" id="268" r:id="R35d1cf4438ba41b2"/>
+    <p:sldId xmlns:r="http://schemas.openxmlformats.org/officeDocument/2006/relationships" id="256" r:id="Rec097e4b61d64474"/>
+    <p:sldId xmlns:r="http://schemas.openxmlformats.org/officeDocument/2006/relationships" id="257" r:id="R3e928f4a4ca647aa"/>
+    <p:sldId xmlns:r="http://schemas.openxmlformats.org/officeDocument/2006/relationships" id="258" r:id="Rbbaf46626a5c48ec"/>
+    <p:sldId xmlns:r="http://schemas.openxmlformats.org/officeDocument/2006/relationships" id="259" r:id="Re4327586101b477d"/>
+    <p:sldId xmlns:r="http://schemas.openxmlformats.org/officeDocument/2006/relationships" id="260" r:id="R4499125737874ad9"/>
+    <p:sldId xmlns:r="http://schemas.openxmlformats.org/officeDocument/2006/relationships" id="261" r:id="R04946dcee9eb477a"/>
+    <p:sldId xmlns:r="http://schemas.openxmlformats.org/officeDocument/2006/relationships" id="262" r:id="R904c2f9db5094c29"/>
+    <p:sldId xmlns:r="http://schemas.openxmlformats.org/officeDocument/2006/relationships" id="263" r:id="Rdab9be567c3f41ca"/>
+    <p:sldId xmlns:r="http://schemas.openxmlformats.org/officeDocument/2006/relationships" id="264" r:id="R61ca8fe6eb3e4423"/>
+    <p:sldId xmlns:r="http://schemas.openxmlformats.org/officeDocument/2006/relationships" id="265" r:id="R4855ce3647a341fe"/>
+    <p:sldId xmlns:r="http://schemas.openxmlformats.org/officeDocument/2006/relationships" id="266" r:id="Radda45a9c3674485"/>
+    <p:sldId xmlns:r="http://schemas.openxmlformats.org/officeDocument/2006/relationships" id="267" r:id="R52696710edad44ca"/>
+    <p:sldId xmlns:r="http://schemas.openxmlformats.org/officeDocument/2006/relationships" id="268" r:id="R2cb3807718324a76"/>
   </p:sldIdLst>
   <p:sldSz cx="12192000" cy="6858000"/>
   <p:notesSz cx="6858000" cy="9144000"/>
@@ -454,27 +454,7 @@
           <a:lstStyle xmlns:a="http://schemas.openxmlformats.org/drawingml/2006/main"/>
           <a:p xmlns:a="http://schemas.openxmlformats.org/drawingml/2006/main">
             <a:r>
-              <a:t>建议 1 分钟。今天重点讨论合作路径和下一阶段验证。影石拥有采集与影像处理能力；我们希望探索家庭中持续呈现与回应的一段体验。目前提出的是合作方案，不代表双方已达成合作、品牌授权或投资。资金上先明确样机与验证支持，股权融资后置到产品和需求证据更充分时。</a:t>
-            </a:r>
-          </a:p>
-          <a:p xmlns:a="http://schemas.openxmlformats.org/drawingml/2006/main">
-            <a:r>
-              <a:t/>
-            </a:r>
-          </a:p>
-          <a:p xmlns:a="http://schemas.openxmlformats.org/drawingml/2006/main">
-            <a:r>
-              <a:t>[A2] 影石官方手册：AI 导演 | 2026-10-12 查阅 | 功能介绍</a:t>
-            </a:r>
-          </a:p>
-          <a:p xmlns:a="http://schemas.openxmlformats.org/drawingml/2006/main">
-            <a:r>
-              <a:t>https://onlinemanual.insta360.com/app/zh-cn/operation_tutorial/edit_function/director</a:t>
-            </a:r>
-          </a:p>
-          <a:p xmlns:a="http://schemas.openxmlformats.org/drawingml/2006/main">
-            <a:r>
-              <a:t>已有素材筛选、自动剪辑等能力。基础 AI 整理不宜作为影石缺失能力来推介。</a:t>
+              <a:t>建议 1 分钟。UNSEEN 探索家庭影像的持续呈现、原声讲述与回应。当前以实体设备和市场需求验证为重点。希望结合投资人或合作伙伴的资金、工程与渠道资源，明确下一阶段的成果和评估方式。合作形式与投入范围按实际资源共同商定。</a:t>
             </a:r>
           </a:p>
         </p:txBody>
@@ -544,7 +524,7 @@
           <a:lstStyle xmlns:a="http://schemas.openxmlformats.org/drawingml/2006/main"/>
           <a:p xmlns:a="http://schemas.openxmlformats.org/drawingml/2006/main">
             <a:r>
-              <a:t>建议 2 分钟。融资可以后置，但不能把样机和试点所需的现金问题也后置。平台预售款何时可用，要按真实结算条款核对。示例现金表应逐笔列出工厂订金、备料和尾款的日期，物流、售后与退款准备，再对应已落实的钱。若下单前仍有缺口，就缩小批次、协商付款节点或补足资金，不把尚未到账的订单总额当现金。金额目前没有报价依据，因此不虚填。</a:t>
+              <a:t>建议 2 分钟。融资节奏可以结合证据积累安排，样机和试点预算在启动前明确。预算按付款时间列出研发、开模、工厂货款、物流和服务支出，再匹配已落实资金。预售净款的口径需统一，平台费用和退款准备只扣一次，交付成本单列。具体金额随工程报价、平台结算和试点范围测算。</a:t>
             </a:r>
           </a:p>
           <a:p xmlns:a="http://schemas.openxmlformats.org/drawingml/2006/main">
@@ -554,7 +534,7 @@
           </a:p>
           <a:p xmlns:a="http://schemas.openxmlformats.org/drawingml/2006/main">
             <a:r>
-              <a:t>[U3] 本次项目方向与计划 | 2026-10-13 | Max 本轮口述及转写纠正</a:t>
+              <a:t>[U3] 产品验证与市场规划 | 2026-10-13 | 团队当前规划</a:t>
             </a:r>
           </a:p>
           <a:p xmlns:a="http://schemas.openxmlformats.org/drawingml/2006/main">
@@ -564,7 +544,7 @@
           </a:p>
           <a:p xmlns:a="http://schemas.openxmlformats.org/drawingml/2006/main">
             <a:r>
-              <a:t>翻译笔验证 → 大屏多机试用 → 视频与市场测试 → 国内平台预售 → 工厂订单与交付；先有产品和订单信号，再讨论融资。未规划车内产品。</a:t>
+              <a:t>翻译笔验证、大屏样机、家庭试用、国内预售、公益采购与海外需求测试。样机数量和排期为讨论方案。</a:t>
             </a:r>
           </a:p>
         </p:txBody>
@@ -634,7 +614,7 @@
           <a:lstStyle xmlns:a="http://schemas.openxmlformats.org/drawingml/2006/main"/>
           <a:p xmlns:a="http://schemas.openxmlformats.org/drawingml/2006/main">
             <a:r>
-              <a:t>建议 2 分钟。这次不再把立刻拿股权投资当作唯一目标。优先把一个可以执行的样机共创阶段落地：谁来对接、双方各做什么、预算怎么出、何时看结果。店铺和投资是后续路径；不要让所有资源诉求同时成为启动前提。</a:t>
+              <a:t>建议 2 分钟。以支持、具体行动和可验证成果对齐期待。阶段成果是执行目标，实际结果通过记录和评审确认。对于采集端或影像品牌，家庭持续呈现与回应可能增加新的使用场景。对于投资人，样机、成本、使用和订单记录有助于评估后续投资。商业回报及股权权益按实际合作另行约定。</a:t>
             </a:r>
           </a:p>
           <a:p xmlns:a="http://schemas.openxmlformats.org/drawingml/2006/main">
@@ -644,7 +624,7 @@
           </a:p>
           <a:p xmlns:a="http://schemas.openxmlformats.org/drawingml/2006/main">
             <a:r>
-              <a:t>[U3] 本次项目方向与计划 | 2026-10-13 | Max 本轮口述及转写纠正</a:t>
+              <a:t>[U3] 产品验证与市场规划 | 2026-10-13 | 团队当前规划</a:t>
             </a:r>
           </a:p>
           <a:p xmlns:a="http://schemas.openxmlformats.org/drawingml/2006/main">
@@ -654,7 +634,7 @@
           </a:p>
           <a:p xmlns:a="http://schemas.openxmlformats.org/drawingml/2006/main">
             <a:r>
-              <a:t>翻译笔验证 → 大屏多机试用 → 视频与市场测试 → 国内平台预售 → 工厂订单与交付；先有产品和订单信号，再讨论融资。未规划车内产品。</a:t>
+              <a:t>翻译笔验证、大屏样机、家庭试用、国内预售、公益采购与海外需求测试。样机数量和排期为讨论方案。</a:t>
             </a:r>
           </a:p>
         </p:txBody>
@@ -724,7 +704,7 @@
           <a:lstStyle xmlns:a="http://schemas.openxmlformats.org/drawingml/2006/main"/>
           <a:p xmlns:a="http://schemas.openxmlformats.org/drawingml/2006/main">
             <a:r>
-              <a:t>预留 6 分钟讨论，整场合计 30 分钟。建议现场记录三个明确结果：当前阶段负责人、双方需要补的证据、下一次评审时间。如果对方更倾向直接投资，也可以听取方案，但仍然围绕产品与资金用途作具体沟通。若暂无合作资源，继续在已有预算内推进设备测试，不把所有进度押在单一合作方。</a:t>
+              <a:t>预留 6 分钟讨论，整场约 30 分钟。会议结束时明确下一阶段范围、负责人、投入和复盘日期。合作方式可结合实际资源选择。关于投资的讨论仍围绕资金用途、阶段目标及评估依据展开。</a:t>
             </a:r>
           </a:p>
         </p:txBody>
@@ -794,7 +774,7 @@
           <a:lstStyle xmlns:a="http://schemas.openxmlformats.org/drawingml/2006/main"/>
           <a:p xmlns:a="http://schemas.openxmlformats.org/drawingml/2006/main">
             <a:r>
-              <a:t>公开来源 A1 核实颁奖时间；A2 说明影石已有 AI 影像处理能力。因此不声称影石完全没有呈现或编辑能力。用户补充 U3 决定本版方向。该版本没有指定具体预售平台，没有承诺融资金额、品牌授权、首批交货日期或公益合作。</a:t>
+              <a:t>公开报道支持赛事颁奖日期。获奖归属沿用团队已确认记录。外观图复用 2026 年 10 月 8 日 R1 方案，并标明概念状态。排期和样机数量为规划建议，具体报价、渠道、合作及交付安排待确认。</a:t>
             </a:r>
           </a:p>
           <a:p xmlns:a="http://schemas.openxmlformats.org/drawingml/2006/main">
@@ -829,22 +809,22 @@
           </a:p>
           <a:p xmlns:a="http://schemas.openxmlformats.org/drawingml/2006/main">
             <a:r>
-              <a:t>[A2] 影石官方手册：AI 导演</a:t>
-            </a:r>
-          </a:p>
-          <a:p xmlns:a="http://schemas.openxmlformats.org/drawingml/2006/main">
-            <a:r>
-              <a:t>https://onlinemanual.insta360.com/app/zh-cn/operation_tutorial/edit_function/director</a:t>
-            </a:r>
-          </a:p>
-          <a:p xmlns:a="http://schemas.openxmlformats.org/drawingml/2006/main">
-            <a:r>
-              <a:t>2026-10-12 查阅 | 功能介绍</a:t>
-            </a:r>
-          </a:p>
-          <a:p xmlns:a="http://schemas.openxmlformats.org/drawingml/2006/main">
-            <a:r>
-              <a:t>已有素材筛选、自动剪辑等能力。基础 AI 整理不宜作为影石缺失能力来推介。</a:t>
+              <a:t>[P2] 项目成果与设备验证记录</a:t>
+            </a:r>
+          </a:p>
+          <a:p xmlns:a="http://schemas.openxmlformats.org/drawingml/2006/main">
+            <a:r>
+              <a:t>用户提供／项目内部记录</a:t>
+            </a:r>
+          </a:p>
+          <a:p xmlns:a="http://schemas.openxmlformats.org/drawingml/2006/main">
+            <a:r>
+              <a:t>截至 2026-10-13 | 团队项目记录</a:t>
+            </a:r>
+          </a:p>
+          <a:p xmlns:a="http://schemas.openxmlformats.org/drawingml/2006/main">
+            <a:r>
+              <a:t>影石 AI+社会公益赛道第一名为团队确认成果。当前通过翻译笔开展实体 Demo 验证，持续运行结果待设备测试确认。</a:t>
             </a:r>
           </a:p>
           <a:p xmlns:a="http://schemas.openxmlformats.org/drawingml/2006/main">
@@ -854,7 +834,7 @@
           </a:p>
           <a:p xmlns:a="http://schemas.openxmlformats.org/drawingml/2006/main">
             <a:r>
-              <a:t>[U3] 本次项目方向与计划</a:t>
+              <a:t>[D1] UNSEEN 原有外观与结构方案</a:t>
             </a:r>
           </a:p>
           <a:p xmlns:a="http://schemas.openxmlformats.org/drawingml/2006/main">
@@ -864,12 +844,12 @@
           </a:p>
           <a:p xmlns:a="http://schemas.openxmlformats.org/drawingml/2006/main">
             <a:r>
-              <a:t>2026-10-13 | Max 本轮口述及转写纠正</a:t>
-            </a:r>
-          </a:p>
-          <a:p xmlns:a="http://schemas.openxmlformats.org/drawingml/2006/main">
-            <a:r>
-              <a:t>翻译笔验证 → 大屏多机试用 → 视频与市场测试 → 国内平台预售 → 工厂订单与交付；先有产品和订单信号，再讨论融资。未规划车内产品。</a:t>
+              <a:t>2026-10-08 | R1 设计评审稿</a:t>
+            </a:r>
+          </a:p>
+          <a:p xmlns:a="http://schemas.openxmlformats.org/drawingml/2006/main">
+            <a:r>
+              <a:t>浅木色外框、暖白后壳、灰绿与陶土红双键。独立相框作为首版方向，灯座构型作为后续备选。图片为设计概念。</a:t>
             </a:r>
           </a:p>
           <a:p xmlns:a="http://schemas.openxmlformats.org/drawingml/2006/main">
@@ -879,7 +859,7 @@
           </a:p>
           <a:p xmlns:a="http://schemas.openxmlformats.org/drawingml/2006/main">
             <a:r>
-              <a:t>[P2] 获奖口径与当前阶段</a:t>
+              <a:t>[U3] 产品验证与市场规划</a:t>
             </a:r>
           </a:p>
           <a:p xmlns:a="http://schemas.openxmlformats.org/drawingml/2006/main">
@@ -889,12 +869,12 @@
           </a:p>
           <a:p xmlns:a="http://schemas.openxmlformats.org/drawingml/2006/main">
             <a:r>
-              <a:t>用户既有确认；当前状态以 2026-10-13 补充为准 | UNSEEN 获奖记录与本次讨论</a:t>
-            </a:r>
-          </a:p>
-          <a:p xmlns:a="http://schemas.openxmlformats.org/drawingml/2006/main">
-            <a:r>
-              <a:t>影石 AI+社会公益赛道第一名为用户已确认成绩；公开报道用于核对典礼日期。翻译笔用于一代实体 Demo 验证，独立运行稳定性仍需设备测试。</a:t>
+              <a:t>2026-10-13 | 团队当前规划</a:t>
+            </a:r>
+          </a:p>
+          <a:p xmlns:a="http://schemas.openxmlformats.org/drawingml/2006/main">
+            <a:r>
+              <a:t>翻译笔验证、大屏样机、家庭试用、国内预售、公益采购与海外需求测试。样机数量和排期为讨论方案。</a:t>
             </a:r>
           </a:p>
         </p:txBody>
@@ -964,7 +944,7 @@
           <a:lstStyle xmlns:a="http://schemas.openxmlformats.org/drawingml/2006/main"/>
           <a:p xmlns:a="http://schemas.openxmlformats.org/drawingml/2006/main">
             <a:r>
-              <a:t>建议 2 分钟。先讲比赛之后项目继续推进的事实，再拿出当前翻译笔。9 月 24 日是已核实的颁奖日期；第一名归属沿用用户已确认成绩，不把日期报道当作完整获奖名单。翻译笔是验证载体，不是已经决定销售的 SKU。没有验过的实体能力直接说明，不填稳定运行天数。</a:t>
+              <a:t>建议 2 分钟。获奖是项目已有成果，当前实体 Demo 以翻译笔为验证载体。独立设备运行指脱离开发电脑使用，具体联网和云端依赖按演示说明。展示已有能力，并说明仍在测试的部分。</a:t>
             </a:r>
           </a:p>
           <a:p xmlns:a="http://schemas.openxmlformats.org/drawingml/2006/main">
@@ -994,7 +974,7 @@
           </a:p>
           <a:p xmlns:a="http://schemas.openxmlformats.org/drawingml/2006/main">
             <a:r>
-              <a:t>[P2] 获奖口径与当前阶段 | 用户既有确认；当前状态以 2026-10-13 补充为准 | UNSEEN 获奖记录与本次讨论</a:t>
+              <a:t>[P2] 项目成果与设备验证记录 | 截至 2026-10-13 | 团队项目记录</a:t>
             </a:r>
           </a:p>
           <a:p xmlns:a="http://schemas.openxmlformats.org/drawingml/2006/main">
@@ -1004,7 +984,7 @@
           </a:p>
           <a:p xmlns:a="http://schemas.openxmlformats.org/drawingml/2006/main">
             <a:r>
-              <a:t>影石 AI+社会公益赛道第一名为用户已确认成绩；公开报道用于核对典礼日期。翻译笔用于一代实体 Demo 验证，独立运行稳定性仍需设备测试。</a:t>
+              <a:t>影石 AI+社会公益赛道第一名为团队确认成果。当前通过翻译笔开展实体 Demo 验证，持续运行结果待设备测试确认。</a:t>
             </a:r>
           </a:p>
           <a:p xmlns:a="http://schemas.openxmlformats.org/drawingml/2006/main">
@@ -1014,7 +994,7 @@
           </a:p>
           <a:p xmlns:a="http://schemas.openxmlformats.org/drawingml/2006/main">
             <a:r>
-              <a:t>[U3] 本次项目方向与计划 | 2026-10-13 | Max 本轮口述及转写纠正</a:t>
+              <a:t>[U3] 产品验证与市场规划 | 2026-10-13 | 团队当前规划</a:t>
             </a:r>
           </a:p>
           <a:p xmlns:a="http://schemas.openxmlformats.org/drawingml/2006/main">
@@ -1024,7 +1004,7 @@
           </a:p>
           <a:p xmlns:a="http://schemas.openxmlformats.org/drawingml/2006/main">
             <a:r>
-              <a:t>翻译笔验证 → 大屏多机试用 → 视频与市场测试 → 国内平台预售 → 工厂订单与交付；先有产品和订单信号，再讨论融资。未规划车内产品。</a:t>
+              <a:t>翻译笔验证、大屏样机、家庭试用、国内预售、公益采购与海外需求测试。样机数量和排期为讨论方案。</a:t>
             </a:r>
           </a:p>
         </p:txBody>
@@ -1094,7 +1074,7 @@
           <a:lstStyle xmlns:a="http://schemas.openxmlformats.org/drawingml/2006/main"/>
           <a:p xmlns:a="http://schemas.openxmlformats.org/drawingml/2006/main">
             <a:r>
-              <a:t>建议 2 分钟。将产品版本和获客路径分开：家庭智能屏是核心产品，公益是组织采购与试点模式，海外是地区市场版本。5–10 台为建议起点，不是已完成数量。用户澄清后，不加入“车内产品线”。</a:t>
+              <a:t>建议 2 分钟。产品主线为家庭智能屏。原有 R1 外观方案以 A01 独立相框作为首版方向，B01 灯座构型作为后续备选。展示的产品图为已有设计概念。公益和海外分别是服务模式与市场方向，先共享产品能力，再按验证结果细分。5–10 台为计划建议。</a:t>
             </a:r>
           </a:p>
           <a:p xmlns:a="http://schemas.openxmlformats.org/drawingml/2006/main">
@@ -1104,7 +1084,7 @@
           </a:p>
           <a:p xmlns:a="http://schemas.openxmlformats.org/drawingml/2006/main">
             <a:r>
-              <a:t>[U3] 本次项目方向与计划 | 2026-10-13 | Max 本轮口述及转写纠正</a:t>
+              <a:t>[D1] UNSEEN 原有外观与结构方案 | 2026-10-08 | R1 设计评审稿</a:t>
             </a:r>
           </a:p>
           <a:p xmlns:a="http://schemas.openxmlformats.org/drawingml/2006/main">
@@ -1114,7 +1094,27 @@
           </a:p>
           <a:p xmlns:a="http://schemas.openxmlformats.org/drawingml/2006/main">
             <a:r>
-              <a:t>翻译笔验证 → 大屏多机试用 → 视频与市场测试 → 国内平台预售 → 工厂订单与交付；先有产品和订单信号，再讨论融资。未规划车内产品。</a:t>
+              <a:t>浅木色外框、暖白后壳、灰绿与陶土红双键。独立相框作为首版方向，灯座构型作为后续备选。图片为设计概念。</a:t>
+            </a:r>
+          </a:p>
+          <a:p xmlns:a="http://schemas.openxmlformats.org/drawingml/2006/main">
+            <a:r>
+              <a:t/>
+            </a:r>
+          </a:p>
+          <a:p xmlns:a="http://schemas.openxmlformats.org/drawingml/2006/main">
+            <a:r>
+              <a:t>[U3] 产品验证与市场规划 | 2026-10-13 | 团队当前规划</a:t>
+            </a:r>
+          </a:p>
+          <a:p xmlns:a="http://schemas.openxmlformats.org/drawingml/2006/main">
+            <a:r>
+              <a:t>用户提供／项目内部记录</a:t>
+            </a:r>
+          </a:p>
+          <a:p xmlns:a="http://schemas.openxmlformats.org/drawingml/2006/main">
+            <a:r>
+              <a:t>翻译笔验证、大屏样机、家庭试用、国内预售、公益采购与海外需求测试。样机数量和排期为讨论方案。</a:t>
             </a:r>
           </a:p>
         </p:txBody>
@@ -1194,7 +1194,7 @@
           </a:p>
           <a:p xmlns:a="http://schemas.openxmlformats.org/drawingml/2006/main">
             <a:r>
-              <a:t>[U3] 本次项目方向与计划 | 2026-10-13 | Max 本轮口述及转写纠正</a:t>
+              <a:t>[U3] 产品验证与市场规划 | 2026-10-13 | 团队当前规划</a:t>
             </a:r>
           </a:p>
           <a:p xmlns:a="http://schemas.openxmlformats.org/drawingml/2006/main">
@@ -1204,7 +1204,7 @@
           </a:p>
           <a:p xmlns:a="http://schemas.openxmlformats.org/drawingml/2006/main">
             <a:r>
-              <a:t>翻译笔验证 → 大屏多机试用 → 视频与市场测试 → 国内平台预售 → 工厂订单与交付；先有产品和订单信号，再讨论融资。未规划车内产品。</a:t>
+              <a:t>翻译笔验证、大屏样机、家庭试用、国内预售、公益采购与海外需求测试。样机数量和排期为讨论方案。</a:t>
             </a:r>
           </a:p>
         </p:txBody>
@@ -1274,7 +1274,7 @@
           <a:lstStyle xmlns:a="http://schemas.openxmlformats.org/drawingml/2006/main"/>
           <a:p xmlns:a="http://schemas.openxmlformats.org/drawingml/2006/main">
             <a:r>
-              <a:t>建议 2 分钟。这里的目标是通过国内预售平台验证需求并获得订单资金，不把预售称作已经融到股权资金。尚未核实具体平台和类目规则，因此不写死平台名称。“影石独家授权的店”按用户确认保留为待商谈路径，不能在获得授权前展示已授权标识。意向登记、支付订金、全额付款和成功交付是不同证据。</a:t>
+              <a:t>建议 2 分钟。国内预售路径包括内容测试、意向登记、付费订单和交付。具体平台需核验类目准入、费用与资金结算。获得品牌或渠道授权后，可评估独家授权店，其范围、期限、运营、收款与售后责任由双方约定。资金规划只计实际可支取的预售净款。</a:t>
             </a:r>
           </a:p>
           <a:p xmlns:a="http://schemas.openxmlformats.org/drawingml/2006/main">
@@ -1284,7 +1284,7 @@
           </a:p>
           <a:p xmlns:a="http://schemas.openxmlformats.org/drawingml/2006/main">
             <a:r>
-              <a:t>[U3] 本次项目方向与计划 | 2026-10-13 | Max 本轮口述及转写纠正</a:t>
+              <a:t>[U3] 产品验证与市场规划 | 2026-10-13 | 团队当前规划</a:t>
             </a:r>
           </a:p>
           <a:p xmlns:a="http://schemas.openxmlformats.org/drawingml/2006/main">
@@ -1294,7 +1294,7 @@
           </a:p>
           <a:p xmlns:a="http://schemas.openxmlformats.org/drawingml/2006/main">
             <a:r>
-              <a:t>翻译笔验证 → 大屏多机试用 → 视频与市场测试 → 国内平台预售 → 工厂订单与交付；先有产品和订单信号，再讨论融资。未规划车内产品。</a:t>
+              <a:t>翻译笔验证、大屏样机、家庭试用、国内预售、公益采购与海外需求测试。样机数量和排期为讨论方案。</a:t>
             </a:r>
           </a:p>
         </p:txBody>
@@ -1364,7 +1364,7 @@
           <a:lstStyle xmlns:a="http://schemas.openxmlformats.org/drawingml/2006/main"/>
           <a:p xmlns:a="http://schemas.openxmlformats.org/drawingml/2006/main">
             <a:r>
-              <a:t>建议 2 分钟。把“公益公司出钱、我们成本价捐赠”整理为明确的资金流：资金方采购或资助，组织负责分发和运营，我们按合同交付。成本需要包含必要安装和持续支持，避免把后续服务漏掉。公益合作可以建立可信案例，但没有约定就不声称得到某机构背书。视频拍摄须单独征得同意，不以接受采访换取设备。</a:t>
+              <a:t>建议 2 分钟。公益路径可作为组织采购与试点，不预设已经获得合作或背书。成本包含设备及约定服务，明确持续支持责任。影像记录单独获得同意，赠送不以参与宣传为条件。公益使用数据用于评估体验与服务，消费者购买意愿另行验证。</a:t>
             </a:r>
           </a:p>
           <a:p xmlns:a="http://schemas.openxmlformats.org/drawingml/2006/main">
@@ -1374,7 +1374,7 @@
           </a:p>
           <a:p xmlns:a="http://schemas.openxmlformats.org/drawingml/2006/main">
             <a:r>
-              <a:t>[U3] 本次项目方向与计划 | 2026-10-13 | Max 本轮口述及转写纠正</a:t>
+              <a:t>[U3] 产品验证与市场规划 | 2026-10-13 | 团队当前规划</a:t>
             </a:r>
           </a:p>
           <a:p xmlns:a="http://schemas.openxmlformats.org/drawingml/2006/main">
@@ -1384,7 +1384,7 @@
           </a:p>
           <a:p xmlns:a="http://schemas.openxmlformats.org/drawingml/2006/main">
             <a:r>
-              <a:t>翻译笔验证 → 大屏多机试用 → 视频与市场测试 → 国内平台预售 → 工厂订单与交付；先有产品和订单信号，再讨论融资。未规划车内产品。</a:t>
+              <a:t>翻译笔验证、大屏样机、家庭试用、国内预售、公益采购与海外需求测试。样机数量和排期为讨论方案。</a:t>
             </a:r>
           </a:p>
         </p:txBody>
@@ -1454,7 +1454,7 @@
           <a:lstStyle xmlns:a="http://schemas.openxmlformats.org/drawingml/2006/main"/>
           <a:p xmlns:a="http://schemas.openxmlformats.org/drawingml/2006/main">
             <a:r>
-              <a:t>建议 2 分钟。用户提出海外方向，但尚未指定国家，因此不替团队选定市场或承诺上线时间。先做可低成本执行的需求测试；涉及跨境付款与硬件交付时，再核实具体市场规则与成本。这与国内样机、公益对接可以并行，但不要把未付费等待名单算成订单。</a:t>
+              <a:t>建议 2 分钟。海外市场尚未选定，以团队可触达和可服务的范围开展低成本验证。意向、付费订单与交付各自记录。涉及当地销售与付款前，核实适用的产品要求及实际成本。</a:t>
             </a:r>
           </a:p>
           <a:p xmlns:a="http://schemas.openxmlformats.org/drawingml/2006/main">
@@ -1464,7 +1464,7 @@
           </a:p>
           <a:p xmlns:a="http://schemas.openxmlformats.org/drawingml/2006/main">
             <a:r>
-              <a:t>[U3] 本次项目方向与计划 | 2026-10-13 | Max 本轮口述及转写纠正</a:t>
+              <a:t>[U3] 产品验证与市场规划 | 2026-10-13 | 团队当前规划</a:t>
             </a:r>
           </a:p>
           <a:p xmlns:a="http://schemas.openxmlformats.org/drawingml/2006/main">
@@ -1474,7 +1474,7 @@
           </a:p>
           <a:p xmlns:a="http://schemas.openxmlformats.org/drawingml/2006/main">
             <a:r>
-              <a:t>翻译笔验证 → 大屏多机试用 → 视频与市场测试 → 国内平台预售 → 工厂订单与交付；先有产品和订单信号，再讨论融资。未规划车内产品。</a:t>
+              <a:t>翻译笔验证、大屏样机、家庭试用、国内预售、公益采购与海外需求测试。样机数量和排期为讨论方案。</a:t>
             </a:r>
           </a:p>
         </p:txBody>
@@ -1544,7 +1544,7 @@
           <a:lstStyle xmlns:a="http://schemas.openxmlformats.org/drawingml/2006/main"/>
           <a:p xmlns:a="http://schemas.openxmlformats.org/drawingml/2006/main">
             <a:r>
-              <a:t>建议 3 分钟。这几种方式是供双方选择的方案，不假设影石已提供任何支持。孵化不自动等于股权投资；共创也不自动意味着对方替团队承担生产经营风险。报道提及基地孵化与赛事资源，可以顺势询问可用的具体入口和申请条件，但不声称我们已获得资格或资金。</a:t>
+              <a:t>建议 3 分钟。合作模式面向任何合适的产业伙伴、孵化机构或投资人。产品共创优先用于补齐样机阶段的工程能力。渠道合作可以包括已获授权范围内的独家店铺。投资安排结合产品和订单信号推进。各模式可组合，股权、知识产权及独家期限须形成明确约定。团队在已有预算内也可继续推进基础验证。</a:t>
             </a:r>
           </a:p>
           <a:p xmlns:a="http://schemas.openxmlformats.org/drawingml/2006/main">
@@ -1554,7 +1554,7 @@
           </a:p>
           <a:p xmlns:a="http://schemas.openxmlformats.org/drawingml/2006/main">
             <a:r>
-              <a:t>[U3] 本次项目方向与计划 | 2026-10-13 | Max 本轮口述及转写纠正</a:t>
+              <a:t>[U3] 产品验证与市场规划 | 2026-10-13 | 团队当前规划</a:t>
             </a:r>
           </a:p>
           <a:p xmlns:a="http://schemas.openxmlformats.org/drawingml/2006/main">
@@ -1564,27 +1564,7 @@
           </a:p>
           <a:p xmlns:a="http://schemas.openxmlformats.org/drawingml/2006/main">
             <a:r>
-              <a:t>翻译笔验证 → 大屏多机试用 → 视频与市场测试 → 国内平台预售 → 工厂订单与交付；先有产品和订单信号，再讨论融资。未规划车内产品。</a:t>
-            </a:r>
-          </a:p>
-          <a:p xmlns:a="http://schemas.openxmlformats.org/drawingml/2006/main">
-            <a:r>
-              <a:t/>
-            </a:r>
-          </a:p>
-          <a:p xmlns:a="http://schemas.openxmlformats.org/drawingml/2006/main">
-            <a:r>
-              <a:t>[A1] 影石 Bold Maker 挑战赛收官报道 | 2026-09-26 发布 | 正文：9 月 24 日颁奖典礼；孵化与赛事支持段</a:t>
-            </a:r>
-          </a:p>
-          <a:p xmlns:a="http://schemas.openxmlformats.org/drawingml/2006/main">
-            <a:r>
-              <a:t>https://news.jschina.com.cn/qy/202609/t20260926_s6ab7dfaee4b03e594b54bf26.shtml</a:t>
-            </a:r>
-          </a:p>
-          <a:p xmlns:a="http://schemas.openxmlformats.org/drawingml/2006/main">
-            <a:r>
-              <a:t>核实颁奖日期为 2026-09-24。报道介绍孵化、技术验证与落地支持；具体可申请项目及资格仍需确认。</a:t>
+              <a:t>翻译笔验证、大屏样机、家庭试用、国内预售、公益采购与海外需求测试。样机数量和排期为讨论方案。</a:t>
             </a:r>
           </a:p>
         </p:txBody>
@@ -1654,7 +1634,7 @@
           <a:lstStyle xmlns:a="http://schemas.openxmlformats.org/drawingml/2006/main"/>
           <a:p xmlns:a="http://schemas.openxmlformats.org/drawingml/2006/main">
             <a:r>
-              <a:t>建议 2 分钟。直接回答用户最关心的问题：即使对方愿意开模，也需要有人承担备料、工厂订金、尾款、物流、平台费用、售后和运营。建议先形成一张责任表和现金表，再收付费预售；不先口头承诺无限独家或全链条包办。具体条款需后续共同确认。</a:t>
+              <a:t>建议 2 分钟。获得开模支持后，还需要衔接工厂备料、订金、尾款、交付与售后。各项支持以实际覆盖范围进入预算。先明确模具和设计使用安排，再形成试产与付款计划。生产准备和渠道准备同时推进，交付承诺以已确认资源和排期为依据。</a:t>
             </a:r>
           </a:p>
         </p:txBody>
@@ -1701,7 +1681,7 @@
           <p:cNvPr id="3" name="Title">
             <a:extLst xmlns:a="http://schemas.openxmlformats.org/drawingml/2006/main">
               <a:ext uri="{FF2B5EF4-FFF2-40B4-BE49-F238E27FC236}">
-                <a16:creationId xmlns:a16="http://schemas.microsoft.com/office/drawing/2014/main" id="{054DDB34-03B3-4E97-AD8B-8FE15DFD45BE}"/>
+                <a16:creationId xmlns:a16="http://schemas.microsoft.com/office/drawing/2014/main" id="{A98BF0FB-AA77-4D71-908A-A67806352A62}"/>
               </a:ext>
             </a:extLst>
           </p:cNvPr>
@@ -1858,7 +1838,7 @@
           <p:cNvPr id="2" name="Subtitle">
             <a:extLst xmlns:a="http://schemas.openxmlformats.org/drawingml/2006/main">
               <a:ext uri="{FF2B5EF4-FFF2-40B4-BE49-F238E27FC236}">
-                <a16:creationId xmlns:a16="http://schemas.microsoft.com/office/drawing/2014/main" id="{257F9657-3A2B-4333-8A73-67339C5C1356}"/>
+                <a16:creationId xmlns:a16="http://schemas.microsoft.com/office/drawing/2014/main" id="{F515B74A-247A-43C8-BA85-1168978D5169}"/>
               </a:ext>
             </a:extLst>
           </p:cNvPr>
@@ -2032,7 +2012,7 @@
           <p:cNvPr id="2" name="Section title">
             <a:extLst xmlns:a="http://schemas.openxmlformats.org/drawingml/2006/main">
               <a:ext uri="{FF2B5EF4-FFF2-40B4-BE49-F238E27FC236}">
-                <a16:creationId xmlns:a16="http://schemas.microsoft.com/office/drawing/2014/main" id="{ADE14A5E-FAD4-4607-818A-A3E59C6419CA}"/>
+                <a16:creationId xmlns:a16="http://schemas.microsoft.com/office/drawing/2014/main" id="{3D753399-0236-416A-9479-61F795D0A0EA}"/>
               </a:ext>
             </a:extLst>
           </p:cNvPr>
@@ -2206,7 +2186,7 @@
           <p:cNvPr id="3" name="Title">
             <a:extLst xmlns:a="http://schemas.openxmlformats.org/drawingml/2006/main">
               <a:ext uri="{FF2B5EF4-FFF2-40B4-BE49-F238E27FC236}">
-                <a16:creationId xmlns:a16="http://schemas.microsoft.com/office/drawing/2014/main" id="{56D59823-8AA0-4425-BAC3-1B4C5BF0228D}"/>
+                <a16:creationId xmlns:a16="http://schemas.microsoft.com/office/drawing/2014/main" id="{CE525E30-8152-4D25-BC81-01EC25D8BCB5}"/>
               </a:ext>
             </a:extLst>
           </p:cNvPr>
@@ -2363,7 +2343,7 @@
           <p:cNvPr id="2" name="Body">
             <a:extLst xmlns:a="http://schemas.openxmlformats.org/drawingml/2006/main">
               <a:ext uri="{FF2B5EF4-FFF2-40B4-BE49-F238E27FC236}">
-                <a16:creationId xmlns:a16="http://schemas.microsoft.com/office/drawing/2014/main" id="{EDD78DF8-8BBC-4DD9-B747-2216EF34FDCF}"/>
+                <a16:creationId xmlns:a16="http://schemas.microsoft.com/office/drawing/2014/main" id="{F937BFAB-1407-426E-860D-75BDB3F8F2BE}"/>
               </a:ext>
             </a:extLst>
           </p:cNvPr>
@@ -2537,7 +2517,7 @@
           <p:cNvPr id="4" name="Title">
             <a:extLst xmlns:a="http://schemas.openxmlformats.org/drawingml/2006/main">
               <a:ext uri="{FF2B5EF4-FFF2-40B4-BE49-F238E27FC236}">
-                <a16:creationId xmlns:a16="http://schemas.microsoft.com/office/drawing/2014/main" id="{AB8B6483-4E10-4B35-B619-773FBA761A5D}"/>
+                <a16:creationId xmlns:a16="http://schemas.microsoft.com/office/drawing/2014/main" id="{F3E1D698-C596-4C8B-9537-F3850F5B8FC2}"/>
               </a:ext>
             </a:extLst>
           </p:cNvPr>
@@ -2694,7 +2674,7 @@
           <p:cNvPr id="2" name="Left column">
             <a:extLst xmlns:a="http://schemas.openxmlformats.org/drawingml/2006/main">
               <a:ext uri="{FF2B5EF4-FFF2-40B4-BE49-F238E27FC236}">
-                <a16:creationId xmlns:a16="http://schemas.microsoft.com/office/drawing/2014/main" id="{CD051250-61E8-4D61-B43B-602115D3E7AA}"/>
+                <a16:creationId xmlns:a16="http://schemas.microsoft.com/office/drawing/2014/main" id="{93DE264E-F543-4413-8F38-764C372009CD}"/>
               </a:ext>
             </a:extLst>
           </p:cNvPr>
@@ -2851,7 +2831,7 @@
           <p:cNvPr id="3" name="Right column">
             <a:extLst xmlns:a="http://schemas.openxmlformats.org/drawingml/2006/main">
               <a:ext uri="{FF2B5EF4-FFF2-40B4-BE49-F238E27FC236}">
-                <a16:creationId xmlns:a16="http://schemas.microsoft.com/office/drawing/2014/main" id="{76E205A6-D114-4034-BDA9-BA07A2C21A54}"/>
+                <a16:creationId xmlns:a16="http://schemas.microsoft.com/office/drawing/2014/main" id="{5AFF96FA-1BC0-4DDD-9EF2-59675D844D2E}"/>
               </a:ext>
             </a:extLst>
           </p:cNvPr>
@@ -3025,7 +3005,7 @@
           <p:cNvPr id="3" name="Title">
             <a:extLst xmlns:a="http://schemas.openxmlformats.org/drawingml/2006/main">
               <a:ext uri="{FF2B5EF4-FFF2-40B4-BE49-F238E27FC236}">
-                <a16:creationId xmlns:a16="http://schemas.microsoft.com/office/drawing/2014/main" id="{F929FC09-16E6-4478-BCFB-2A23A47A93BC}"/>
+                <a16:creationId xmlns:a16="http://schemas.microsoft.com/office/drawing/2014/main" id="{82A42E88-9547-47F3-B3BB-CD892C25D6FD}"/>
               </a:ext>
             </a:extLst>
           </p:cNvPr>
@@ -3182,7 +3162,7 @@
           <p:cNvPr id="2" name="Left column">
             <a:extLst xmlns:a="http://schemas.openxmlformats.org/drawingml/2006/main">
               <a:ext uri="{FF2B5EF4-FFF2-40B4-BE49-F238E27FC236}">
-                <a16:creationId xmlns:a16="http://schemas.microsoft.com/office/drawing/2014/main" id="{F9909B7B-DB32-4785-8B7D-AE7AFB7FDEE5}"/>
+                <a16:creationId xmlns:a16="http://schemas.microsoft.com/office/drawing/2014/main" id="{80AB2BF2-4A4C-43BA-9350-315EC695C1DC}"/>
               </a:ext>
             </a:extLst>
           </p:cNvPr>
@@ -3377,12 +3357,12 @@
   </p:cSld>
   <p:clrMap bg1="lt1" tx1="dk1" bg2="lt2" tx2="dk2" accent1="accent1" accent2="accent2" accent3="accent3" accent4="accent4" accent5="accent5" accent6="accent6" hlink="hlink" folHlink="folHlink"/>
   <p:sldLayoutIdLst>
-    <p:sldLayoutId xmlns:r="http://schemas.openxmlformats.org/officeDocument/2006/relationships" id="2147483649" r:id="R80e5ba157b0c479c"/>
-    <p:sldLayoutId xmlns:r="http://schemas.openxmlformats.org/officeDocument/2006/relationships" id="2147483650" r:id="Rd9023e1f24a14817"/>
-    <p:sldLayoutId xmlns:r="http://schemas.openxmlformats.org/officeDocument/2006/relationships" id="2147483651" r:id="R688823f18b48407b"/>
-    <p:sldLayoutId xmlns:r="http://schemas.openxmlformats.org/officeDocument/2006/relationships" id="2147483652" r:id="Ra90e26a4a12b4389"/>
-    <p:sldLayoutId xmlns:r="http://schemas.openxmlformats.org/officeDocument/2006/relationships" id="2147483653" r:id="Recf00def4aee430f"/>
-    <p:sldLayoutId xmlns:r="http://schemas.openxmlformats.org/officeDocument/2006/relationships" id="2147483654" r:id="R0d1a88daf36d47f5"/>
+    <p:sldLayoutId xmlns:r="http://schemas.openxmlformats.org/officeDocument/2006/relationships" id="2147483649" r:id="Rf30777f833e147f0"/>
+    <p:sldLayoutId xmlns:r="http://schemas.openxmlformats.org/officeDocument/2006/relationships" id="2147483650" r:id="R643d6e6470a44d4a"/>
+    <p:sldLayoutId xmlns:r="http://schemas.openxmlformats.org/officeDocument/2006/relationships" id="2147483651" r:id="Ra75f3a6c4c50425a"/>
+    <p:sldLayoutId xmlns:r="http://schemas.openxmlformats.org/officeDocument/2006/relationships" id="2147483652" r:id="Re68e95b8188c4f4c"/>
+    <p:sldLayoutId xmlns:r="http://schemas.openxmlformats.org/officeDocument/2006/relationships" id="2147483653" r:id="R83aa6105d5a94241"/>
+    <p:sldLayoutId xmlns:r="http://schemas.openxmlformats.org/officeDocument/2006/relationships" id="2147483654" r:id="Rc63e833c939c497b"/>
   </p:sldLayoutIdLst>
   <p:txStyles>
     <p:titleStyle>
@@ -3930,10 +3910,10 @@
       </p:grpSpPr>
       <p:sp>
         <p:nvSpPr>
-          <p:cNvPr id="9" name="cover-label">
-            <a:extLst xmlns:a="http://schemas.openxmlformats.org/drawingml/2006/main">
-              <a:ext uri="{FF2B5EF4-FFF2-40B4-BE49-F238E27FC236}">
-                <a16:creationId xmlns:a16="http://schemas.microsoft.com/office/drawing/2014/main" id="{A1353E95-5D72-44B0-AE09-909D2610E955}"/>
+          <p:cNvPr id="7" name="cover-label">
+            <a:extLst xmlns:a="http://schemas.openxmlformats.org/drawingml/2006/main">
+              <a:ext uri="{FF2B5EF4-FFF2-40B4-BE49-F238E27FC236}">
+                <a16:creationId xmlns:a16="http://schemas.microsoft.com/office/drawing/2014/main" id="{B4236BAA-5A0F-4EAA-89DD-4739B5976E84}"/>
               </a:ext>
             </a:extLst>
           </p:cNvPr>
@@ -3991,7 +3971,7 @@
                 <a:ea typeface="Noto Sans SC"/>
                 <a:cs typeface="Noto Sans SC"/>
               </a:rPr>
-              <a:t>合作讨论稿 · 2026-10-13</a:t>
+              <a:t>产品与合作规划 · 2026-10-13</a:t>
             </a:r>
           </a:p>
         </p:txBody>
@@ -4001,7 +3981,7 @@
           <p:cNvPr id="2" name="cover-title">
             <a:extLst xmlns:a="http://schemas.openxmlformats.org/drawingml/2006/main">
               <a:ext uri="{FF2B5EF4-FFF2-40B4-BE49-F238E27FC236}">
-                <a16:creationId xmlns:a16="http://schemas.microsoft.com/office/drawing/2014/main" id="{0C4CF67F-5B9F-4953-BE17-65CE2C5C4407}"/>
+                <a16:creationId xmlns:a16="http://schemas.microsoft.com/office/drawing/2014/main" id="{0D530C93-21FC-4E82-B1DC-88C1FEF9BC03}"/>
               </a:ext>
             </a:extLst>
           </p:cNvPr>
@@ -4059,7 +4039,7 @@
                 <a:ea typeface="Noto Sans SC"/>
                 <a:cs typeface="Noto Sans SC"/>
               </a:rPr>
-              <a:t>UNSEEN｜家庭影像呈现端</a:t>
+              <a:t>UNSEEN 家庭记忆智能屏</a:t>
             </a:r>
           </a:p>
         </p:txBody>
@@ -4069,7 +4049,7 @@
           <p:cNvPr id="3" name="cover-subtitle">
             <a:extLst xmlns:a="http://schemas.openxmlformats.org/drawingml/2006/main">
               <a:ext uri="{FF2B5EF4-FFF2-40B4-BE49-F238E27FC236}">
-                <a16:creationId xmlns:a16="http://schemas.microsoft.com/office/drawing/2014/main" id="{5832E9D4-E947-4D2F-A829-E88BD0832A2E}"/>
+                <a16:creationId xmlns:a16="http://schemas.microsoft.com/office/drawing/2014/main" id="{4971F602-2A3B-4DC8-87F1-D9032CA29C71}"/>
               </a:ext>
             </a:extLst>
           </p:cNvPr>
@@ -4127,7 +4107,7 @@
                 <a:ea typeface="Noto Sans SC"/>
                 <a:cs typeface="Noto Sans SC"/>
               </a:rPr>
-              <a:t>产品验证与市场进入计划</a:t>
+              <a:t>产品进展与市场验证</a:t>
             </a:r>
           </a:p>
           <a:p xmlns:a="http://schemas.openxmlformats.org/drawingml/2006/main">
@@ -4150,7 +4130,7 @@
                 <a:ea typeface="Noto Sans SC"/>
                 <a:cs typeface="Noto Sans SC"/>
               </a:rPr>
-              <a:t>与影石的共创／孵化讨论</a:t>
+              <a:t>面向投资人与合作伙伴</a:t>
             </a:r>
           </a:p>
         </p:txBody>
@@ -4160,7 +4140,7 @@
           <p:cNvPr id="4" name="cover-question">
             <a:extLst xmlns:a="http://schemas.openxmlformats.org/drawingml/2006/main">
               <a:ext uri="{FF2B5EF4-FFF2-40B4-BE49-F238E27FC236}">
-                <a16:creationId xmlns:a16="http://schemas.microsoft.com/office/drawing/2014/main" id="{8560AD96-3DA4-4380-94A5-35DD457ED64C}"/>
+                <a16:creationId xmlns:a16="http://schemas.microsoft.com/office/drawing/2014/main" id="{7D8850D7-CF77-44C4-AB30-DE07E5E29A78}"/>
               </a:ext>
             </a:extLst>
           </p:cNvPr>
@@ -4218,7 +4198,7 @@
                 <a:ea typeface="Noto Sans SC"/>
                 <a:cs typeface="Noto Sans SC"/>
               </a:rPr>
-              <a:t>采集与影像处理</a:t>
+              <a:t>支持投入</a:t>
             </a:r>
           </a:p>
           <a:p xmlns:a="http://schemas.openxmlformats.org/drawingml/2006/main">
@@ -4241,7 +4221,7 @@
                 <a:ea typeface="Noto Sans SC"/>
                 <a:cs typeface="Noto Sans SC"/>
               </a:rPr>
-              <a:t>家庭呈现与回应</a:t>
+              <a:t>阶段成果</a:t>
             </a:r>
           </a:p>
         </p:txBody>
@@ -4251,7 +4231,7 @@
           <p:cNvPr id="5" name="cover-note">
             <a:extLst xmlns:a="http://schemas.openxmlformats.org/drawingml/2006/main">
               <a:ext uri="{FF2B5EF4-FFF2-40B4-BE49-F238E27FC236}">
-                <a16:creationId xmlns:a16="http://schemas.microsoft.com/office/drawing/2014/main" id="{FF2BDABD-E745-4881-9ED1-CC6451283644}"/>
+                <a16:creationId xmlns:a16="http://schemas.microsoft.com/office/drawing/2014/main" id="{0F1BD8DF-753F-4C8D-9A7A-F7F683B707F2}"/>
               </a:ext>
             </a:extLst>
           </p:cNvPr>
@@ -4309,7 +4289,7 @@
                 <a:ea typeface="Noto Sans SC"/>
                 <a:cs typeface="Noto Sans SC"/>
               </a:rPr>
-              <a:t>2026.10.13 · 12 页讨论 + 1 页来源 · 约 30 分钟</a:t>
+              <a:t>2026.10.13 · 产品与合作规划 · 约 30 分钟</a:t>
             </a:r>
           </a:p>
         </p:txBody>
@@ -4319,7 +4299,7 @@
           <p:cNvPr id="6" name="page">
             <a:extLst xmlns:a="http://schemas.openxmlformats.org/drawingml/2006/main">
               <a:ext uri="{FF2B5EF4-FFF2-40B4-BE49-F238E27FC236}">
-                <a16:creationId xmlns:a16="http://schemas.microsoft.com/office/drawing/2014/main" id="{CE0EA9AF-6F9D-49EC-A355-095687F0B8A8}"/>
+                <a16:creationId xmlns:a16="http://schemas.microsoft.com/office/drawing/2014/main" id="{0FBF733E-9A96-4FFE-AE20-65E9FB9FB8E2}"/>
               </a:ext>
             </a:extLst>
           </p:cNvPr>
@@ -4382,147 +4362,10 @@
           </a:p>
         </p:txBody>
       </p:sp>
-      <p:sp>
-        <p:nvSpPr>
-          <p:cNvPr id="7" name="source-label">
-            <a:extLst xmlns:a="http://schemas.openxmlformats.org/drawingml/2006/main">
-              <a:ext uri="{FF2B5EF4-FFF2-40B4-BE49-F238E27FC236}">
-                <a16:creationId xmlns:a16="http://schemas.microsoft.com/office/drawing/2014/main" id="{E44F4E97-0519-4A1D-9370-58B9116196B6}"/>
-              </a:ext>
-            </a:extLst>
-          </p:cNvPr>
-          <p:cNvSpPr>
-            <a:spLocks xmlns:a="http://schemas.openxmlformats.org/drawingml/2006/main" noGrp="1"/>
-          </p:cNvSpPr>
-          <p:nvPr/>
-        </p:nvSpPr>
-        <p:spPr>
-          <a:xfrm xmlns:a="http://schemas.openxmlformats.org/drawingml/2006/main">
-            <a:off x="571500" y="6457950"/>
-            <a:ext cx="381000" cy="190500"/>
-          </a:xfrm>
-          <a:prstGeom xmlns:a="http://schemas.openxmlformats.org/drawingml/2006/main" prst="rect">
-            <a:avLst/>
-          </a:prstGeom>
-          <a:noFill xmlns:a="http://schemas.openxmlformats.org/drawingml/2006/main"/>
-          <a:ln xmlns:a="http://schemas.openxmlformats.org/drawingml/2006/main" w="0">
-            <a:noFill/>
-          </a:ln>
-        </p:spPr>
-        <p:txBody>
-          <a:bodyPr xmlns:a="http://schemas.openxmlformats.org/drawingml/2006/main" wrap="square" lIns="0" tIns="0" rIns="0" bIns="0" anchor="t">
-            <a:noAutofit/>
-          </a:bodyPr>
-          <a:lstStyle xmlns:a="http://schemas.openxmlformats.org/drawingml/2006/main">
-            <a:defPPr>
-              <a:defRPr sz="1050" b="0">
-                <a:solidFill>
-                  <a:srgbClr val="97B8CA"/>
-                </a:solidFill>
-                <a:latin typeface="Noto Sans SC"/>
-                <a:ea typeface="Noto Sans SC"/>
-                <a:cs typeface="Noto Sans SC"/>
-              </a:defRPr>
-            </a:defPPr>
-          </a:lstStyle>
-          <a:p xmlns:a="http://schemas.openxmlformats.org/drawingml/2006/main">
-            <a:pPr>
-              <a:defRPr sz="1050" b="0">
-                <a:solidFill>
-                  <a:srgbClr val="97B8CA"/>
-                </a:solidFill>
-                <a:latin typeface="Noto Sans SC"/>
-                <a:ea typeface="Noto Sans SC"/>
-                <a:cs typeface="Noto Sans SC"/>
-              </a:defRPr>
-            </a:pPr>
-            <a:r>
-              <a:rPr sz="1050" b="0">
-                <a:solidFill>
-                  <a:srgbClr val="97B8CA"/>
-                </a:solidFill>
-                <a:latin typeface="Noto Sans SC"/>
-                <a:ea typeface="Noto Sans SC"/>
-                <a:cs typeface="Noto Sans SC"/>
-              </a:rPr>
-              <a:t>来源</a:t>
-            </a:r>
-          </a:p>
-        </p:txBody>
-      </p:sp>
-      <p:sp>
-        <p:nvSpPr>
-          <p:cNvPr id="8" name="source-A2">
-            <a:extLst xmlns:a="http://schemas.openxmlformats.org/drawingml/2006/main">
-              <a:ext uri="{FF2B5EF4-FFF2-40B4-BE49-F238E27FC236}">
-                <a16:creationId xmlns:a16="http://schemas.microsoft.com/office/drawing/2014/main" id="{C89F7059-54C4-452B-948C-48D7CC091E08}"/>
-              </a:ext>
-            </a:extLst>
-          </p:cNvPr>
-          <p:cNvSpPr>
-            <a:spLocks xmlns:a="http://schemas.openxmlformats.org/drawingml/2006/main" noGrp="1"/>
-          </p:cNvSpPr>
-          <p:nvPr/>
-        </p:nvSpPr>
-        <p:spPr>
-          <a:xfrm xmlns:a="http://schemas.openxmlformats.org/drawingml/2006/main">
-            <a:off x="971550" y="6457950"/>
-            <a:ext cx="647700" cy="190500"/>
-          </a:xfrm>
-          <a:prstGeom xmlns:a="http://schemas.openxmlformats.org/drawingml/2006/main" prst="rect">
-            <a:avLst/>
-          </a:prstGeom>
-          <a:noFill xmlns:a="http://schemas.openxmlformats.org/drawingml/2006/main"/>
-          <a:ln xmlns:a="http://schemas.openxmlformats.org/drawingml/2006/main" w="0">
-            <a:noFill/>
-          </a:ln>
-        </p:spPr>
-        <p:txBody>
-          <a:bodyPr xmlns:a="http://schemas.openxmlformats.org/drawingml/2006/main" wrap="square" lIns="0" tIns="0" rIns="0" bIns="0" anchor="t">
-            <a:noAutofit/>
-          </a:bodyPr>
-          <a:lstStyle xmlns:a="http://schemas.openxmlformats.org/drawingml/2006/main">
-            <a:defPPr>
-              <a:defRPr sz="1050" b="0">
-                <a:solidFill>
-                  <a:srgbClr val="197780"/>
-                </a:solidFill>
-                <a:latin typeface="Noto Sans SC"/>
-                <a:ea typeface="Noto Sans SC"/>
-                <a:cs typeface="Noto Sans SC"/>
-              </a:defRPr>
-            </a:defPPr>
-          </a:lstStyle>
-          <a:p xmlns:a="http://schemas.openxmlformats.org/drawingml/2006/main">
-            <a:pPr>
-              <a:defRPr sz="1050" b="0">
-                <a:solidFill>
-                  <a:srgbClr val="197780"/>
-                </a:solidFill>
-                <a:latin typeface="Noto Sans SC"/>
-                <a:ea typeface="Noto Sans SC"/>
-                <a:cs typeface="Noto Sans SC"/>
-              </a:defRPr>
-            </a:pPr>
-            <a:r>
-              <a:rPr sz="1050" b="0">
-                <a:solidFill>
-                  <a:srgbClr val="197780"/>
-                </a:solidFill>
-                <a:latin typeface="Noto Sans SC"/>
-                <a:ea typeface="Noto Sans SC"/>
-                <a:cs typeface="Noto Sans SC"/>
-                <a:hlinkClick xmlns:r="http://schemas.openxmlformats.org/officeDocument/2006/relationships" r:id="Rf6a22b43c4dc442c"/>
-              </a:rPr>
-              <a:t>A2 ↗</a:t>
-            </a:r>
-          </a:p>
-        </p:txBody>
-      </p:sp>
     </p:spTree>
     <p:extLst>
       <p:ext uri="{BB962C8B-B14F-4D97-AF65-F5344CB8AC3E}">
-        <p14:creationId xmlns:p14="http://schemas.microsoft.com/office/powerpoint/2010/main" val="183580818"/>
+        <p14:creationId xmlns:p14="http://schemas.microsoft.com/office/powerpoint/2010/main" val="68204457"/>
       </p:ext>
     </p:extLst>
   </p:cSld>
@@ -4553,7 +4396,7 @@
           <p:cNvPr id="16" name="section">
             <a:extLst xmlns:a="http://schemas.openxmlformats.org/drawingml/2006/main">
               <a:ext uri="{FF2B5EF4-FFF2-40B4-BE49-F238E27FC236}">
-                <a16:creationId xmlns:a16="http://schemas.microsoft.com/office/drawing/2014/main" id="{C540CE66-B64E-442B-BC10-528F7EE82DBE}"/>
+                <a16:creationId xmlns:a16="http://schemas.microsoft.com/office/drawing/2014/main" id="{50FED1C3-73ED-42AB-8CED-FCE39575E82E}"/>
               </a:ext>
             </a:extLst>
           </p:cNvPr>
@@ -4621,7 +4464,7 @@
           <p:cNvPr id="2" name="title">
             <a:extLst xmlns:a="http://schemas.openxmlformats.org/drawingml/2006/main">
               <a:ext uri="{FF2B5EF4-FFF2-40B4-BE49-F238E27FC236}">
-                <a16:creationId xmlns:a16="http://schemas.microsoft.com/office/drawing/2014/main" id="{18555383-A775-4B86-B1AA-BC502301A31F}"/>
+                <a16:creationId xmlns:a16="http://schemas.microsoft.com/office/drawing/2014/main" id="{1D2A3942-5A0E-4466-BA8D-B87876B30338}"/>
               </a:ext>
             </a:extLst>
           </p:cNvPr>
@@ -4679,7 +4522,7 @@
                 <a:ea typeface="Noto Sans SC"/>
                 <a:cs typeface="Noto Sans SC"/>
               </a:rPr>
-              <a:t>资金安排：先验证，再扩大投入</a:t>
+              <a:t>阶段资金安排</a:t>
             </a:r>
           </a:p>
         </p:txBody>
@@ -4689,7 +4532,7 @@
           <p:cNvPr id="3" name="lead">
             <a:extLst xmlns:a="http://schemas.openxmlformats.org/drawingml/2006/main">
               <a:ext uri="{FF2B5EF4-FFF2-40B4-BE49-F238E27FC236}">
-                <a16:creationId xmlns:a16="http://schemas.microsoft.com/office/drawing/2014/main" id="{F3B1E357-9FCF-44C1-BEFE-F4D7EFC7A8B6}"/>
+                <a16:creationId xmlns:a16="http://schemas.microsoft.com/office/drawing/2014/main" id="{513E9B84-45B8-4418-83B4-5EC9EA2C1797}"/>
               </a:ext>
             </a:extLst>
           </p:cNvPr>
@@ -4747,7 +4590,7 @@
                 <a:ea typeface="Noto Sans SC"/>
                 <a:cs typeface="Noto Sans SC"/>
               </a:rPr>
-              <a:t>首批生产资金缺口，需要按付款时间测算，不能只看预售总额。</a:t>
+              <a:t>资金与里程碑相匹配，按实际付款节点测算需求。</a:t>
             </a:r>
           </a:p>
         </p:txBody>
@@ -4757,7 +4600,7 @@
           <p:cNvPr id="4" name="row-label-0">
             <a:extLst xmlns:a="http://schemas.openxmlformats.org/drawingml/2006/main">
               <a:ext uri="{FF2B5EF4-FFF2-40B4-BE49-F238E27FC236}">
-                <a16:creationId xmlns:a16="http://schemas.microsoft.com/office/drawing/2014/main" id="{68F742CD-AF3D-4929-B416-8092FBADFACB}"/>
+                <a16:creationId xmlns:a16="http://schemas.microsoft.com/office/drawing/2014/main" id="{DC4E6A99-81A6-4937-8DAA-5A1EDCCB1CBB}"/>
               </a:ext>
             </a:extLst>
           </p:cNvPr>
@@ -4815,7 +4658,7 @@
                 <a:ea typeface="Noto Sans SC"/>
                 <a:cs typeface="Noto Sans SC"/>
               </a:rPr>
-              <a:t>样机阶段</a:t>
+              <a:t>样机验证</a:t>
             </a:r>
           </a:p>
         </p:txBody>
@@ -4825,7 +4668,7 @@
           <p:cNvPr id="5" name="row-body-0">
             <a:extLst xmlns:a="http://schemas.openxmlformats.org/drawingml/2006/main">
               <a:ext uri="{FF2B5EF4-FFF2-40B4-BE49-F238E27FC236}">
-                <a16:creationId xmlns:a16="http://schemas.microsoft.com/office/drawing/2014/main" id="{6B72C919-7A64-4424-8225-5727EFEF86A8}"/>
+                <a16:creationId xmlns:a16="http://schemas.microsoft.com/office/drawing/2014/main" id="{75889E19-E3B3-465E-879D-BD9CC8ECCFBC}"/>
               </a:ext>
             </a:extLst>
           </p:cNvPr>
@@ -4883,7 +4726,7 @@
                 <a:ea typeface="Noto Sans SC"/>
                 <a:cs typeface="Noto Sans SC"/>
               </a:rPr>
-              <a:t>已有预算优先；争取影石共创经费或孵化支持，先覆盖小批样机。</a:t>
+              <a:t>结合已有预算、共创经费或孵化支持，覆盖小批样机。</a:t>
             </a:r>
           </a:p>
         </p:txBody>
@@ -4893,7 +4736,7 @@
           <p:cNvPr id="6" name="row-label-1">
             <a:extLst xmlns:a="http://schemas.openxmlformats.org/drawingml/2006/main">
               <a:ext uri="{FF2B5EF4-FFF2-40B4-BE49-F238E27FC236}">
-                <a16:creationId xmlns:a16="http://schemas.microsoft.com/office/drawing/2014/main" id="{B542A711-6843-40E9-A707-F505DDD7910B}"/>
+                <a16:creationId xmlns:a16="http://schemas.microsoft.com/office/drawing/2014/main" id="{8FBEE514-C01B-46FC-B1F3-2FCA05F67BB7}"/>
               </a:ext>
             </a:extLst>
           </p:cNvPr>
@@ -4951,7 +4794,7 @@
                 <a:ea typeface="Noto Sans SC"/>
                 <a:cs typeface="Noto Sans SC"/>
               </a:rPr>
-              <a:t>试点阶段</a:t>
+              <a:t>家庭试点</a:t>
             </a:r>
           </a:p>
         </p:txBody>
@@ -4961,7 +4804,7 @@
           <p:cNvPr id="7" name="row-body-1">
             <a:extLst xmlns:a="http://schemas.openxmlformats.org/drawingml/2006/main">
               <a:ext uri="{FF2B5EF4-FFF2-40B4-BE49-F238E27FC236}">
-                <a16:creationId xmlns:a16="http://schemas.microsoft.com/office/drawing/2014/main" id="{CB049C36-3EF7-4039-9B25-8AC574B15D0D}"/>
+                <a16:creationId xmlns:a16="http://schemas.microsoft.com/office/drawing/2014/main" id="{CE79ECCA-BB5C-46F5-BD8A-F8A388FCFC75}"/>
               </a:ext>
             </a:extLst>
           </p:cNvPr>
@@ -5019,7 +4862,7 @@
                 <a:ea typeface="Noto Sans SC"/>
                 <a:cs typeface="Noto Sans SC"/>
               </a:rPr>
-              <a:t>公益采购／试点经费可支付约定设备与服务；C 端资金单独记账。</a:t>
+              <a:t>采购或试点经费覆盖约定设备与服务，形成使用和成本记录。</a:t>
             </a:r>
           </a:p>
         </p:txBody>
@@ -5029,7 +4872,7 @@
           <p:cNvPr id="8" name="row-label-2">
             <a:extLst xmlns:a="http://schemas.openxmlformats.org/drawingml/2006/main">
               <a:ext uri="{FF2B5EF4-FFF2-40B4-BE49-F238E27FC236}">
-                <a16:creationId xmlns:a16="http://schemas.microsoft.com/office/drawing/2014/main" id="{F0C91F17-FB2E-4168-BD6A-E9FC3ABC9F20}"/>
+                <a16:creationId xmlns:a16="http://schemas.microsoft.com/office/drawing/2014/main" id="{933A0C19-AB37-4E5C-AE2F-6C35AA678057}"/>
               </a:ext>
             </a:extLst>
           </p:cNvPr>
@@ -5087,7 +4930,7 @@
                 <a:ea typeface="Noto Sans SC"/>
                 <a:cs typeface="Noto Sans SC"/>
               </a:rPr>
-              <a:t>预售阶段</a:t>
+              <a:t>预售交付</a:t>
             </a:r>
           </a:p>
         </p:txBody>
@@ -5097,7 +4940,7 @@
           <p:cNvPr id="9" name="row-body-2">
             <a:extLst xmlns:a="http://schemas.openxmlformats.org/drawingml/2006/main">
               <a:ext uri="{FF2B5EF4-FFF2-40B4-BE49-F238E27FC236}">
-                <a16:creationId xmlns:a16="http://schemas.microsoft.com/office/drawing/2014/main" id="{04B6A270-FD29-435F-A830-24D2B3A958DA}"/>
+                <a16:creationId xmlns:a16="http://schemas.microsoft.com/office/drawing/2014/main" id="{FD3519B3-82C5-41E9-B797-B883F2AF2F6A}"/>
               </a:ext>
             </a:extLst>
           </p:cNvPr>
@@ -5155,7 +4998,7 @@
                 <a:ea typeface="Noto Sans SC"/>
                 <a:cs typeface="Noto Sans SC"/>
               </a:rPr>
-              <a:t>只计可实际支取的预售净款；先扣平台费用与退款准备，交付成本另算。</a:t>
+              <a:t>计入可支取的预售净款，单列平台费用、退款准备和交付成本。</a:t>
             </a:r>
           </a:p>
         </p:txBody>
@@ -5165,7 +5008,7 @@
           <p:cNvPr id="10" name="row-label-3">
             <a:extLst xmlns:a="http://schemas.openxmlformats.org/drawingml/2006/main">
               <a:ext uri="{FF2B5EF4-FFF2-40B4-BE49-F238E27FC236}">
-                <a16:creationId xmlns:a16="http://schemas.microsoft.com/office/drawing/2014/main" id="{0BC1E38B-D0C3-40E7-9F16-D229166E1796}"/>
+                <a16:creationId xmlns:a16="http://schemas.microsoft.com/office/drawing/2014/main" id="{039FD340-218C-458A-B7AA-951C46830BD2}"/>
               </a:ext>
             </a:extLst>
           </p:cNvPr>
@@ -5223,7 +5066,7 @@
                 <a:ea typeface="Noto Sans SC"/>
                 <a:cs typeface="Noto Sans SC"/>
               </a:rPr>
-              <a:t>融资阶段</a:t>
+              <a:t>后续融资</a:t>
             </a:r>
           </a:p>
         </p:txBody>
@@ -5233,7 +5076,7 @@
           <p:cNvPr id="11" name="row-body-3">
             <a:extLst xmlns:a="http://schemas.openxmlformats.org/drawingml/2006/main">
               <a:ext uri="{FF2B5EF4-FFF2-40B4-BE49-F238E27FC236}">
-                <a16:creationId xmlns:a16="http://schemas.microsoft.com/office/drawing/2014/main" id="{28EF3053-BECA-466E-9673-C536432DC721}"/>
+                <a16:creationId xmlns:a16="http://schemas.microsoft.com/office/drawing/2014/main" id="{9C55FD73-7A01-4941-92E0-731C364EF811}"/>
               </a:ext>
             </a:extLst>
           </p:cNvPr>
@@ -5291,7 +5134,7 @@
                 <a:ea typeface="Noto Sans SC"/>
                 <a:cs typeface="Noto Sans SC"/>
               </a:rPr>
-              <a:t>产品、试用和初步订单信号形成后，再评估股权融资或其他资金方案。</a:t>
+              <a:t>结合产品、试用与初步订单信号，评估融资规模及资金用途。</a:t>
             </a:r>
           </a:p>
         </p:txBody>
@@ -5301,7 +5144,7 @@
           <p:cNvPr id="12" name="takeaway">
             <a:extLst xmlns:a="http://schemas.openxmlformats.org/drawingml/2006/main">
               <a:ext uri="{FF2B5EF4-FFF2-40B4-BE49-F238E27FC236}">
-                <a16:creationId xmlns:a16="http://schemas.microsoft.com/office/drawing/2014/main" id="{12EDCF00-96F8-4DCD-86EF-0E0ADABB4484}"/>
+                <a16:creationId xmlns:a16="http://schemas.microsoft.com/office/drawing/2014/main" id="{F0236CFA-B2A5-4C44-A434-2204E64181EB}"/>
               </a:ext>
             </a:extLst>
           </p:cNvPr>
@@ -5359,7 +5202,7 @@
                 <a:ea typeface="Noto Sans SC"/>
                 <a:cs typeface="Noto Sans SC"/>
               </a:rPr>
-              <a:t>开模／研发费 ＋ 首批制造与交付支出 − 可支取预售净款 − 已落实支持 ＝ 待补资金。</a:t>
+              <a:t>阶段支出减去已落实支持及可支取订单资金，得到需要补足的资金。</a:t>
             </a:r>
           </a:p>
         </p:txBody>
@@ -5369,7 +5212,7 @@
           <p:cNvPr id="13" name="page">
             <a:extLst xmlns:a="http://schemas.openxmlformats.org/drawingml/2006/main">
               <a:ext uri="{FF2B5EF4-FFF2-40B4-BE49-F238E27FC236}">
-                <a16:creationId xmlns:a16="http://schemas.microsoft.com/office/drawing/2014/main" id="{6E64DCA6-8F71-4D71-AE6E-8A576AC65AE4}"/>
+                <a16:creationId xmlns:a16="http://schemas.microsoft.com/office/drawing/2014/main" id="{DEC832B2-3953-4764-9A58-0E707A47632C}"/>
               </a:ext>
             </a:extLst>
           </p:cNvPr>
@@ -5437,7 +5280,7 @@
           <p:cNvPr id="14" name="source-label">
             <a:extLst xmlns:a="http://schemas.openxmlformats.org/drawingml/2006/main">
               <a:ext uri="{FF2B5EF4-FFF2-40B4-BE49-F238E27FC236}">
-                <a16:creationId xmlns:a16="http://schemas.microsoft.com/office/drawing/2014/main" id="{2963FDD9-9D1F-4CEB-BFA9-6F44E26B5C23}"/>
+                <a16:creationId xmlns:a16="http://schemas.microsoft.com/office/drawing/2014/main" id="{F27F78BC-9846-4487-AC7E-B07D95C5C0CB}"/>
               </a:ext>
             </a:extLst>
           </p:cNvPr>
@@ -5505,7 +5348,7 @@
           <p:cNvPr id="15" name="source-U3">
             <a:extLst xmlns:a="http://schemas.openxmlformats.org/drawingml/2006/main">
               <a:ext uri="{FF2B5EF4-FFF2-40B4-BE49-F238E27FC236}">
-                <a16:creationId xmlns:a16="http://schemas.microsoft.com/office/drawing/2014/main" id="{2F93C7A1-10BB-4A4A-9D1D-996FF53B25A9}"/>
+                <a16:creationId xmlns:a16="http://schemas.microsoft.com/office/drawing/2014/main" id="{887BFDD8-D80B-43A8-A3D2-EF523EE1C330}"/>
               </a:ext>
             </a:extLst>
           </p:cNvPr>
@@ -5571,7 +5414,7 @@
     </p:spTree>
     <p:extLst>
       <p:ext uri="{BB962C8B-B14F-4D97-AF65-F5344CB8AC3E}">
-        <p14:creationId xmlns:p14="http://schemas.microsoft.com/office/powerpoint/2010/main" val="1485332906"/>
+        <p14:creationId xmlns:p14="http://schemas.microsoft.com/office/powerpoint/2010/main" val="2040149612"/>
       </p:ext>
     </p:extLst>
   </p:cSld>
@@ -5602,7 +5445,7 @@
           <p:cNvPr id="16" name="section">
             <a:extLst xmlns:a="http://schemas.openxmlformats.org/drawingml/2006/main">
               <a:ext uri="{FF2B5EF4-FFF2-40B4-BE49-F238E27FC236}">
-                <a16:creationId xmlns:a16="http://schemas.microsoft.com/office/drawing/2014/main" id="{A26ED177-C674-4F3D-9D30-868563B5E29C}"/>
+                <a16:creationId xmlns:a16="http://schemas.microsoft.com/office/drawing/2014/main" id="{1344C846-E808-4D22-8BF1-75E6FD46558C}"/>
               </a:ext>
             </a:extLst>
           </p:cNvPr>
@@ -5660,7 +5503,7 @@
                 <a:ea typeface="Noto Sans SC"/>
                 <a:cs typeface="Noto Sans SC"/>
               </a:rPr>
-              <a:t>本次诉求 · 2 分钟</a:t>
+              <a:t>合作价值 · 2 分钟</a:t>
             </a:r>
           </a:p>
         </p:txBody>
@@ -5670,7 +5513,7 @@
           <p:cNvPr id="2" name="title">
             <a:extLst xmlns:a="http://schemas.openxmlformats.org/drawingml/2006/main">
               <a:ext uri="{FF2B5EF4-FFF2-40B4-BE49-F238E27FC236}">
-                <a16:creationId xmlns:a16="http://schemas.microsoft.com/office/drawing/2014/main" id="{04EA1109-8CFD-4F3C-BBC5-F820F74443EE}"/>
+                <a16:creationId xmlns:a16="http://schemas.microsoft.com/office/drawing/2014/main" id="{9572E933-D42C-4DC2-9DB3-9B3D86609ED2}"/>
               </a:ext>
             </a:extLst>
           </p:cNvPr>
@@ -5728,7 +5571,7 @@
                 <a:ea typeface="Noto Sans SC"/>
                 <a:cs typeface="Noto Sans SC"/>
               </a:rPr>
-              <a:t>这次希望与影石确认的支持</a:t>
+              <a:t>资源支持与阶段成果</a:t>
             </a:r>
           </a:p>
         </p:txBody>
@@ -5738,7 +5581,7 @@
           <p:cNvPr id="3" name="lead">
             <a:extLst xmlns:a="http://schemas.openxmlformats.org/drawingml/2006/main">
               <a:ext uri="{FF2B5EF4-FFF2-40B4-BE49-F238E27FC236}">
-                <a16:creationId xmlns:a16="http://schemas.microsoft.com/office/drawing/2014/main" id="{7D2EB37B-1A8D-4960-864D-9CB103DBCAEA}"/>
+                <a16:creationId xmlns:a16="http://schemas.microsoft.com/office/drawing/2014/main" id="{DEB2460D-6B2B-4820-B85B-D055D97E9358}"/>
               </a:ext>
             </a:extLst>
           </p:cNvPr>
@@ -5796,7 +5639,7 @@
                 <a:ea typeface="Noto Sans SC"/>
                 <a:cs typeface="Noto Sans SC"/>
               </a:rPr>
-              <a:t>当前先争取把下一阶段产品验证做成；融资保留为后续议题。</a:t>
+              <a:t>支持投入转化为可检查的产品、市场与经营成果。</a:t>
             </a:r>
           </a:p>
         </p:txBody>
@@ -5806,7 +5649,7 @@
           <p:cNvPr id="4" name="row-label-0">
             <a:extLst xmlns:a="http://schemas.openxmlformats.org/drawingml/2006/main">
               <a:ext uri="{FF2B5EF4-FFF2-40B4-BE49-F238E27FC236}">
-                <a16:creationId xmlns:a16="http://schemas.microsoft.com/office/drawing/2014/main" id="{81D4854C-AE2F-43C8-83DB-1F23CD770609}"/>
+                <a16:creationId xmlns:a16="http://schemas.microsoft.com/office/drawing/2014/main" id="{DC6F0132-A44D-403E-AF3B-505E0F170EC3}"/>
               </a:ext>
             </a:extLst>
           </p:cNvPr>
@@ -5864,7 +5707,7 @@
                 <a:ea typeface="Noto Sans SC"/>
                 <a:cs typeface="Noto Sans SC"/>
               </a:rPr>
-              <a:t>优先：产品共创</a:t>
+              <a:t>获得工程支持</a:t>
             </a:r>
           </a:p>
         </p:txBody>
@@ -5874,7 +5717,7 @@
           <p:cNvPr id="5" name="row-body-0">
             <a:extLst xmlns:a="http://schemas.openxmlformats.org/drawingml/2006/main">
               <a:ext uri="{FF2B5EF4-FFF2-40B4-BE49-F238E27FC236}">
-                <a16:creationId xmlns:a16="http://schemas.microsoft.com/office/drawing/2014/main" id="{3841A5C9-CCFC-4186-8DA9-736D5647DA9B}"/>
+                <a16:creationId xmlns:a16="http://schemas.microsoft.com/office/drawing/2014/main" id="{FF155EDB-9238-4349-AC32-B2B6C3C666F4}"/>
               </a:ext>
             </a:extLst>
           </p:cNvPr>
@@ -5932,7 +5775,7 @@
                 <a:ea typeface="Noto Sans SC"/>
                 <a:cs typeface="Noto Sans SC"/>
               </a:rPr>
-              <a:t>指定一位产品／硬件接口人，评审现有 Demo 和大屏样机方案。</a:t>
+              <a:t>可推进大屏样机，形成器件方案、成本依据与稳定性记录。</a:t>
             </a:r>
           </a:p>
         </p:txBody>
@@ -5942,7 +5785,7 @@
           <p:cNvPr id="6" name="row-label-1">
             <a:extLst xmlns:a="http://schemas.openxmlformats.org/drawingml/2006/main">
               <a:ext uri="{FF2B5EF4-FFF2-40B4-BE49-F238E27FC236}">
-                <a16:creationId xmlns:a16="http://schemas.microsoft.com/office/drawing/2014/main" id="{6583E50A-4A93-4856-9AA4-F22C29A5D9C3}"/>
+                <a16:creationId xmlns:a16="http://schemas.microsoft.com/office/drawing/2014/main" id="{6FC4F127-1AC2-4F01-8246-5896AA1FDF8A}"/>
               </a:ext>
             </a:extLst>
           </p:cNvPr>
@@ -6000,7 +5843,7 @@
                 <a:ea typeface="Noto Sans SC"/>
                 <a:cs typeface="Noto Sans SC"/>
               </a:rPr>
-              <a:t>具体：样机支持</a:t>
+              <a:t>获得试点资源</a:t>
             </a:r>
           </a:p>
         </p:txBody>
@@ -6010,7 +5853,7 @@
           <p:cNvPr id="7" name="row-body-1">
             <a:extLst xmlns:a="http://schemas.openxmlformats.org/drawingml/2006/main">
               <a:ext uri="{FF2B5EF4-FFF2-40B4-BE49-F238E27FC236}">
-                <a16:creationId xmlns:a16="http://schemas.microsoft.com/office/drawing/2014/main" id="{8D61ECE0-D807-414F-BD45-2A88D4AA29A0}"/>
+                <a16:creationId xmlns:a16="http://schemas.microsoft.com/office/drawing/2014/main" id="{BC544398-0A88-4E05-8CE8-82B9C300F349}"/>
               </a:ext>
             </a:extLst>
           </p:cNvPr>
@@ -6068,7 +5911,7 @@
                 <a:ea typeface="Noto Sans SC"/>
                 <a:cs typeface="Noto Sans SC"/>
               </a:rPr>
-              <a:t>讨论 5–10 台样机的硬件、工程与预算支持；以双方确认范围为准。</a:t>
+              <a:t>可组织真实家庭使用，形成体验反馈与服务案例。</a:t>
             </a:r>
           </a:p>
         </p:txBody>
@@ -6078,7 +5921,7 @@
           <p:cNvPr id="8" name="row-label-2">
             <a:extLst xmlns:a="http://schemas.openxmlformats.org/drawingml/2006/main">
               <a:ext uri="{FF2B5EF4-FFF2-40B4-BE49-F238E27FC236}">
-                <a16:creationId xmlns:a16="http://schemas.microsoft.com/office/drawing/2014/main" id="{B977D261-F7AB-465C-AE16-EE0443E115A0}"/>
+                <a16:creationId xmlns:a16="http://schemas.microsoft.com/office/drawing/2014/main" id="{96C00461-F4FA-42C0-BAE6-E4309CD8057C}"/>
               </a:ext>
             </a:extLst>
           </p:cNvPr>
@@ -6136,7 +5979,7 @@
                 <a:ea typeface="Noto Sans SC"/>
                 <a:cs typeface="Noto Sans SC"/>
               </a:rPr>
-              <a:t>同步：市场路径</a:t>
+              <a:t>获得渠道支持</a:t>
             </a:r>
           </a:p>
         </p:txBody>
@@ -6146,7 +5989,7 @@
           <p:cNvPr id="9" name="row-body-2">
             <a:extLst xmlns:a="http://schemas.openxmlformats.org/drawingml/2006/main">
               <a:ext uri="{FF2B5EF4-FFF2-40B4-BE49-F238E27FC236}">
-                <a16:creationId xmlns:a16="http://schemas.microsoft.com/office/drawing/2014/main" id="{3BEBAB51-9E37-4F9C-9813-8F85141D31F0}"/>
+                <a16:creationId xmlns:a16="http://schemas.microsoft.com/office/drawing/2014/main" id="{5727297D-E7A2-443C-91E7-DA9B2E4AA99B}"/>
               </a:ext>
             </a:extLst>
           </p:cNvPr>
@@ -6204,7 +6047,7 @@
                 <a:ea typeface="Noto Sans SC"/>
                 <a:cs typeface="Noto Sans SC"/>
               </a:rPr>
-              <a:t>讨论独家授权店是否可行，或是否有适合的试点与孵化资源。</a:t>
+              <a:t>可测试预售与销售，形成购买意愿、订单和交付数据。</a:t>
             </a:r>
           </a:p>
         </p:txBody>
@@ -6214,7 +6057,7 @@
           <p:cNvPr id="10" name="row-label-3">
             <a:extLst xmlns:a="http://schemas.openxmlformats.org/drawingml/2006/main">
               <a:ext uri="{FF2B5EF4-FFF2-40B4-BE49-F238E27FC236}">
-                <a16:creationId xmlns:a16="http://schemas.microsoft.com/office/drawing/2014/main" id="{9E546625-06C4-4BF5-B1CA-E8DAADED20F3}"/>
+                <a16:creationId xmlns:a16="http://schemas.microsoft.com/office/drawing/2014/main" id="{8BDD6D04-2316-42FD-8775-D5612B982952}"/>
               </a:ext>
             </a:extLst>
           </p:cNvPr>
@@ -6272,7 +6115,7 @@
                 <a:ea typeface="Noto Sans SC"/>
                 <a:cs typeface="Noto Sans SC"/>
               </a:rPr>
-              <a:t>后续：投资评估</a:t>
+              <a:t>获得阶段资金</a:t>
             </a:r>
           </a:p>
         </p:txBody>
@@ -6282,7 +6125,7 @@
           <p:cNvPr id="11" name="row-body-3">
             <a:extLst xmlns:a="http://schemas.openxmlformats.org/drawingml/2006/main">
               <a:ext uri="{FF2B5EF4-FFF2-40B4-BE49-F238E27FC236}">
-                <a16:creationId xmlns:a16="http://schemas.microsoft.com/office/drawing/2014/main" id="{25B743ED-554A-4DD1-A248-2E2AABDB525E}"/>
+                <a16:creationId xmlns:a16="http://schemas.microsoft.com/office/drawing/2014/main" id="{58500694-4A36-4BDB-B025-FF51DDCC694B}"/>
               </a:ext>
             </a:extLst>
           </p:cNvPr>
@@ -6340,7 +6183,7 @@
                 <a:ea typeface="Noto Sans SC"/>
                 <a:cs typeface="Noto Sans SC"/>
               </a:rPr>
-              <a:t>明确达到何种试用、成本和订单证据后，再进入融资讨论。</a:t>
+              <a:t>可落实研发与试产计划，为下一轮投入提供评估依据。</a:t>
             </a:r>
           </a:p>
         </p:txBody>
@@ -6350,7 +6193,7 @@
           <p:cNvPr id="12" name="takeaway">
             <a:extLst xmlns:a="http://schemas.openxmlformats.org/drawingml/2006/main">
               <a:ext uri="{FF2B5EF4-FFF2-40B4-BE49-F238E27FC236}">
-                <a16:creationId xmlns:a16="http://schemas.microsoft.com/office/drawing/2014/main" id="{1E13EBBE-507B-4186-9C70-3397B0E9822F}"/>
+                <a16:creationId xmlns:a16="http://schemas.microsoft.com/office/drawing/2014/main" id="{5C93A888-A9D2-4D7A-A317-C41C6BB180EE}"/>
               </a:ext>
             </a:extLst>
           </p:cNvPr>
@@ -6408,7 +6251,7 @@
                 <a:ea typeface="Noto Sans SC"/>
                 <a:cs typeface="Noto Sans SC"/>
               </a:rPr>
-              <a:t>希望带回：合作负责人、下一阶段任务与投入范围，以及一次明确的复盘时间。</a:t>
+              <a:t>产业伙伴获得新使用场景的验证机会，投资人获得更清晰的阶段进展与决策依据。</a:t>
             </a:r>
           </a:p>
         </p:txBody>
@@ -6418,7 +6261,7 @@
           <p:cNvPr id="13" name="page">
             <a:extLst xmlns:a="http://schemas.openxmlformats.org/drawingml/2006/main">
               <a:ext uri="{FF2B5EF4-FFF2-40B4-BE49-F238E27FC236}">
-                <a16:creationId xmlns:a16="http://schemas.microsoft.com/office/drawing/2014/main" id="{0C0ED3EE-81E0-4AE1-BE21-EEC67682C74F}"/>
+                <a16:creationId xmlns:a16="http://schemas.microsoft.com/office/drawing/2014/main" id="{0C4D4BCF-6B16-46C4-B9C1-361ADDA04C64}"/>
               </a:ext>
             </a:extLst>
           </p:cNvPr>
@@ -6486,7 +6329,7 @@
           <p:cNvPr id="14" name="source-label">
             <a:extLst xmlns:a="http://schemas.openxmlformats.org/drawingml/2006/main">
               <a:ext uri="{FF2B5EF4-FFF2-40B4-BE49-F238E27FC236}">
-                <a16:creationId xmlns:a16="http://schemas.microsoft.com/office/drawing/2014/main" id="{EC29B275-F462-4141-A8E4-CCAF9B8BFB67}"/>
+                <a16:creationId xmlns:a16="http://schemas.microsoft.com/office/drawing/2014/main" id="{9D4E17EF-E711-44F0-8CE4-C4343E8E4C33}"/>
               </a:ext>
             </a:extLst>
           </p:cNvPr>
@@ -6554,7 +6397,7 @@
           <p:cNvPr id="15" name="source-U3">
             <a:extLst xmlns:a="http://schemas.openxmlformats.org/drawingml/2006/main">
               <a:ext uri="{FF2B5EF4-FFF2-40B4-BE49-F238E27FC236}">
-                <a16:creationId xmlns:a16="http://schemas.microsoft.com/office/drawing/2014/main" id="{AD6985CD-7EA1-49F1-BC78-792BDD26E0CF}"/>
+                <a16:creationId xmlns:a16="http://schemas.microsoft.com/office/drawing/2014/main" id="{D5505D21-CAF9-46AC-8CFC-BD6E088F19E8}"/>
               </a:ext>
             </a:extLst>
           </p:cNvPr>
@@ -6620,7 +6463,7 @@
     </p:spTree>
     <p:extLst>
       <p:ext uri="{BB962C8B-B14F-4D97-AF65-F5344CB8AC3E}">
-        <p14:creationId xmlns:p14="http://schemas.microsoft.com/office/powerpoint/2010/main" val="675046679"/>
+        <p14:creationId xmlns:p14="http://schemas.microsoft.com/office/powerpoint/2010/main" val="672550396"/>
       </p:ext>
     </p:extLst>
   </p:cSld>
@@ -6651,7 +6494,7 @@
           <p:cNvPr id="14" name="section">
             <a:extLst xmlns:a="http://schemas.openxmlformats.org/drawingml/2006/main">
               <a:ext uri="{FF2B5EF4-FFF2-40B4-BE49-F238E27FC236}">
-                <a16:creationId xmlns:a16="http://schemas.microsoft.com/office/drawing/2014/main" id="{5A009F9B-3BAD-4A1D-9898-0F567A356A3A}"/>
+                <a16:creationId xmlns:a16="http://schemas.microsoft.com/office/drawing/2014/main" id="{53FE0C33-69C4-49F1-B94B-EE7D4EE77C5D}"/>
               </a:ext>
             </a:extLst>
           </p:cNvPr>
@@ -6719,7 +6562,7 @@
           <p:cNvPr id="2" name="title">
             <a:extLst xmlns:a="http://schemas.openxmlformats.org/drawingml/2006/main">
               <a:ext uri="{FF2B5EF4-FFF2-40B4-BE49-F238E27FC236}">
-                <a16:creationId xmlns:a16="http://schemas.microsoft.com/office/drawing/2014/main" id="{E320956A-335A-4DB7-BEC3-F7030DF013B3}"/>
+                <a16:creationId xmlns:a16="http://schemas.microsoft.com/office/drawing/2014/main" id="{9395FE6F-A53D-4849-BC0B-0E72D968381B}"/>
               </a:ext>
             </a:extLst>
           </p:cNvPr>
@@ -6777,7 +6620,7 @@
                 <a:ea typeface="Noto Sans SC"/>
                 <a:cs typeface="Noto Sans SC"/>
               </a:rPr>
-              <a:t>一起决定下一阶段怎样推进</a:t>
+              <a:t>下一阶段的合作议题</a:t>
             </a:r>
           </a:p>
         </p:txBody>
@@ -6787,7 +6630,7 @@
           <p:cNvPr id="3" name="lead">
             <a:extLst xmlns:a="http://schemas.openxmlformats.org/drawingml/2006/main">
               <a:ext uri="{FF2B5EF4-FFF2-40B4-BE49-F238E27FC236}">
-                <a16:creationId xmlns:a16="http://schemas.microsoft.com/office/drawing/2014/main" id="{02C41ACC-E2A6-48A7-B9B5-6812D8F229A2}"/>
+                <a16:creationId xmlns:a16="http://schemas.microsoft.com/office/drawing/2014/main" id="{62373BC3-5A46-479B-A7A2-7217F4A200BC}"/>
               </a:ext>
             </a:extLst>
           </p:cNvPr>
@@ -6845,7 +6688,7 @@
                 <a:ea typeface="Noto Sans SC"/>
                 <a:cs typeface="Noto Sans SC"/>
               </a:rPr>
-              <a:t>以下问题用于会谈收尾；双方尚未形成承诺。</a:t>
+              <a:t>围绕当前资源与阶段目标，确定双方可以推进的工作。</a:t>
             </a:r>
           </a:p>
         </p:txBody>
@@ -6855,7 +6698,7 @@
           <p:cNvPr id="4" name="row-label-0">
             <a:extLst xmlns:a="http://schemas.openxmlformats.org/drawingml/2006/main">
               <a:ext uri="{FF2B5EF4-FFF2-40B4-BE49-F238E27FC236}">
-                <a16:creationId xmlns:a16="http://schemas.microsoft.com/office/drawing/2014/main" id="{153603FF-7746-4A4A-AEB3-388D09E7ADCA}"/>
+                <a16:creationId xmlns:a16="http://schemas.microsoft.com/office/drawing/2014/main" id="{D3619185-4913-439E-8BFC-93F91A720C10}"/>
               </a:ext>
             </a:extLst>
           </p:cNvPr>
@@ -6923,7 +6766,7 @@
           <p:cNvPr id="5" name="row-body-0">
             <a:extLst xmlns:a="http://schemas.openxmlformats.org/drawingml/2006/main">
               <a:ext uri="{FF2B5EF4-FFF2-40B4-BE49-F238E27FC236}">
-                <a16:creationId xmlns:a16="http://schemas.microsoft.com/office/drawing/2014/main" id="{9B947E4E-0D87-448C-AA04-AB66350FEF1D}"/>
+                <a16:creationId xmlns:a16="http://schemas.microsoft.com/office/drawing/2014/main" id="{F4DBB79D-C07D-40FA-818B-FF4CB78D73F4}"/>
               </a:ext>
             </a:extLst>
           </p:cNvPr>
@@ -6981,7 +6824,7 @@
                 <a:ea typeface="Noto Sans SC"/>
                 <a:cs typeface="Noto Sans SC"/>
               </a:rPr>
-              <a:t>更适合产品共创、孵化支持，还是我们独立做产品并讨论授权店？</a:t>
+              <a:t>优先采用产品共创、孵化、渠道合作或投资中的哪种方式？</a:t>
             </a:r>
           </a:p>
         </p:txBody>
@@ -6991,7 +6834,7 @@
           <p:cNvPr id="6" name="row-label-1">
             <a:extLst xmlns:a="http://schemas.openxmlformats.org/drawingml/2006/main">
               <a:ext uri="{FF2B5EF4-FFF2-40B4-BE49-F238E27FC236}">
-                <a16:creationId xmlns:a16="http://schemas.microsoft.com/office/drawing/2014/main" id="{A9808592-5C4A-44DA-9853-E08F850A1327}"/>
+                <a16:creationId xmlns:a16="http://schemas.microsoft.com/office/drawing/2014/main" id="{903A536A-C3A2-437E-A097-47D7A90B1A4A}"/>
               </a:ext>
             </a:extLst>
           </p:cNvPr>
@@ -7049,7 +6892,7 @@
                 <a:ea typeface="Noto Sans SC"/>
                 <a:cs typeface="Noto Sans SC"/>
               </a:rPr>
-              <a:t>产品范围</a:t>
+              <a:t>工作范围</a:t>
             </a:r>
           </a:p>
         </p:txBody>
@@ -7059,7 +6902,7 @@
           <p:cNvPr id="7" name="row-body-1">
             <a:extLst xmlns:a="http://schemas.openxmlformats.org/drawingml/2006/main">
               <a:ext uri="{FF2B5EF4-FFF2-40B4-BE49-F238E27FC236}">
-                <a16:creationId xmlns:a16="http://schemas.microsoft.com/office/drawing/2014/main" id="{9C5B6024-DF72-4727-877F-7B4FEB458930}"/>
+                <a16:creationId xmlns:a16="http://schemas.microsoft.com/office/drawing/2014/main" id="{073920D7-50C8-4BDC-A18D-170AE55141CF}"/>
               </a:ext>
             </a:extLst>
           </p:cNvPr>
@@ -7117,7 +6960,7 @@
                 <a:ea typeface="Noto Sans SC"/>
                 <a:cs typeface="Noto Sans SC"/>
               </a:rPr>
-              <a:t>首发是否聚焦家庭大屏？样机数量和最小完整体验怎样确定？</a:t>
+              <a:t>首批样机的数量、核心体验与试用范围如何确定？</a:t>
             </a:r>
           </a:p>
         </p:txBody>
@@ -7127,7 +6970,7 @@
           <p:cNvPr id="8" name="row-label-2">
             <a:extLst xmlns:a="http://schemas.openxmlformats.org/drawingml/2006/main">
               <a:ext uri="{FF2B5EF4-FFF2-40B4-BE49-F238E27FC236}">
-                <a16:creationId xmlns:a16="http://schemas.microsoft.com/office/drawing/2014/main" id="{D36DD720-BEBD-438F-8197-54A1D4B626C4}"/>
+                <a16:creationId xmlns:a16="http://schemas.microsoft.com/office/drawing/2014/main" id="{4EA958F0-1F0A-466D-A54B-CC1BA0CF1B74}"/>
               </a:ext>
             </a:extLst>
           </p:cNvPr>
@@ -7185,7 +7028,7 @@
                 <a:ea typeface="Noto Sans SC"/>
                 <a:cs typeface="Noto Sans SC"/>
               </a:rPr>
-              <a:t>资金责任</a:t>
+              <a:t>投入安排</a:t>
             </a:r>
           </a:p>
         </p:txBody>
@@ -7195,7 +7038,7 @@
           <p:cNvPr id="9" name="row-body-2">
             <a:extLst xmlns:a="http://schemas.openxmlformats.org/drawingml/2006/main">
               <a:ext uri="{FF2B5EF4-FFF2-40B4-BE49-F238E27FC236}">
-                <a16:creationId xmlns:a16="http://schemas.microsoft.com/office/drawing/2014/main" id="{731106E5-7652-4598-B0AC-7E7BB649A2C4}"/>
+                <a16:creationId xmlns:a16="http://schemas.microsoft.com/office/drawing/2014/main" id="{0E032CD8-BF22-429A-B0E6-46190A14D2A0}"/>
               </a:ext>
             </a:extLst>
           </p:cNvPr>
@@ -7253,7 +7096,7 @@
                 <a:ea typeface="Noto Sans SC"/>
                 <a:cs typeface="Noto Sans SC"/>
               </a:rPr>
-              <a:t>样机、开模、首批制造和售后，分别由谁承担？</a:t>
+              <a:t>工程、试点、生产与服务需要哪些资源，分别如何落实？</a:t>
             </a:r>
           </a:p>
         </p:txBody>
@@ -7263,7 +7106,7 @@
           <p:cNvPr id="10" name="row-label-3">
             <a:extLst xmlns:a="http://schemas.openxmlformats.org/drawingml/2006/main">
               <a:ext uri="{FF2B5EF4-FFF2-40B4-BE49-F238E27FC236}">
-                <a16:creationId xmlns:a16="http://schemas.microsoft.com/office/drawing/2014/main" id="{9A6EC2B9-D6FA-4F33-B639-B9555B44C983}"/>
+                <a16:creationId xmlns:a16="http://schemas.microsoft.com/office/drawing/2014/main" id="{D5DA016F-3196-4563-A291-E31F4F6C50AD}"/>
               </a:ext>
             </a:extLst>
           </p:cNvPr>
@@ -7321,7 +7164,7 @@
                 <a:ea typeface="Noto Sans SC"/>
                 <a:cs typeface="Noto Sans SC"/>
               </a:rPr>
-              <a:t>下一次评估</a:t>
+              <a:t>评估节点</a:t>
             </a:r>
           </a:p>
         </p:txBody>
@@ -7331,7 +7174,7 @@
           <p:cNvPr id="11" name="row-body-3">
             <a:extLst xmlns:a="http://schemas.openxmlformats.org/drawingml/2006/main">
               <a:ext uri="{FF2B5EF4-FFF2-40B4-BE49-F238E27FC236}">
-                <a16:creationId xmlns:a16="http://schemas.microsoft.com/office/drawing/2014/main" id="{AE6EB540-E790-4606-9078-EBD4F3A8F625}"/>
+                <a16:creationId xmlns:a16="http://schemas.microsoft.com/office/drawing/2014/main" id="{17418187-FB16-4D38-B8E5-A6A9799DEBA0}"/>
               </a:ext>
             </a:extLst>
           </p:cNvPr>
@@ -7389,7 +7232,7 @@
                 <a:ea typeface="Noto Sans SC"/>
                 <a:cs typeface="Noto Sans SC"/>
               </a:rPr>
-              <a:t>以哪些使用、成本与订单证据复盘？由谁参与，安排在何时？</a:t>
+              <a:t>以哪些使用、成本和订单记录评估进展，何时再次讨论？</a:t>
             </a:r>
           </a:p>
         </p:txBody>
@@ -7399,7 +7242,7 @@
           <p:cNvPr id="12" name="takeaway">
             <a:extLst xmlns:a="http://schemas.openxmlformats.org/drawingml/2006/main">
               <a:ext uri="{FF2B5EF4-FFF2-40B4-BE49-F238E27FC236}">
-                <a16:creationId xmlns:a16="http://schemas.microsoft.com/office/drawing/2014/main" id="{80884628-4FD5-4136-9036-0B366EBDED78}"/>
+                <a16:creationId xmlns:a16="http://schemas.microsoft.com/office/drawing/2014/main" id="{1AA20973-DDBA-441D-9FFD-738D66E415D9}"/>
               </a:ext>
             </a:extLst>
           </p:cNvPr>
@@ -7457,7 +7300,7 @@
                 <a:ea typeface="Noto Sans SC"/>
                 <a:cs typeface="Noto Sans SC"/>
               </a:rPr>
-              <a:t>主张：以家庭呈现与回应补充采集端价值，用真实使用和订单逐步推进合作。</a:t>
+              <a:t>下一步以明确的工作范围、负责人和评估时间推进。</a:t>
             </a:r>
           </a:p>
         </p:txBody>
@@ -7467,7 +7310,7 @@
           <p:cNvPr id="13" name="page">
             <a:extLst xmlns:a="http://schemas.openxmlformats.org/drawingml/2006/main">
               <a:ext uri="{FF2B5EF4-FFF2-40B4-BE49-F238E27FC236}">
-                <a16:creationId xmlns:a16="http://schemas.microsoft.com/office/drawing/2014/main" id="{60AE6B45-3C52-4F8C-8524-BB6E09DEA3FF}"/>
+                <a16:creationId xmlns:a16="http://schemas.microsoft.com/office/drawing/2014/main" id="{8E84B134-695A-44BA-AEC7-54539185AD7D}"/>
               </a:ext>
             </a:extLst>
           </p:cNvPr>
@@ -7533,7 +7376,7 @@
     </p:spTree>
     <p:extLst>
       <p:ext uri="{BB962C8B-B14F-4D97-AF65-F5344CB8AC3E}">
-        <p14:creationId xmlns:p14="http://schemas.microsoft.com/office/powerpoint/2010/main" val="1497320018"/>
+        <p14:creationId xmlns:p14="http://schemas.microsoft.com/office/powerpoint/2010/main" val="941749714"/>
       </p:ext>
     </p:extLst>
   </p:cSld>
@@ -7564,7 +7407,7 @@
           <p:cNvPr id="21" name="section">
             <a:extLst xmlns:a="http://schemas.openxmlformats.org/drawingml/2006/main">
               <a:ext uri="{FF2B5EF4-FFF2-40B4-BE49-F238E27FC236}">
-                <a16:creationId xmlns:a16="http://schemas.microsoft.com/office/drawing/2014/main" id="{60F1F498-FEEB-4A87-8B9F-ED99389A79C4}"/>
+                <a16:creationId xmlns:a16="http://schemas.microsoft.com/office/drawing/2014/main" id="{E291B61E-BF67-445D-A282-581D27B4125A}"/>
               </a:ext>
             </a:extLst>
           </p:cNvPr>
@@ -7622,7 +7465,7 @@
                 <a:ea typeface="Noto Sans SC"/>
                 <a:cs typeface="Noto Sans SC"/>
               </a:rPr>
-              <a:t>备查，不占主讲时间</a:t>
+              <a:t>参考资料</a:t>
             </a:r>
           </a:p>
         </p:txBody>
@@ -7632,7 +7475,7 @@
           <p:cNvPr id="2" name="title">
             <a:extLst xmlns:a="http://schemas.openxmlformats.org/drawingml/2006/main">
               <a:ext uri="{FF2B5EF4-FFF2-40B4-BE49-F238E27FC236}">
-                <a16:creationId xmlns:a16="http://schemas.microsoft.com/office/drawing/2014/main" id="{5ED17AA4-4563-4F09-A057-A8BEA0829AC7}"/>
+                <a16:creationId xmlns:a16="http://schemas.microsoft.com/office/drawing/2014/main" id="{0EEC5A6D-3302-4832-9360-49A7C197315B}"/>
               </a:ext>
             </a:extLst>
           </p:cNvPr>
@@ -7690,7 +7533,7 @@
                 <a:ea typeface="Noto Sans SC"/>
                 <a:cs typeface="Noto Sans SC"/>
               </a:rPr>
-              <a:t>来源与计划口径</a:t>
+              <a:t>资料来源与规划依据</a:t>
             </a:r>
           </a:p>
         </p:txBody>
@@ -7700,7 +7543,7 @@
           <p:cNvPr id="3" name="ref-A1">
             <a:extLst xmlns:a="http://schemas.openxmlformats.org/drawingml/2006/main">
               <a:ext uri="{FF2B5EF4-FFF2-40B4-BE49-F238E27FC236}">
-                <a16:creationId xmlns:a16="http://schemas.microsoft.com/office/drawing/2014/main" id="{1DF7E501-2EF1-44A3-8573-E4F889249296}"/>
+                <a16:creationId xmlns:a16="http://schemas.microsoft.com/office/drawing/2014/main" id="{12200F9A-6E94-49B0-AFF9-76C7D4106892}"/>
               </a:ext>
             </a:extLst>
           </p:cNvPr>
@@ -7768,7 +7611,7 @@
           <p:cNvPr id="4" name="ref-title-A1">
             <a:extLst xmlns:a="http://schemas.openxmlformats.org/drawingml/2006/main">
               <a:ext uri="{FF2B5EF4-FFF2-40B4-BE49-F238E27FC236}">
-                <a16:creationId xmlns:a16="http://schemas.microsoft.com/office/drawing/2014/main" id="{C8A50534-4030-41D1-88EA-B2589C103D48}"/>
+                <a16:creationId xmlns:a16="http://schemas.microsoft.com/office/drawing/2014/main" id="{EAB6C0C3-5C49-476E-86FA-137AC5DCFE98}"/>
               </a:ext>
             </a:extLst>
           </p:cNvPr>
@@ -7825,7 +7668,7 @@
                 <a:latin typeface="Noto Sans SC"/>
                 <a:ea typeface="Noto Sans SC"/>
                 <a:cs typeface="Noto Sans SC"/>
-                <a:hlinkClick xmlns:r="http://schemas.openxmlformats.org/officeDocument/2006/relationships" r:id="R8f2ed77a4d584525"/>
+                <a:hlinkClick xmlns:r="http://schemas.openxmlformats.org/officeDocument/2006/relationships" r:id="R937f3383836146c2"/>
               </a:rPr>
               <a:t>影石 Bold Maker 挑战赛收官报道 ↗</a:t>
             </a:r>
@@ -7837,7 +7680,7 @@
           <p:cNvPr id="5" name="ref-locator-A1">
             <a:extLst xmlns:a="http://schemas.openxmlformats.org/drawingml/2006/main">
               <a:ext uri="{FF2B5EF4-FFF2-40B4-BE49-F238E27FC236}">
-                <a16:creationId xmlns:a16="http://schemas.microsoft.com/office/drawing/2014/main" id="{38ECE421-6A0B-42CC-B87A-A5B7AAF42AFE}"/>
+                <a16:creationId xmlns:a16="http://schemas.microsoft.com/office/drawing/2014/main" id="{E35B0A49-A3A7-483E-8EFB-E8AF21F1E91C}"/>
               </a:ext>
             </a:extLst>
           </p:cNvPr>
@@ -7905,7 +7748,7 @@
           <p:cNvPr id="6" name="ref-summary-A1">
             <a:extLst xmlns:a="http://schemas.openxmlformats.org/drawingml/2006/main">
               <a:ext uri="{FF2B5EF4-FFF2-40B4-BE49-F238E27FC236}">
-                <a16:creationId xmlns:a16="http://schemas.microsoft.com/office/drawing/2014/main" id="{D1EE29FB-932F-4396-9516-3FE887BB3314}"/>
+                <a16:creationId xmlns:a16="http://schemas.microsoft.com/office/drawing/2014/main" id="{70F5EBFB-E8FD-4C1C-BC38-D8410E4AB1C1}"/>
               </a:ext>
             </a:extLst>
           </p:cNvPr>
@@ -7970,10 +7813,10 @@
       </p:sp>
       <p:sp>
         <p:nvSpPr>
-          <p:cNvPr id="7" name="ref-A2">
-            <a:extLst xmlns:a="http://schemas.openxmlformats.org/drawingml/2006/main">
-              <a:ext uri="{FF2B5EF4-FFF2-40B4-BE49-F238E27FC236}">
-                <a16:creationId xmlns:a16="http://schemas.microsoft.com/office/drawing/2014/main" id="{6047E564-3B4D-444C-8E35-E2C6BE897353}"/>
+          <p:cNvPr id="7" name="ref-P2">
+            <a:extLst xmlns:a="http://schemas.openxmlformats.org/drawingml/2006/main">
+              <a:ext uri="{FF2B5EF4-FFF2-40B4-BE49-F238E27FC236}">
+                <a16:creationId xmlns:a16="http://schemas.microsoft.com/office/drawing/2014/main" id="{02872AD8-7D3A-41AA-B3F6-54639C48E8AE}"/>
               </a:ext>
             </a:extLst>
           </p:cNvPr>
@@ -8031,17 +7874,17 @@
                 <a:ea typeface="Noto Sans SC"/>
                 <a:cs typeface="Noto Sans SC"/>
               </a:rPr>
-              <a:t>A2</a:t>
-            </a:r>
-          </a:p>
-        </p:txBody>
-      </p:sp>
-      <p:sp>
-        <p:nvSpPr>
-          <p:cNvPr id="8" name="ref-title-A2">
-            <a:extLst xmlns:a="http://schemas.openxmlformats.org/drawingml/2006/main">
-              <a:ext uri="{FF2B5EF4-FFF2-40B4-BE49-F238E27FC236}">
-                <a16:creationId xmlns:a16="http://schemas.microsoft.com/office/drawing/2014/main" id="{96342DD6-14CF-4760-997E-8B4DDBC2EF06}"/>
+              <a:t>P2</a:t>
+            </a:r>
+          </a:p>
+        </p:txBody>
+      </p:sp>
+      <p:sp>
+        <p:nvSpPr>
+          <p:cNvPr id="8" name="ref-title-P2">
+            <a:extLst xmlns:a="http://schemas.openxmlformats.org/drawingml/2006/main">
+              <a:ext uri="{FF2B5EF4-FFF2-40B4-BE49-F238E27FC236}">
+                <a16:creationId xmlns:a16="http://schemas.microsoft.com/office/drawing/2014/main" id="{FD76ACC8-E7C5-488F-9491-0589221D1A37}"/>
               </a:ext>
             </a:extLst>
           </p:cNvPr>
@@ -8098,19 +7941,18 @@
                 <a:latin typeface="Noto Sans SC"/>
                 <a:ea typeface="Noto Sans SC"/>
                 <a:cs typeface="Noto Sans SC"/>
-                <a:hlinkClick xmlns:r="http://schemas.openxmlformats.org/officeDocument/2006/relationships" r:id="Rbbd8bdd696484753"/>
-              </a:rPr>
-              <a:t>影石官方手册：AI 导演 ↗</a:t>
-            </a:r>
-          </a:p>
-        </p:txBody>
-      </p:sp>
-      <p:sp>
-        <p:nvSpPr>
-          <p:cNvPr id="9" name="ref-locator-A2">
-            <a:extLst xmlns:a="http://schemas.openxmlformats.org/drawingml/2006/main">
-              <a:ext uri="{FF2B5EF4-FFF2-40B4-BE49-F238E27FC236}">
-                <a16:creationId xmlns:a16="http://schemas.microsoft.com/office/drawing/2014/main" id="{0B2EF6D2-2DE3-44D9-ACBB-71F23E5F6452}"/>
+              </a:rPr>
+              <a:t>项目成果与设备验证记录</a:t>
+            </a:r>
+          </a:p>
+        </p:txBody>
+      </p:sp>
+      <p:sp>
+        <p:nvSpPr>
+          <p:cNvPr id="9" name="ref-locator-P2">
+            <a:extLst xmlns:a="http://schemas.openxmlformats.org/drawingml/2006/main">
+              <a:ext uri="{FF2B5EF4-FFF2-40B4-BE49-F238E27FC236}">
+                <a16:creationId xmlns:a16="http://schemas.microsoft.com/office/drawing/2014/main" id="{BFCFA2AF-25D8-4DF1-BC42-35680A6B7AD6}"/>
               </a:ext>
             </a:extLst>
           </p:cNvPr>
@@ -8168,17 +8010,17 @@
                 <a:ea typeface="Noto Sans SC"/>
                 <a:cs typeface="Noto Sans SC"/>
               </a:rPr>
-              <a:t>2026-10-12 查阅 · 功能介绍</a:t>
-            </a:r>
-          </a:p>
-        </p:txBody>
-      </p:sp>
-      <p:sp>
-        <p:nvSpPr>
-          <p:cNvPr id="10" name="ref-summary-A2">
-            <a:extLst xmlns:a="http://schemas.openxmlformats.org/drawingml/2006/main">
-              <a:ext uri="{FF2B5EF4-FFF2-40B4-BE49-F238E27FC236}">
-                <a16:creationId xmlns:a16="http://schemas.microsoft.com/office/drawing/2014/main" id="{893AAB36-89A3-4F4A-846E-E9EB0AB4154B}"/>
+              <a:t>截至 2026-10-13 · 团队项目记录</a:t>
+            </a:r>
+          </a:p>
+        </p:txBody>
+      </p:sp>
+      <p:sp>
+        <p:nvSpPr>
+          <p:cNvPr id="10" name="ref-summary-P2">
+            <a:extLst xmlns:a="http://schemas.openxmlformats.org/drawingml/2006/main">
+              <a:ext uri="{FF2B5EF4-FFF2-40B4-BE49-F238E27FC236}">
+                <a16:creationId xmlns:a16="http://schemas.microsoft.com/office/drawing/2014/main" id="{E5BD0204-9E2B-479D-B844-233DE1C57C2F}"/>
               </a:ext>
             </a:extLst>
           </p:cNvPr>
@@ -8236,17 +8078,17 @@
                 <a:ea typeface="Noto Sans SC"/>
                 <a:cs typeface="Noto Sans SC"/>
               </a:rPr>
-              <a:t>已有素材筛选、自动剪辑等能力。基础 AI 整理不宜作为影石缺失能力来推介。</a:t>
-            </a:r>
-          </a:p>
-        </p:txBody>
-      </p:sp>
-      <p:sp>
-        <p:nvSpPr>
-          <p:cNvPr id="11" name="ref-U3">
-            <a:extLst xmlns:a="http://schemas.openxmlformats.org/drawingml/2006/main">
-              <a:ext uri="{FF2B5EF4-FFF2-40B4-BE49-F238E27FC236}">
-                <a16:creationId xmlns:a16="http://schemas.microsoft.com/office/drawing/2014/main" id="{E22DF6D1-FFB0-436E-B049-E8D4C7D1AD5E}"/>
+              <a:t>影石 AI+社会公益赛道第一名为团队确认成果。当前通过翻译笔开展实体 Demo 验证，持续运行结果待设备测试确认。</a:t>
+            </a:r>
+          </a:p>
+        </p:txBody>
+      </p:sp>
+      <p:sp>
+        <p:nvSpPr>
+          <p:cNvPr id="11" name="ref-D1">
+            <a:extLst xmlns:a="http://schemas.openxmlformats.org/drawingml/2006/main">
+              <a:ext uri="{FF2B5EF4-FFF2-40B4-BE49-F238E27FC236}">
+                <a16:creationId xmlns:a16="http://schemas.microsoft.com/office/drawing/2014/main" id="{C3851409-0FFA-4C59-9970-AEA0D3C1101B}"/>
               </a:ext>
             </a:extLst>
           </p:cNvPr>
@@ -8304,17 +8146,17 @@
                 <a:ea typeface="Noto Sans SC"/>
                 <a:cs typeface="Noto Sans SC"/>
               </a:rPr>
-              <a:t>U3</a:t>
-            </a:r>
-          </a:p>
-        </p:txBody>
-      </p:sp>
-      <p:sp>
-        <p:nvSpPr>
-          <p:cNvPr id="12" name="ref-title-U3">
-            <a:extLst xmlns:a="http://schemas.openxmlformats.org/drawingml/2006/main">
-              <a:ext uri="{FF2B5EF4-FFF2-40B4-BE49-F238E27FC236}">
-                <a16:creationId xmlns:a16="http://schemas.microsoft.com/office/drawing/2014/main" id="{F08C024D-D04C-442C-AB0A-F3289C7379BF}"/>
+              <a:t>D1</a:t>
+            </a:r>
+          </a:p>
+        </p:txBody>
+      </p:sp>
+      <p:sp>
+        <p:nvSpPr>
+          <p:cNvPr id="12" name="ref-title-D1">
+            <a:extLst xmlns:a="http://schemas.openxmlformats.org/drawingml/2006/main">
+              <a:ext uri="{FF2B5EF4-FFF2-40B4-BE49-F238E27FC236}">
+                <a16:creationId xmlns:a16="http://schemas.microsoft.com/office/drawing/2014/main" id="{1DDD037E-63F8-410D-9709-F66689BD4EAF}"/>
               </a:ext>
             </a:extLst>
           </p:cNvPr>
@@ -8372,17 +8214,17 @@
                 <a:ea typeface="Noto Sans SC"/>
                 <a:cs typeface="Noto Sans SC"/>
               </a:rPr>
-              <a:t>本次项目方向与计划</a:t>
-            </a:r>
-          </a:p>
-        </p:txBody>
-      </p:sp>
-      <p:sp>
-        <p:nvSpPr>
-          <p:cNvPr id="13" name="ref-locator-U3">
-            <a:extLst xmlns:a="http://schemas.openxmlformats.org/drawingml/2006/main">
-              <a:ext uri="{FF2B5EF4-FFF2-40B4-BE49-F238E27FC236}">
-                <a16:creationId xmlns:a16="http://schemas.microsoft.com/office/drawing/2014/main" id="{9C22502E-0E32-45EC-AEA4-552C30A48F44}"/>
+              <a:t>UNSEEN 原有外观与结构方案</a:t>
+            </a:r>
+          </a:p>
+        </p:txBody>
+      </p:sp>
+      <p:sp>
+        <p:nvSpPr>
+          <p:cNvPr id="13" name="ref-locator-D1">
+            <a:extLst xmlns:a="http://schemas.openxmlformats.org/drawingml/2006/main">
+              <a:ext uri="{FF2B5EF4-FFF2-40B4-BE49-F238E27FC236}">
+                <a16:creationId xmlns:a16="http://schemas.microsoft.com/office/drawing/2014/main" id="{C10C2EAA-D40A-4495-A699-DD8DE32A9195}"/>
               </a:ext>
             </a:extLst>
           </p:cNvPr>
@@ -8440,17 +8282,17 @@
                 <a:ea typeface="Noto Sans SC"/>
                 <a:cs typeface="Noto Sans SC"/>
               </a:rPr>
-              <a:t>2026-10-13 · Max 本轮口述及转写纠正</a:t>
-            </a:r>
-          </a:p>
-        </p:txBody>
-      </p:sp>
-      <p:sp>
-        <p:nvSpPr>
-          <p:cNvPr id="14" name="ref-summary-U3">
-            <a:extLst xmlns:a="http://schemas.openxmlformats.org/drawingml/2006/main">
-              <a:ext uri="{FF2B5EF4-FFF2-40B4-BE49-F238E27FC236}">
-                <a16:creationId xmlns:a16="http://schemas.microsoft.com/office/drawing/2014/main" id="{2E618EEB-F133-43AD-A6EF-EB1B3643BC8B}"/>
+              <a:t>2026-10-08 · R1 设计评审稿</a:t>
+            </a:r>
+          </a:p>
+        </p:txBody>
+      </p:sp>
+      <p:sp>
+        <p:nvSpPr>
+          <p:cNvPr id="14" name="ref-summary-D1">
+            <a:extLst xmlns:a="http://schemas.openxmlformats.org/drawingml/2006/main">
+              <a:ext uri="{FF2B5EF4-FFF2-40B4-BE49-F238E27FC236}">
+                <a16:creationId xmlns:a16="http://schemas.microsoft.com/office/drawing/2014/main" id="{353E3C9A-E114-4502-9598-3234502026E9}"/>
               </a:ext>
             </a:extLst>
           </p:cNvPr>
@@ -8508,17 +8350,17 @@
                 <a:ea typeface="Noto Sans SC"/>
                 <a:cs typeface="Noto Sans SC"/>
               </a:rPr>
-              <a:t>翻译笔验证 → 大屏多机试用 → 视频与市场测试 → 国内平台预售 → 工厂订单与交付；先有产品和订单信号，再讨论融资。未规划车内产品。</a:t>
-            </a:r>
-          </a:p>
-        </p:txBody>
-      </p:sp>
-      <p:sp>
-        <p:nvSpPr>
-          <p:cNvPr id="15" name="ref-P2">
-            <a:extLst xmlns:a="http://schemas.openxmlformats.org/drawingml/2006/main">
-              <a:ext uri="{FF2B5EF4-FFF2-40B4-BE49-F238E27FC236}">
-                <a16:creationId xmlns:a16="http://schemas.microsoft.com/office/drawing/2014/main" id="{7070C6FA-98B1-43E6-BAA4-436E8A9E412D}"/>
+              <a:t>浅木色外框、暖白后壳、灰绿与陶土红双键。独立相框作为首版方向，灯座构型作为后续备选。图片为设计概念。</a:t>
+            </a:r>
+          </a:p>
+        </p:txBody>
+      </p:sp>
+      <p:sp>
+        <p:nvSpPr>
+          <p:cNvPr id="15" name="ref-U3">
+            <a:extLst xmlns:a="http://schemas.openxmlformats.org/drawingml/2006/main">
+              <a:ext uri="{FF2B5EF4-FFF2-40B4-BE49-F238E27FC236}">
+                <a16:creationId xmlns:a16="http://schemas.microsoft.com/office/drawing/2014/main" id="{A1FEB777-D90F-46B3-8514-69CD731AB34A}"/>
               </a:ext>
             </a:extLst>
           </p:cNvPr>
@@ -8576,17 +8418,17 @@
                 <a:ea typeface="Noto Sans SC"/>
                 <a:cs typeface="Noto Sans SC"/>
               </a:rPr>
-              <a:t>P2</a:t>
-            </a:r>
-          </a:p>
-        </p:txBody>
-      </p:sp>
-      <p:sp>
-        <p:nvSpPr>
-          <p:cNvPr id="16" name="ref-title-P2">
-            <a:extLst xmlns:a="http://schemas.openxmlformats.org/drawingml/2006/main">
-              <a:ext uri="{FF2B5EF4-FFF2-40B4-BE49-F238E27FC236}">
-                <a16:creationId xmlns:a16="http://schemas.microsoft.com/office/drawing/2014/main" id="{83323511-BA4C-4EEC-9B88-6924A9D83B84}"/>
+              <a:t>U3</a:t>
+            </a:r>
+          </a:p>
+        </p:txBody>
+      </p:sp>
+      <p:sp>
+        <p:nvSpPr>
+          <p:cNvPr id="16" name="ref-title-U3">
+            <a:extLst xmlns:a="http://schemas.openxmlformats.org/drawingml/2006/main">
+              <a:ext uri="{FF2B5EF4-FFF2-40B4-BE49-F238E27FC236}">
+                <a16:creationId xmlns:a16="http://schemas.microsoft.com/office/drawing/2014/main" id="{1BAB5A2D-F3CA-4DBC-912D-B5400B13238D}"/>
               </a:ext>
             </a:extLst>
           </p:cNvPr>
@@ -8644,17 +8486,17 @@
                 <a:ea typeface="Noto Sans SC"/>
                 <a:cs typeface="Noto Sans SC"/>
               </a:rPr>
-              <a:t>获奖口径与当前阶段</a:t>
-            </a:r>
-          </a:p>
-        </p:txBody>
-      </p:sp>
-      <p:sp>
-        <p:nvSpPr>
-          <p:cNvPr id="17" name="ref-locator-P2">
-            <a:extLst xmlns:a="http://schemas.openxmlformats.org/drawingml/2006/main">
-              <a:ext uri="{FF2B5EF4-FFF2-40B4-BE49-F238E27FC236}">
-                <a16:creationId xmlns:a16="http://schemas.microsoft.com/office/drawing/2014/main" id="{79F46230-F341-487C-8D9D-B67130A68B9F}"/>
+              <a:t>产品验证与市场规划</a:t>
+            </a:r>
+          </a:p>
+        </p:txBody>
+      </p:sp>
+      <p:sp>
+        <p:nvSpPr>
+          <p:cNvPr id="17" name="ref-locator-U3">
+            <a:extLst xmlns:a="http://schemas.openxmlformats.org/drawingml/2006/main">
+              <a:ext uri="{FF2B5EF4-FFF2-40B4-BE49-F238E27FC236}">
+                <a16:creationId xmlns:a16="http://schemas.microsoft.com/office/drawing/2014/main" id="{D778F49F-154B-4131-9D16-AB97B0B4B439}"/>
               </a:ext>
             </a:extLst>
           </p:cNvPr>
@@ -8712,17 +8554,17 @@
                 <a:ea typeface="Noto Sans SC"/>
                 <a:cs typeface="Noto Sans SC"/>
               </a:rPr>
-              <a:t>用户既有确认；当前状态以 2026-10-13 补充为准 · UNSEEN 获奖记录与本次讨论</a:t>
-            </a:r>
-          </a:p>
-        </p:txBody>
-      </p:sp>
-      <p:sp>
-        <p:nvSpPr>
-          <p:cNvPr id="18" name="ref-summary-P2">
-            <a:extLst xmlns:a="http://schemas.openxmlformats.org/drawingml/2006/main">
-              <a:ext uri="{FF2B5EF4-FFF2-40B4-BE49-F238E27FC236}">
-                <a16:creationId xmlns:a16="http://schemas.microsoft.com/office/drawing/2014/main" id="{8151C857-79A2-427E-96FC-5D03646E6C92}"/>
+              <a:t>2026-10-13 · 团队当前规划</a:t>
+            </a:r>
+          </a:p>
+        </p:txBody>
+      </p:sp>
+      <p:sp>
+        <p:nvSpPr>
+          <p:cNvPr id="18" name="ref-summary-U3">
+            <a:extLst xmlns:a="http://schemas.openxmlformats.org/drawingml/2006/main">
+              <a:ext uri="{FF2B5EF4-FFF2-40B4-BE49-F238E27FC236}">
+                <a16:creationId xmlns:a16="http://schemas.microsoft.com/office/drawing/2014/main" id="{DE3FB1BE-9C0C-4ADF-95C6-D71C77F4D328}"/>
               </a:ext>
             </a:extLst>
           </p:cNvPr>
@@ -8780,7 +8622,7 @@
                 <a:ea typeface="Noto Sans SC"/>
                 <a:cs typeface="Noto Sans SC"/>
               </a:rPr>
-              <a:t>影石 AI+社会公益赛道第一名为用户已确认成绩；公开报道用于核对典礼日期。翻译笔用于一代实体 Demo 验证，独立运行稳定性仍需设备测试。</a:t>
+              <a:t>翻译笔验证、大屏样机、家庭试用、国内预售、公益采购与海外需求测试。样机数量和排期为讨论方案。</a:t>
             </a:r>
           </a:p>
         </p:txBody>
@@ -8790,7 +8632,7 @@
           <p:cNvPr id="19" name="takeaway">
             <a:extLst xmlns:a="http://schemas.openxmlformats.org/drawingml/2006/main">
               <a:ext uri="{FF2B5EF4-FFF2-40B4-BE49-F238E27FC236}">
-                <a16:creationId xmlns:a16="http://schemas.microsoft.com/office/drawing/2014/main" id="{89797B61-6ED7-401E-89EB-58E7B80FBDAF}"/>
+                <a16:creationId xmlns:a16="http://schemas.microsoft.com/office/drawing/2014/main" id="{EB60A9CF-1BB3-4460-B25D-8D53A4CABDAC}"/>
               </a:ext>
             </a:extLst>
           </p:cNvPr>
@@ -8848,7 +8690,7 @@
                 <a:ea typeface="Noto Sans SC"/>
                 <a:cs typeface="Noto Sans SC"/>
               </a:rPr>
-              <a:t>日期与官方能力可追溯；时间表、样机数量、市场方案和合作安排均为讨论提案。</a:t>
+              <a:t>外观图为设计概念，产品配置、阶段计划与合作安排随验证和协商更新。</a:t>
             </a:r>
           </a:p>
         </p:txBody>
@@ -8858,7 +8700,7 @@
           <p:cNvPr id="20" name="page">
             <a:extLst xmlns:a="http://schemas.openxmlformats.org/drawingml/2006/main">
               <a:ext uri="{FF2B5EF4-FFF2-40B4-BE49-F238E27FC236}">
-                <a16:creationId xmlns:a16="http://schemas.microsoft.com/office/drawing/2014/main" id="{C4F7D2FE-3EF4-4C63-8478-D6B7CDFE28E5}"/>
+                <a16:creationId xmlns:a16="http://schemas.microsoft.com/office/drawing/2014/main" id="{257BFDB1-4432-4A71-9485-919609E87EBC}"/>
               </a:ext>
             </a:extLst>
           </p:cNvPr>
@@ -8924,7 +8766,7 @@
     </p:spTree>
     <p:extLst>
       <p:ext uri="{BB962C8B-B14F-4D97-AF65-F5344CB8AC3E}">
-        <p14:creationId xmlns:p14="http://schemas.microsoft.com/office/powerpoint/2010/main" val="1444217165"/>
+        <p14:creationId xmlns:p14="http://schemas.microsoft.com/office/powerpoint/2010/main" val="866986310"/>
       </p:ext>
     </p:extLst>
   </p:cSld>
@@ -8955,7 +8797,7 @@
           <p:cNvPr id="18" name="section">
             <a:extLst xmlns:a="http://schemas.openxmlformats.org/drawingml/2006/main">
               <a:ext uri="{FF2B5EF4-FFF2-40B4-BE49-F238E27FC236}">
-                <a16:creationId xmlns:a16="http://schemas.microsoft.com/office/drawing/2014/main" id="{F90C2013-0970-440E-A5D1-515B6465315A}"/>
+                <a16:creationId xmlns:a16="http://schemas.microsoft.com/office/drawing/2014/main" id="{FF5A235C-6F88-4BCC-AD6D-AA64DC2D70A7}"/>
               </a:ext>
             </a:extLst>
           </p:cNvPr>
@@ -9023,7 +8865,7 @@
           <p:cNvPr id="2" name="title">
             <a:extLst xmlns:a="http://schemas.openxmlformats.org/drawingml/2006/main">
               <a:ext uri="{FF2B5EF4-FFF2-40B4-BE49-F238E27FC236}">
-                <a16:creationId xmlns:a16="http://schemas.microsoft.com/office/drawing/2014/main" id="{07D74212-E987-4449-A99E-1B81247A8D36}"/>
+                <a16:creationId xmlns:a16="http://schemas.microsoft.com/office/drawing/2014/main" id="{37D7D742-4553-4173-B27F-C3AD46E3BA88}"/>
               </a:ext>
             </a:extLst>
           </p:cNvPr>
@@ -9081,7 +8923,7 @@
                 <a:ea typeface="Noto Sans SC"/>
                 <a:cs typeface="Noto Sans SC"/>
               </a:rPr>
-              <a:t>获奖之后，进入实体产品验证</a:t>
+              <a:t>当前进展</a:t>
             </a:r>
           </a:p>
         </p:txBody>
@@ -9091,7 +8933,7 @@
           <p:cNvPr id="3" name="lead">
             <a:extLst xmlns:a="http://schemas.openxmlformats.org/drawingml/2006/main">
               <a:ext uri="{FF2B5EF4-FFF2-40B4-BE49-F238E27FC236}">
-                <a16:creationId xmlns:a16="http://schemas.microsoft.com/office/drawing/2014/main" id="{B14F4F62-5754-4327-BAD9-191C9DB2CCEC}"/>
+                <a16:creationId xmlns:a16="http://schemas.microsoft.com/office/drawing/2014/main" id="{21B298B5-C964-4C5C-AA1B-E1F4CCA55BE3}"/>
               </a:ext>
             </a:extLst>
           </p:cNvPr>
@@ -9149,7 +8991,7 @@
                 <a:ea typeface="Noto Sans SC"/>
                 <a:cs typeface="Noto Sans SC"/>
               </a:rPr>
-              <a:t>2026.09.24 赛事颁奖 → 2026.10.13 当前讨论，间隔 19 天。</a:t>
+              <a:t>已有软件与交互原型，正在推进第一代实体 Demo。</a:t>
             </a:r>
           </a:p>
         </p:txBody>
@@ -9159,7 +9001,7 @@
           <p:cNvPr id="4" name="row-label-0">
             <a:extLst xmlns:a="http://schemas.openxmlformats.org/drawingml/2006/main">
               <a:ext uri="{FF2B5EF4-FFF2-40B4-BE49-F238E27FC236}">
-                <a16:creationId xmlns:a16="http://schemas.microsoft.com/office/drawing/2014/main" id="{B2ED556D-3D35-4DB5-998B-3D722F2900E0}"/>
+                <a16:creationId xmlns:a16="http://schemas.microsoft.com/office/drawing/2014/main" id="{512BC163-5DC1-4E73-8EC4-7CCBFEF6E9E7}"/>
               </a:ext>
             </a:extLst>
           </p:cNvPr>
@@ -9217,7 +9059,7 @@
                 <a:ea typeface="Noto Sans SC"/>
                 <a:cs typeface="Noto Sans SC"/>
               </a:rPr>
-              <a:t>已有基础</a:t>
+              <a:t>项目基础</a:t>
             </a:r>
           </a:p>
         </p:txBody>
@@ -9227,7 +9069,7 @@
           <p:cNvPr id="5" name="row-body-0">
             <a:extLst xmlns:a="http://schemas.openxmlformats.org/drawingml/2006/main">
               <a:ext uri="{FF2B5EF4-FFF2-40B4-BE49-F238E27FC236}">
-                <a16:creationId xmlns:a16="http://schemas.microsoft.com/office/drawing/2014/main" id="{B9E7F777-38F3-47A1-9BA6-B5D9AAC8C7FA}"/>
+                <a16:creationId xmlns:a16="http://schemas.microsoft.com/office/drawing/2014/main" id="{FD4F9EBF-EC61-4C00-8C69-438B88E380CF}"/>
               </a:ext>
             </a:extLst>
           </p:cNvPr>
@@ -9285,7 +9127,7 @@
                 <a:ea typeface="Noto Sans SC"/>
                 <a:cs typeface="Noto Sans SC"/>
               </a:rPr>
-              <a:t>UNSEEN 获影石 AI+社会公益赛道第一名；已有软件与交互原型。</a:t>
+              <a:t>获影石 AI+社会公益赛道第一名，颁奖日期为 2026 年 9 月 24 日。</a:t>
             </a:r>
           </a:p>
         </p:txBody>
@@ -9295,7 +9137,7 @@
           <p:cNvPr id="6" name="row-label-1">
             <a:extLst xmlns:a="http://schemas.openxmlformats.org/drawingml/2006/main">
               <a:ext uri="{FF2B5EF4-FFF2-40B4-BE49-F238E27FC236}">
-                <a16:creationId xmlns:a16="http://schemas.microsoft.com/office/drawing/2014/main" id="{916E243D-96BA-411A-A2F3-3C94F72EB68B}"/>
+                <a16:creationId xmlns:a16="http://schemas.microsoft.com/office/drawing/2014/main" id="{095B5970-F55A-4872-95CA-D3A702C1E295}"/>
               </a:ext>
             </a:extLst>
           </p:cNvPr>
@@ -9353,7 +9195,7 @@
                 <a:ea typeface="Noto Sans SC"/>
                 <a:cs typeface="Noto Sans SC"/>
               </a:rPr>
-              <a:t>当前设备</a:t>
+              <a:t>当前验证</a:t>
             </a:r>
           </a:p>
         </p:txBody>
@@ -9363,7 +9205,7 @@
           <p:cNvPr id="7" name="row-body-1">
             <a:extLst xmlns:a="http://schemas.openxmlformats.org/drawingml/2006/main">
               <a:ext uri="{FF2B5EF4-FFF2-40B4-BE49-F238E27FC236}">
-                <a16:creationId xmlns:a16="http://schemas.microsoft.com/office/drawing/2014/main" id="{F7CE840C-F104-4BAC-B226-3DC3E5834B78}"/>
+                <a16:creationId xmlns:a16="http://schemas.microsoft.com/office/drawing/2014/main" id="{F1C3297E-2337-4E79-8DE3-82CD4E8FA36C}"/>
               </a:ext>
             </a:extLst>
           </p:cNvPr>
@@ -9421,7 +9263,7 @@
                 <a:ea typeface="Noto Sans SC"/>
                 <a:cs typeface="Noto Sans SC"/>
               </a:rPr>
-              <a:t>用翻译笔验证第一代实体 Demo，观察体验效果与设备限制。</a:t>
+              <a:t>以翻译笔为载体，验证交互体验与独立设备运行。</a:t>
             </a:r>
           </a:p>
         </p:txBody>
@@ -9431,7 +9273,7 @@
           <p:cNvPr id="8" name="row-label-2">
             <a:extLst xmlns:a="http://schemas.openxmlformats.org/drawingml/2006/main">
               <a:ext uri="{FF2B5EF4-FFF2-40B4-BE49-F238E27FC236}">
-                <a16:creationId xmlns:a16="http://schemas.microsoft.com/office/drawing/2014/main" id="{C34C566A-A774-440D-A255-D92498A156A0}"/>
+                <a16:creationId xmlns:a16="http://schemas.microsoft.com/office/drawing/2014/main" id="{495F69D5-E309-4CAF-B791-0727DF5D396E}"/>
               </a:ext>
             </a:extLst>
           </p:cNvPr>
@@ -9489,7 +9331,7 @@
                 <a:ea typeface="Noto Sans SC"/>
                 <a:cs typeface="Noto Sans SC"/>
               </a:rPr>
-              <a:t>眼前目标</a:t>
+              <a:t>近期重点</a:t>
             </a:r>
           </a:p>
         </p:txBody>
@@ -9499,7 +9341,7 @@
           <p:cNvPr id="9" name="row-body-2">
             <a:extLst xmlns:a="http://schemas.openxmlformats.org/drawingml/2006/main">
               <a:ext uri="{FF2B5EF4-FFF2-40B4-BE49-F238E27FC236}">
-                <a16:creationId xmlns:a16="http://schemas.microsoft.com/office/drawing/2014/main" id="{10807F77-E56E-410F-83F2-64317411AAD4}"/>
+                <a16:creationId xmlns:a16="http://schemas.microsoft.com/office/drawing/2014/main" id="{1CA53CEF-5297-44C3-B5AA-EAE3949F290A}"/>
               </a:ext>
             </a:extLst>
           </p:cNvPr>
@@ -9557,7 +9399,7 @@
                 <a:ea typeface="Noto Sans SC"/>
                 <a:cs typeface="Noto Sans SC"/>
               </a:rPr>
-              <a:t>脱离开发电脑连续使用；核对启动、网络、音频、回复和恢复。</a:t>
+              <a:t>连续使用测试，记录启动、网络、音频和回复流程的表现。</a:t>
             </a:r>
           </a:p>
         </p:txBody>
@@ -9567,7 +9409,7 @@
           <p:cNvPr id="10" name="row-label-3">
             <a:extLst xmlns:a="http://schemas.openxmlformats.org/drawingml/2006/main">
               <a:ext uri="{FF2B5EF4-FFF2-40B4-BE49-F238E27FC236}">
-                <a16:creationId xmlns:a16="http://schemas.microsoft.com/office/drawing/2014/main" id="{FA200042-7DA3-4E78-8811-0995CC783FA4}"/>
+                <a16:creationId xmlns:a16="http://schemas.microsoft.com/office/drawing/2014/main" id="{F8480079-BA7C-46FD-A31E-058185067926}"/>
               </a:ext>
             </a:extLst>
           </p:cNvPr>
@@ -9625,7 +9467,7 @@
                 <a:ea typeface="Noto Sans SC"/>
                 <a:cs typeface="Noto Sans SC"/>
               </a:rPr>
-              <a:t>下一步</a:t>
+              <a:t>下一阶段</a:t>
             </a:r>
           </a:p>
         </p:txBody>
@@ -9635,7 +9477,7 @@
           <p:cNvPr id="11" name="row-body-3">
             <a:extLst xmlns:a="http://schemas.openxmlformats.org/drawingml/2006/main">
               <a:ext uri="{FF2B5EF4-FFF2-40B4-BE49-F238E27FC236}">
-                <a16:creationId xmlns:a16="http://schemas.microsoft.com/office/drawing/2014/main" id="{A64180F6-A133-49B3-9931-C4BCD5138EBA}"/>
+                <a16:creationId xmlns:a16="http://schemas.microsoft.com/office/drawing/2014/main" id="{0A639D32-5A1D-43A4-93B7-278284A3661A}"/>
               </a:ext>
             </a:extLst>
           </p:cNvPr>
@@ -9693,7 +9535,7 @@
                 <a:ea typeface="Noto Sans SC"/>
                 <a:cs typeface="Noto Sans SC"/>
               </a:rPr>
-              <a:t>通过后做更大的机子，制作多台样机，交给真实使用者。</a:t>
+              <a:t>在验证基础上形成大屏方案，制作小批样机供家庭试用。</a:t>
             </a:r>
           </a:p>
         </p:txBody>
@@ -9703,7 +9545,7 @@
           <p:cNvPr id="12" name="takeaway">
             <a:extLst xmlns:a="http://schemas.openxmlformats.org/drawingml/2006/main">
               <a:ext uri="{FF2B5EF4-FFF2-40B4-BE49-F238E27FC236}">
-                <a16:creationId xmlns:a16="http://schemas.microsoft.com/office/drawing/2014/main" id="{FC6B85BC-61DA-4C3D-B25E-5FFAC813D43E}"/>
+                <a16:creationId xmlns:a16="http://schemas.microsoft.com/office/drawing/2014/main" id="{5E444A55-FDCA-434B-B1B4-67464307C04C}"/>
               </a:ext>
             </a:extLst>
           </p:cNvPr>
@@ -9761,7 +9603,7 @@
                 <a:ea typeface="Noto Sans SC"/>
                 <a:cs typeface="Noto Sans SC"/>
               </a:rPr>
-              <a:t>独立设备运行不自动等于全部离线；具体云端依赖随演示说明。</a:t>
+              <a:t>当前重点是实体体验与稳定性验证，设备与云端的能力边界随测试明确。</a:t>
             </a:r>
           </a:p>
         </p:txBody>
@@ -9771,7 +9613,7 @@
           <p:cNvPr id="13" name="page">
             <a:extLst xmlns:a="http://schemas.openxmlformats.org/drawingml/2006/main">
               <a:ext uri="{FF2B5EF4-FFF2-40B4-BE49-F238E27FC236}">
-                <a16:creationId xmlns:a16="http://schemas.microsoft.com/office/drawing/2014/main" id="{B6652322-7ADF-4706-98C5-4D38D12F29F6}"/>
+                <a16:creationId xmlns:a16="http://schemas.microsoft.com/office/drawing/2014/main" id="{42F9DBF2-0C24-4C67-84AD-6B587C65C24F}"/>
               </a:ext>
             </a:extLst>
           </p:cNvPr>
@@ -9839,7 +9681,7 @@
           <p:cNvPr id="14" name="source-label">
             <a:extLst xmlns:a="http://schemas.openxmlformats.org/drawingml/2006/main">
               <a:ext uri="{FF2B5EF4-FFF2-40B4-BE49-F238E27FC236}">
-                <a16:creationId xmlns:a16="http://schemas.microsoft.com/office/drawing/2014/main" id="{7874D661-C4EE-4563-B419-D0B3948FFF45}"/>
+                <a16:creationId xmlns:a16="http://schemas.microsoft.com/office/drawing/2014/main" id="{83FC600E-7DF0-4B95-913D-EFCB9FD7C0AE}"/>
               </a:ext>
             </a:extLst>
           </p:cNvPr>
@@ -9907,7 +9749,7 @@
           <p:cNvPr id="15" name="source-A1">
             <a:extLst xmlns:a="http://schemas.openxmlformats.org/drawingml/2006/main">
               <a:ext uri="{FF2B5EF4-FFF2-40B4-BE49-F238E27FC236}">
-                <a16:creationId xmlns:a16="http://schemas.microsoft.com/office/drawing/2014/main" id="{8E5923A5-B134-442C-AD4D-F78BEBFBBB4C}"/>
+                <a16:creationId xmlns:a16="http://schemas.microsoft.com/office/drawing/2014/main" id="{E6968A2B-3212-4100-A3FD-327DA880A823}"/>
               </a:ext>
             </a:extLst>
           </p:cNvPr>
@@ -9964,7 +9806,7 @@
                 <a:latin typeface="Noto Sans SC"/>
                 <a:ea typeface="Noto Sans SC"/>
                 <a:cs typeface="Noto Sans SC"/>
-                <a:hlinkClick xmlns:r="http://schemas.openxmlformats.org/officeDocument/2006/relationships" r:id="Rdbe9b6d6f895420f"/>
+                <a:hlinkClick xmlns:r="http://schemas.openxmlformats.org/officeDocument/2006/relationships" r:id="R8a26423b41524108"/>
               </a:rPr>
               <a:t>A1 ↗</a:t>
             </a:r>
@@ -9976,7 +9818,7 @@
           <p:cNvPr id="16" name="source-P2">
             <a:extLst xmlns:a="http://schemas.openxmlformats.org/drawingml/2006/main">
               <a:ext uri="{FF2B5EF4-FFF2-40B4-BE49-F238E27FC236}">
-                <a16:creationId xmlns:a16="http://schemas.microsoft.com/office/drawing/2014/main" id="{0C709CE8-CFB6-4EB0-9DB1-98814519C610}"/>
+                <a16:creationId xmlns:a16="http://schemas.microsoft.com/office/drawing/2014/main" id="{5423939C-65FD-4364-9020-DC7254021627}"/>
               </a:ext>
             </a:extLst>
           </p:cNvPr>
@@ -10044,7 +9886,7 @@
           <p:cNvPr id="17" name="source-U3">
             <a:extLst xmlns:a="http://schemas.openxmlformats.org/drawingml/2006/main">
               <a:ext uri="{FF2B5EF4-FFF2-40B4-BE49-F238E27FC236}">
-                <a16:creationId xmlns:a16="http://schemas.microsoft.com/office/drawing/2014/main" id="{26D19BAF-3C15-4A88-8B08-636FBD6B9C6B}"/>
+                <a16:creationId xmlns:a16="http://schemas.microsoft.com/office/drawing/2014/main" id="{BD0618A3-673D-44E1-8ECE-BD354E45A150}"/>
               </a:ext>
             </a:extLst>
           </p:cNvPr>
@@ -10110,7 +9952,7 @@
     </p:spTree>
     <p:extLst>
       <p:ext uri="{BB962C8B-B14F-4D97-AF65-F5344CB8AC3E}">
-        <p14:creationId xmlns:p14="http://schemas.microsoft.com/office/powerpoint/2010/main" val="1183366440"/>
+        <p14:creationId xmlns:p14="http://schemas.microsoft.com/office/powerpoint/2010/main" val="100364416"/>
       </p:ext>
     </p:extLst>
   </p:cSld>
@@ -10138,10 +9980,10 @@
       </p:grpSpPr>
       <p:sp>
         <p:nvSpPr>
-          <p:cNvPr id="16" name="section">
-            <a:extLst xmlns:a="http://schemas.openxmlformats.org/drawingml/2006/main">
-              <a:ext uri="{FF2B5EF4-FFF2-40B4-BE49-F238E27FC236}">
-                <a16:creationId xmlns:a16="http://schemas.microsoft.com/office/drawing/2014/main" id="{9B95326B-FF5F-4198-B842-00D42C3AC901}"/>
+          <p:cNvPr id="17" name="section">
+            <a:extLst xmlns:a="http://schemas.openxmlformats.org/drawingml/2006/main">
+              <a:ext uri="{FF2B5EF4-FFF2-40B4-BE49-F238E27FC236}">
+                <a16:creationId xmlns:a16="http://schemas.microsoft.com/office/drawing/2014/main" id="{00137DD1-2327-443D-8752-23DAF5B2D36D}"/>
               </a:ext>
             </a:extLst>
           </p:cNvPr>
@@ -10209,7 +10051,7 @@
           <p:cNvPr id="2" name="title">
             <a:extLst xmlns:a="http://schemas.openxmlformats.org/drawingml/2006/main">
               <a:ext uri="{FF2B5EF4-FFF2-40B4-BE49-F238E27FC236}">
-                <a16:creationId xmlns:a16="http://schemas.microsoft.com/office/drawing/2014/main" id="{0E433602-E884-4AB3-A33B-6844EF5E6735}"/>
+                <a16:creationId xmlns:a16="http://schemas.microsoft.com/office/drawing/2014/main" id="{7142DEC5-6BC9-4840-A4F9-83D5982C4C9C}"/>
               </a:ext>
             </a:extLst>
           </p:cNvPr>
@@ -10267,7 +10109,7 @@
                 <a:ea typeface="Noto Sans SC"/>
                 <a:cs typeface="Noto Sans SC"/>
               </a:rPr>
-              <a:t>先共用产品底座，再分版本</a:t>
+              <a:t>产品路线</a:t>
             </a:r>
           </a:p>
         </p:txBody>
@@ -10277,7 +10119,7 @@
           <p:cNvPr id="3" name="lead">
             <a:extLst xmlns:a="http://schemas.openxmlformats.org/drawingml/2006/main">
               <a:ext uri="{FF2B5EF4-FFF2-40B4-BE49-F238E27FC236}">
-                <a16:creationId xmlns:a16="http://schemas.microsoft.com/office/drawing/2014/main" id="{3C416BFD-51B9-4795-906A-D6D0F8104BA0}"/>
+                <a16:creationId xmlns:a16="http://schemas.microsoft.com/office/drawing/2014/main" id="{AF411E17-8A85-45ED-B3FF-4BE48D46498C}"/>
               </a:ext>
             </a:extLst>
           </p:cNvPr>
@@ -10335,7 +10177,7 @@
                 <a:ea typeface="Noto Sans SC"/>
                 <a:cs typeface="Noto Sans SC"/>
               </a:rPr>
-              <a:t>首发聚焦家庭大屏；机构试点和海外版本随验证进度展开。</a:t>
+              <a:t>以家庭智能屏为主线，按需求验证结果扩展服务与市场。</a:t>
             </a:r>
           </a:p>
         </p:txBody>
@@ -10345,7 +10187,7 @@
           <p:cNvPr id="4" name="col-0-title">
             <a:extLst xmlns:a="http://schemas.openxmlformats.org/drawingml/2006/main">
               <a:ext uri="{FF2B5EF4-FFF2-40B4-BE49-F238E27FC236}">
-                <a16:creationId xmlns:a16="http://schemas.microsoft.com/office/drawing/2014/main" id="{E0C46EEC-B155-40F0-A12E-19851A5C009C}"/>
+                <a16:creationId xmlns:a16="http://schemas.microsoft.com/office/drawing/2014/main" id="{6F7B60D4-52B2-4841-8E1C-58C0DD7718DA}"/>
               </a:ext>
             </a:extLst>
           </p:cNvPr>
@@ -10403,7 +10245,7 @@
                 <a:ea typeface="Noto Sans SC"/>
                 <a:cs typeface="Noto Sans SC"/>
               </a:rPr>
-              <a:t>产品底座与首发版本</a:t>
+              <a:t>家庭智能屏</a:t>
             </a:r>
           </a:p>
         </p:txBody>
@@ -10413,7 +10255,7 @@
           <p:cNvPr id="5" name="col-0-0">
             <a:extLst xmlns:a="http://schemas.openxmlformats.org/drawingml/2006/main">
               <a:ext uri="{FF2B5EF4-FFF2-40B4-BE49-F238E27FC236}">
-                <a16:creationId xmlns:a16="http://schemas.microsoft.com/office/drawing/2014/main" id="{5051CBCB-22A3-4CF5-9DA1-04BF292B189C}"/>
+                <a16:creationId xmlns:a16="http://schemas.microsoft.com/office/drawing/2014/main" id="{85117878-9CFC-463E-8E00-7699AD9A9C42}"/>
               </a:ext>
             </a:extLst>
           </p:cNvPr>
@@ -10471,30 +10313,7 @@
                 <a:ea typeface="Noto Sans SC"/>
                 <a:cs typeface="Noto Sans SC"/>
               </a:rPr>
-              <a:t>翻译笔 Demo：验证交互与独立运行，不作</a:t>
-            </a:r>
-          </a:p>
-          <a:p xmlns:a="http://schemas.openxmlformats.org/drawingml/2006/main">
-            <a:pPr>
-              <a:defRPr sz="1875" b="0">
-                <a:solidFill>
-                  <a:srgbClr val="17364E"/>
-                </a:solidFill>
-                <a:latin typeface="Noto Sans SC"/>
-                <a:ea typeface="Noto Sans SC"/>
-                <a:cs typeface="Noto Sans SC"/>
-              </a:defRPr>
-            </a:pPr>
-            <a:r>
-              <a:rPr sz="1875" b="0">
-                <a:solidFill>
-                  <a:srgbClr val="17364E"/>
-                </a:solidFill>
-                <a:latin typeface="Noto Sans SC"/>
-                <a:ea typeface="Noto Sans SC"/>
-                <a:cs typeface="Noto Sans SC"/>
-              </a:rPr>
-              <a:t>为首发销售款。</a:t>
+              <a:t>用照片、原声和回复连接家庭成员。</a:t>
             </a:r>
           </a:p>
         </p:txBody>
@@ -10504,7 +10323,7 @@
           <p:cNvPr id="6" name="col-0-1">
             <a:extLst xmlns:a="http://schemas.openxmlformats.org/drawingml/2006/main">
               <a:ext uri="{FF2B5EF4-FFF2-40B4-BE49-F238E27FC236}">
-                <a16:creationId xmlns:a16="http://schemas.microsoft.com/office/drawing/2014/main" id="{AABEC803-B52E-4EE9-B96A-3C134A7CEF3F}"/>
+                <a16:creationId xmlns:a16="http://schemas.microsoft.com/office/drawing/2014/main" id="{54D72C85-635E-493B-AFDC-60A84821867F}"/>
               </a:ext>
             </a:extLst>
           </p:cNvPr>
@@ -10562,30 +10381,7 @@
                 <a:ea typeface="Noto Sans SC"/>
                 <a:cs typeface="Noto Sans SC"/>
               </a:rPr>
-              <a:t>家庭智能屏：照片、原声、讲述与回复，是</a:t>
-            </a:r>
-          </a:p>
-          <a:p xmlns:a="http://schemas.openxmlformats.org/drawingml/2006/main">
-            <a:pPr>
-              <a:defRPr sz="1875" b="0">
-                <a:solidFill>
-                  <a:srgbClr val="17364E"/>
-                </a:solidFill>
-                <a:latin typeface="Noto Sans SC"/>
-                <a:ea typeface="Noto Sans SC"/>
-                <a:cs typeface="Noto Sans SC"/>
-              </a:defRPr>
-            </a:pPr>
-            <a:r>
-              <a:rPr sz="1875" b="0">
-                <a:solidFill>
-                  <a:srgbClr val="17364E"/>
-                </a:solidFill>
-                <a:latin typeface="Noto Sans SC"/>
-                <a:ea typeface="Noto Sans SC"/>
-                <a:cs typeface="Noto Sans SC"/>
-              </a:rPr>
-              <a:t>第一条产品主线。</a:t>
+              <a:t>沿用浅木色外框、大照片区与小双键设计。</a:t>
             </a:r>
           </a:p>
         </p:txBody>
@@ -10595,7 +10391,7 @@
           <p:cNvPr id="7" name="col-0-2">
             <a:extLst xmlns:a="http://schemas.openxmlformats.org/drawingml/2006/main">
               <a:ext uri="{FF2B5EF4-FFF2-40B4-BE49-F238E27FC236}">
-                <a16:creationId xmlns:a16="http://schemas.microsoft.com/office/drawing/2014/main" id="{5BC98B80-6AF1-4953-B8FD-10408DCACCF6}"/>
+                <a16:creationId xmlns:a16="http://schemas.microsoft.com/office/drawing/2014/main" id="{B8601EE0-6A24-4E31-BAC1-A2F2C6E33959}"/>
               </a:ext>
             </a:extLst>
           </p:cNvPr>
@@ -10653,7 +10449,7 @@
                 <a:ea typeface="Noto Sans SC"/>
                 <a:cs typeface="Noto Sans SC"/>
               </a:rPr>
-              <a:t>大屏样机建议先做 5–10 台；数量随预算</a:t>
+              <a:t>计划制作 5–10 台大屏样机，数量随预算</a:t>
             </a:r>
           </a:p>
           <a:p xmlns:a="http://schemas.openxmlformats.org/drawingml/2006/main">
@@ -10676,7 +10472,7 @@
                 <a:ea typeface="Noto Sans SC"/>
                 <a:cs typeface="Noto Sans SC"/>
               </a:rPr>
-              <a:t>与硬件条件确认。</a:t>
+              <a:t>与工程方案确认。</a:t>
             </a:r>
           </a:p>
         </p:txBody>
@@ -10686,7 +10482,7 @@
           <p:cNvPr id="8" name="col-1-title">
             <a:extLst xmlns:a="http://schemas.openxmlformats.org/drawingml/2006/main">
               <a:ext uri="{FF2B5EF4-FFF2-40B4-BE49-F238E27FC236}">
-                <a16:creationId xmlns:a16="http://schemas.microsoft.com/office/drawing/2014/main" id="{951E2919-B8DF-4B03-9688-31C393D77976}"/>
+                <a16:creationId xmlns:a16="http://schemas.microsoft.com/office/drawing/2014/main" id="{FF474E50-CFA6-4D15-A75D-09CA9B05E792}"/>
               </a:ext>
             </a:extLst>
           </p:cNvPr>
@@ -10744,7 +10540,7 @@
                 <a:ea typeface="Noto Sans SC"/>
                 <a:cs typeface="Noto Sans SC"/>
               </a:rPr>
-              <a:t>同一底座的后续版本</a:t>
+              <a:t>后续扩展</a:t>
             </a:r>
           </a:p>
         </p:txBody>
@@ -10754,7 +10550,7 @@
           <p:cNvPr id="9" name="col-1-0">
             <a:extLst xmlns:a="http://schemas.openxmlformats.org/drawingml/2006/main">
               <a:ext uri="{FF2B5EF4-FFF2-40B4-BE49-F238E27FC236}">
-                <a16:creationId xmlns:a16="http://schemas.microsoft.com/office/drawing/2014/main" id="{B2CA8891-EC1D-4676-AB8B-2096180B8198}"/>
+                <a16:creationId xmlns:a16="http://schemas.microsoft.com/office/drawing/2014/main" id="{54C2E0A4-9D7F-4EC3-A9F7-8AA3AE5FD8B0}"/>
               </a:ext>
             </a:extLst>
           </p:cNvPr>
@@ -10812,7 +10608,7 @@
                 <a:ea typeface="Noto Sans SC"/>
                 <a:cs typeface="Noto Sans SC"/>
               </a:rPr>
-              <a:t>公益／机构试点版：安装、使用支持与集中</a:t>
+              <a:t>公益与机构试点：配套安装、培训与集中支</a:t>
             </a:r>
           </a:p>
           <a:p xmlns:a="http://schemas.openxmlformats.org/drawingml/2006/main">
@@ -10835,7 +10631,7 @@
                 <a:ea typeface="Noto Sans SC"/>
                 <a:cs typeface="Noto Sans SC"/>
               </a:rPr>
-              <a:t>服务。</a:t>
+              <a:t>持。</a:t>
             </a:r>
           </a:p>
         </p:txBody>
@@ -10845,7 +10641,7 @@
           <p:cNvPr id="10" name="col-1-1">
             <a:extLst xmlns:a="http://schemas.openxmlformats.org/drawingml/2006/main">
               <a:ext uri="{FF2B5EF4-FFF2-40B4-BE49-F238E27FC236}">
-                <a16:creationId xmlns:a16="http://schemas.microsoft.com/office/drawing/2014/main" id="{5EFD2AD7-EC84-4671-B65E-E3ADFCDD0EC7}"/>
+                <a16:creationId xmlns:a16="http://schemas.microsoft.com/office/drawing/2014/main" id="{61479FD3-05D4-4FC6-AE94-CA5EE47EF17F}"/>
               </a:ext>
             </a:extLst>
           </p:cNvPr>
@@ -10903,7 +10699,7 @@
                 <a:ea typeface="Noto Sans SC"/>
                 <a:cs typeface="Noto Sans SC"/>
               </a:rPr>
-              <a:t>海外家庭版：在验证后补语言、支付、售后</a:t>
+              <a:t>海外家庭版本：逐步完善语言、支付与当地</a:t>
             </a:r>
           </a:p>
           <a:p xmlns:a="http://schemas.openxmlformats.org/drawingml/2006/main">
@@ -10926,7 +10722,7 @@
                 <a:ea typeface="Noto Sans SC"/>
                 <a:cs typeface="Noto Sans SC"/>
               </a:rPr>
-              <a:t>与当地交付。</a:t>
+              <a:t>服务。</a:t>
             </a:r>
           </a:p>
         </p:txBody>
@@ -10936,7 +10732,7 @@
           <p:cNvPr id="11" name="col-1-2">
             <a:extLst xmlns:a="http://schemas.openxmlformats.org/drawingml/2006/main">
               <a:ext uri="{FF2B5EF4-FFF2-40B4-BE49-F238E27FC236}">
-                <a16:creationId xmlns:a16="http://schemas.microsoft.com/office/drawing/2014/main" id="{AADEDAFC-6315-4C09-A995-BC13B41E411C}"/>
+                <a16:creationId xmlns:a16="http://schemas.microsoft.com/office/drawing/2014/main" id="{95C0FBF0-FE77-404A-A015-0E05F876DB05}"/>
               </a:ext>
             </a:extLst>
           </p:cNvPr>
@@ -10994,7 +10790,7 @@
                 <a:ea typeface="Noto Sans SC"/>
                 <a:cs typeface="Noto Sans SC"/>
               </a:rPr>
-              <a:t>先验证需求，再决定是否拆成独立 SKU；不</a:t>
+              <a:t>独立相框作为首版方向，灯座构型保留为后</a:t>
             </a:r>
           </a:p>
           <a:p xmlns:a="http://schemas.openxmlformats.org/drawingml/2006/main">
@@ -11017,7 +10813,7 @@
                 <a:ea typeface="Noto Sans SC"/>
                 <a:cs typeface="Noto Sans SC"/>
               </a:rPr>
-              <a:t>同时开多套模具。</a:t>
+              <a:t>续选项。</a:t>
             </a:r>
           </a:p>
         </p:txBody>
@@ -11027,7 +10823,7 @@
           <p:cNvPr id="12" name="takeaway">
             <a:extLst xmlns:a="http://schemas.openxmlformats.org/drawingml/2006/main">
               <a:ext uri="{FF2B5EF4-FFF2-40B4-BE49-F238E27FC236}">
-                <a16:creationId xmlns:a16="http://schemas.microsoft.com/office/drawing/2014/main" id="{33D4123E-E9A1-43F2-9374-D78AB510A9C0}"/>
+                <a16:creationId xmlns:a16="http://schemas.microsoft.com/office/drawing/2014/main" id="{6E5D252E-B304-4484-8465-0BB5AA42FFC5}"/>
               </a:ext>
             </a:extLst>
           </p:cNvPr>
@@ -11085,7 +10881,7 @@
                 <a:ea typeface="Noto Sans SC"/>
                 <a:cs typeface="Noto Sans SC"/>
               </a:rPr>
-              <a:t>这次讨论产品扩展方向，不承诺各版本已经完成或具备量产条件。</a:t>
+              <a:t>现有外观方案用于工程评审，具体器件与量产配置随验证确定。</a:t>
             </a:r>
           </a:p>
         </p:txBody>
@@ -11095,7 +10891,7 @@
           <p:cNvPr id="13" name="page">
             <a:extLst xmlns:a="http://schemas.openxmlformats.org/drawingml/2006/main">
               <a:ext uri="{FF2B5EF4-FFF2-40B4-BE49-F238E27FC236}">
-                <a16:creationId xmlns:a16="http://schemas.microsoft.com/office/drawing/2014/main" id="{9818E71F-1FB1-433E-A05E-666A6CCC0918}"/>
+                <a16:creationId xmlns:a16="http://schemas.microsoft.com/office/drawing/2014/main" id="{941ACF69-82FC-4B50-8306-D9534E666B56}"/>
               </a:ext>
             </a:extLst>
           </p:cNvPr>
@@ -11163,7 +10959,7 @@
           <p:cNvPr id="14" name="source-label">
             <a:extLst xmlns:a="http://schemas.openxmlformats.org/drawingml/2006/main">
               <a:ext uri="{FF2B5EF4-FFF2-40B4-BE49-F238E27FC236}">
-                <a16:creationId xmlns:a16="http://schemas.microsoft.com/office/drawing/2014/main" id="{9870A774-817E-4292-A6A9-83125BE5B823}"/>
+                <a16:creationId xmlns:a16="http://schemas.microsoft.com/office/drawing/2014/main" id="{5D3F8192-E034-4F86-B6D0-2888C9643247}"/>
               </a:ext>
             </a:extLst>
           </p:cNvPr>
@@ -11228,10 +11024,10 @@
       </p:sp>
       <p:sp>
         <p:nvSpPr>
-          <p:cNvPr id="15" name="source-U3">
-            <a:extLst xmlns:a="http://schemas.openxmlformats.org/drawingml/2006/main">
-              <a:ext uri="{FF2B5EF4-FFF2-40B4-BE49-F238E27FC236}">
-                <a16:creationId xmlns:a16="http://schemas.microsoft.com/office/drawing/2014/main" id="{7B0FBD5F-B17F-4480-B5BA-9E86B67F56CC}"/>
+          <p:cNvPr id="15" name="source-D1">
+            <a:extLst xmlns:a="http://schemas.openxmlformats.org/drawingml/2006/main">
+              <a:ext uri="{FF2B5EF4-FFF2-40B4-BE49-F238E27FC236}">
+                <a16:creationId xmlns:a16="http://schemas.microsoft.com/office/drawing/2014/main" id="{C509BC81-BDEB-4809-AAB5-3F2B07E6CEC3}"/>
               </a:ext>
             </a:extLst>
           </p:cNvPr>
@@ -11289,6 +11085,74 @@
                 <a:ea typeface="Noto Sans SC"/>
                 <a:cs typeface="Noto Sans SC"/>
               </a:rPr>
+              <a:t>D1</a:t>
+            </a:r>
+          </a:p>
+        </p:txBody>
+      </p:sp>
+      <p:sp>
+        <p:nvSpPr>
+          <p:cNvPr id="16" name="source-U3">
+            <a:extLst xmlns:a="http://schemas.openxmlformats.org/drawingml/2006/main">
+              <a:ext uri="{FF2B5EF4-FFF2-40B4-BE49-F238E27FC236}">
+                <a16:creationId xmlns:a16="http://schemas.microsoft.com/office/drawing/2014/main" id="{156A309E-7B34-4868-A3A4-4047F2A9AFFA}"/>
+              </a:ext>
+            </a:extLst>
+          </p:cNvPr>
+          <p:cNvSpPr>
+            <a:spLocks xmlns:a="http://schemas.openxmlformats.org/drawingml/2006/main" noGrp="1"/>
+          </p:cNvSpPr>
+          <p:nvPr/>
+        </p:nvSpPr>
+        <p:spPr>
+          <a:xfrm xmlns:a="http://schemas.openxmlformats.org/drawingml/2006/main">
+            <a:off x="1657350" y="6457950"/>
+            <a:ext cx="647700" cy="190500"/>
+          </a:xfrm>
+          <a:prstGeom xmlns:a="http://schemas.openxmlformats.org/drawingml/2006/main" prst="rect">
+            <a:avLst/>
+          </a:prstGeom>
+          <a:noFill xmlns:a="http://schemas.openxmlformats.org/drawingml/2006/main"/>
+          <a:ln xmlns:a="http://schemas.openxmlformats.org/drawingml/2006/main" w="0">
+            <a:noFill/>
+          </a:ln>
+        </p:spPr>
+        <p:txBody>
+          <a:bodyPr xmlns:a="http://schemas.openxmlformats.org/drawingml/2006/main" wrap="square" lIns="0" tIns="0" rIns="0" bIns="0" anchor="t">
+            <a:noAutofit/>
+          </a:bodyPr>
+          <a:lstStyle xmlns:a="http://schemas.openxmlformats.org/drawingml/2006/main">
+            <a:defPPr>
+              <a:defRPr sz="1050" b="0">
+                <a:solidFill>
+                  <a:srgbClr val="197780"/>
+                </a:solidFill>
+                <a:latin typeface="Noto Sans SC"/>
+                <a:ea typeface="Noto Sans SC"/>
+                <a:cs typeface="Noto Sans SC"/>
+              </a:defRPr>
+            </a:defPPr>
+          </a:lstStyle>
+          <a:p xmlns:a="http://schemas.openxmlformats.org/drawingml/2006/main">
+            <a:pPr>
+              <a:defRPr sz="1050" b="0">
+                <a:solidFill>
+                  <a:srgbClr val="197780"/>
+                </a:solidFill>
+                <a:latin typeface="Noto Sans SC"/>
+                <a:ea typeface="Noto Sans SC"/>
+                <a:cs typeface="Noto Sans SC"/>
+              </a:defRPr>
+            </a:pPr>
+            <a:r>
+              <a:rPr sz="1050" b="0">
+                <a:solidFill>
+                  <a:srgbClr val="197780"/>
+                </a:solidFill>
+                <a:latin typeface="Noto Sans SC"/>
+                <a:ea typeface="Noto Sans SC"/>
+                <a:cs typeface="Noto Sans SC"/>
+              </a:rPr>
               <a:t>U3</a:t>
             </a:r>
           </a:p>
@@ -11297,7 +11161,7 @@
     </p:spTree>
     <p:extLst>
       <p:ext uri="{BB962C8B-B14F-4D97-AF65-F5344CB8AC3E}">
-        <p14:creationId xmlns:p14="http://schemas.microsoft.com/office/powerpoint/2010/main" val="247344517"/>
+        <p14:creationId xmlns:p14="http://schemas.microsoft.com/office/powerpoint/2010/main" val="1470077868"/>
       </p:ext>
     </p:extLst>
   </p:cSld>
@@ -11328,7 +11192,7 @@
           <p:cNvPr id="9" name="section">
             <a:extLst xmlns:a="http://schemas.openxmlformats.org/drawingml/2006/main">
               <a:ext uri="{FF2B5EF4-FFF2-40B4-BE49-F238E27FC236}">
-                <a16:creationId xmlns:a16="http://schemas.microsoft.com/office/drawing/2014/main" id="{DF70C298-6AEB-4009-8624-86002F3C2AB0}"/>
+                <a16:creationId xmlns:a16="http://schemas.microsoft.com/office/drawing/2014/main" id="{BD4E06D1-AB47-42B3-BE8E-8187DD1A0B34}"/>
               </a:ext>
             </a:extLst>
           </p:cNvPr>
@@ -11396,7 +11260,7 @@
           <p:cNvPr id="2" name="title">
             <a:extLst xmlns:a="http://schemas.openxmlformats.org/drawingml/2006/main">
               <a:ext uri="{FF2B5EF4-FFF2-40B4-BE49-F238E27FC236}">
-                <a16:creationId xmlns:a16="http://schemas.microsoft.com/office/drawing/2014/main" id="{1890A67E-D16F-4683-B200-5208AB9E7556}"/>
+                <a16:creationId xmlns:a16="http://schemas.microsoft.com/office/drawing/2014/main" id="{16A82F4B-2AA0-47D5-8B0E-F5F965295588}"/>
               </a:ext>
             </a:extLst>
           </p:cNvPr>
@@ -11454,7 +11318,7 @@
                 <a:ea typeface="Noto Sans SC"/>
                 <a:cs typeface="Noto Sans SC"/>
               </a:rPr>
-              <a:t>从今天往后排的阶段计划</a:t>
+              <a:t>阶段计划</a:t>
             </a:r>
           </a:p>
         </p:txBody>
@@ -11464,7 +11328,7 @@
           <p:cNvPr id="3" name="lead">
             <a:extLst xmlns:a="http://schemas.openxmlformats.org/drawingml/2006/main">
               <a:ext uri="{FF2B5EF4-FFF2-40B4-BE49-F238E27FC236}">
-                <a16:creationId xmlns:a16="http://schemas.microsoft.com/office/drawing/2014/main" id="{930998DA-6800-4C4D-825B-68618A17CECA}"/>
+                <a16:creationId xmlns:a16="http://schemas.microsoft.com/office/drawing/2014/main" id="{759B2985-529D-4209-B1DB-171C8EF78D33}"/>
               </a:ext>
             </a:extLst>
           </p:cNvPr>
@@ -11522,7 +11386,7 @@
                 <a:ea typeface="Noto Sans SC"/>
                 <a:cs typeface="Noto Sans SC"/>
               </a:rPr>
-              <a:t>建议排期；以前一阶段验收通过为进入条件，交付日期待工厂确认。</a:t>
+              <a:t>以 2026 年 10 月 13 日为起点，按阶段成果滚动调整。</a:t>
             </a:r>
           </a:p>
         </p:txBody>
@@ -11532,7 +11396,7 @@
           <p:cNvPr id="4" name="">
             <a:extLst xmlns:a="http://schemas.openxmlformats.org/drawingml/2006/main">
               <a:ext uri="{FF2B5EF4-FFF2-40B4-BE49-F238E27FC236}">
-                <a16:creationId xmlns:a16="http://schemas.microsoft.com/office/drawing/2014/main" id="{0473EE56-DA0A-4AE7-94AC-F0F9F79B35E9}"/>
+                <a16:creationId xmlns:a16="http://schemas.microsoft.com/office/drawing/2014/main" id="{F840FF87-28F3-4B36-B316-672B1632BE1E}"/>
               </a:ext>
             </a:extLst>
           </p:cNvPr>
@@ -12106,7 +11970,7 @@
           <p:cNvPr id="5" name="takeaway">
             <a:extLst xmlns:a="http://schemas.openxmlformats.org/drawingml/2006/main">
               <a:ext uri="{FF2B5EF4-FFF2-40B4-BE49-F238E27FC236}">
-                <a16:creationId xmlns:a16="http://schemas.microsoft.com/office/drawing/2014/main" id="{C61592FE-F472-47F8-A0A0-B75D165595F8}"/>
+                <a16:creationId xmlns:a16="http://schemas.microsoft.com/office/drawing/2014/main" id="{CC7D243E-0A62-40D2-99BC-B1DAB77E069C}"/>
               </a:ext>
             </a:extLst>
           </p:cNvPr>
@@ -12164,7 +12028,7 @@
                 <a:ea typeface="Noto Sans SC"/>
                 <a:cs typeface="Noto Sans SC"/>
               </a:rPr>
-              <a:t>视频记录和海外意向测试可并行；定制开模与批量下单安排在设计收敛之后。</a:t>
+              <a:t>视频记录与海外意向测试可并行开展，生产交期结合工程进度和工厂排期确认。</a:t>
             </a:r>
           </a:p>
         </p:txBody>
@@ -12174,7 +12038,7 @@
           <p:cNvPr id="6" name="page">
             <a:extLst xmlns:a="http://schemas.openxmlformats.org/drawingml/2006/main">
               <a:ext uri="{FF2B5EF4-FFF2-40B4-BE49-F238E27FC236}">
-                <a16:creationId xmlns:a16="http://schemas.microsoft.com/office/drawing/2014/main" id="{DA9AF0B4-2FE8-4EAD-B018-4DF88600B742}"/>
+                <a16:creationId xmlns:a16="http://schemas.microsoft.com/office/drawing/2014/main" id="{65917259-DD4F-49C1-87F3-3481FECD48BE}"/>
               </a:ext>
             </a:extLst>
           </p:cNvPr>
@@ -12242,7 +12106,7 @@
           <p:cNvPr id="7" name="source-label">
             <a:extLst xmlns:a="http://schemas.openxmlformats.org/drawingml/2006/main">
               <a:ext uri="{FF2B5EF4-FFF2-40B4-BE49-F238E27FC236}">
-                <a16:creationId xmlns:a16="http://schemas.microsoft.com/office/drawing/2014/main" id="{B0759090-6654-4D34-8E35-5896EEDA4FF6}"/>
+                <a16:creationId xmlns:a16="http://schemas.microsoft.com/office/drawing/2014/main" id="{71F4F86C-0DAA-431D-BBD3-1380B0C846A2}"/>
               </a:ext>
             </a:extLst>
           </p:cNvPr>
@@ -12310,7 +12174,7 @@
           <p:cNvPr id="8" name="source-U3">
             <a:extLst xmlns:a="http://schemas.openxmlformats.org/drawingml/2006/main">
               <a:ext uri="{FF2B5EF4-FFF2-40B4-BE49-F238E27FC236}">
-                <a16:creationId xmlns:a16="http://schemas.microsoft.com/office/drawing/2014/main" id="{20C7A695-2E85-40AD-84A3-30644E92D18D}"/>
+                <a16:creationId xmlns:a16="http://schemas.microsoft.com/office/drawing/2014/main" id="{B9D90EA2-4169-4056-A4D6-823676F6B4C5}"/>
               </a:ext>
             </a:extLst>
           </p:cNvPr>
@@ -12376,7 +12240,7 @@
     </p:spTree>
     <p:extLst>
       <p:ext uri="{BB962C8B-B14F-4D97-AF65-F5344CB8AC3E}">
-        <p14:creationId xmlns:p14="http://schemas.microsoft.com/office/powerpoint/2010/main" val="322567093"/>
+        <p14:creationId xmlns:p14="http://schemas.microsoft.com/office/powerpoint/2010/main" val="296259975"/>
       </p:ext>
     </p:extLst>
   </p:cSld>
@@ -12407,7 +12271,7 @@
           <p:cNvPr id="16" name="section">
             <a:extLst xmlns:a="http://schemas.openxmlformats.org/drawingml/2006/main">
               <a:ext uri="{FF2B5EF4-FFF2-40B4-BE49-F238E27FC236}">
-                <a16:creationId xmlns:a16="http://schemas.microsoft.com/office/drawing/2014/main" id="{E2379AF4-C046-4501-B74E-A031F11D2AB8}"/>
+                <a16:creationId xmlns:a16="http://schemas.microsoft.com/office/drawing/2014/main" id="{796C3C94-15B3-4177-8939-23EE450FF9B7}"/>
               </a:ext>
             </a:extLst>
           </p:cNvPr>
@@ -12475,7 +12339,7 @@
           <p:cNvPr id="2" name="title">
             <a:extLst xmlns:a="http://schemas.openxmlformats.org/drawingml/2006/main">
               <a:ext uri="{FF2B5EF4-FFF2-40B4-BE49-F238E27FC236}">
-                <a16:creationId xmlns:a16="http://schemas.microsoft.com/office/drawing/2014/main" id="{A60476F9-2FEC-4A7A-8E4F-DD2B98BC43F9}"/>
+                <a16:creationId xmlns:a16="http://schemas.microsoft.com/office/drawing/2014/main" id="{4855795E-8C12-4B67-B193-7014D2DF126C}"/>
               </a:ext>
             </a:extLst>
           </p:cNvPr>
@@ -12533,7 +12397,7 @@
                 <a:ea typeface="Noto Sans SC"/>
                 <a:cs typeface="Noto Sans SC"/>
               </a:rPr>
-              <a:t>市场方案 A｜国内 C 端预售</a:t>
+              <a:t>国内预售路径</a:t>
             </a:r>
           </a:p>
         </p:txBody>
@@ -12543,7 +12407,7 @@
           <p:cNvPr id="3" name="lead">
             <a:extLst xmlns:a="http://schemas.openxmlformats.org/drawingml/2006/main">
               <a:ext uri="{FF2B5EF4-FFF2-40B4-BE49-F238E27FC236}">
-                <a16:creationId xmlns:a16="http://schemas.microsoft.com/office/drawing/2014/main" id="{CF979B8F-2FC4-49E3-BAF1-8BA0D50FBEA9}"/>
+                <a16:creationId xmlns:a16="http://schemas.microsoft.com/office/drawing/2014/main" id="{C94E0810-E90E-404F-9C71-00C055B2C54B}"/>
               </a:ext>
             </a:extLst>
           </p:cNvPr>
@@ -12601,7 +12465,7 @@
                 <a:ea typeface="Noto Sans SC"/>
                 <a:cs typeface="Noto Sans SC"/>
               </a:rPr>
-              <a:t>真实演示吸引关注，意向登记检验兴趣，付费预售检验购买承诺。</a:t>
+              <a:t>以内容和试用积累意向，以付费订单评估首批生产规模。</a:t>
             </a:r>
           </a:p>
         </p:txBody>
@@ -12611,7 +12475,7 @@
           <p:cNvPr id="4" name="row-label-0">
             <a:extLst xmlns:a="http://schemas.openxmlformats.org/drawingml/2006/main">
               <a:ext uri="{FF2B5EF4-FFF2-40B4-BE49-F238E27FC236}">
-                <a16:creationId xmlns:a16="http://schemas.microsoft.com/office/drawing/2014/main" id="{B6663003-DEB6-4324-9813-F85389EB5891}"/>
+                <a16:creationId xmlns:a16="http://schemas.microsoft.com/office/drawing/2014/main" id="{865D20A8-8C9D-45CA-B143-61100D7BF2AB}"/>
               </a:ext>
             </a:extLst>
           </p:cNvPr>
@@ -12669,7 +12533,7 @@
                 <a:ea typeface="Noto Sans SC"/>
                 <a:cs typeface="Noto Sans SC"/>
               </a:rPr>
-              <a:t>先积累意向</a:t>
+              <a:t>内容与意向</a:t>
             </a:r>
           </a:p>
         </p:txBody>
@@ -12679,7 +12543,7 @@
           <p:cNvPr id="5" name="row-body-0">
             <a:extLst xmlns:a="http://schemas.openxmlformats.org/drawingml/2006/main">
               <a:ext uri="{FF2B5EF4-FFF2-40B4-BE49-F238E27FC236}">
-                <a16:creationId xmlns:a16="http://schemas.microsoft.com/office/drawing/2014/main" id="{8F6B4ADC-090A-432C-A8E1-E4CF4E1223E1}"/>
+                <a16:creationId xmlns:a16="http://schemas.microsoft.com/office/drawing/2014/main" id="{D6679EBA-8C5F-4FD5-BD31-7F62FC6786BA}"/>
               </a:ext>
             </a:extLst>
           </p:cNvPr>
@@ -12737,7 +12601,7 @@
                 <a:ea typeface="Noto Sans SC"/>
                 <a:cs typeface="Noto Sans SC"/>
               </a:rPr>
-              <a:t>发布实际使用视频，收集使用场景、价格反馈与联系方式。</a:t>
+              <a:t>发布真实演示，收集使用场景、价格反馈与购买意向。</a:t>
             </a:r>
           </a:p>
         </p:txBody>
@@ -12747,7 +12611,7 @@
           <p:cNvPr id="6" name="row-label-1">
             <a:extLst xmlns:a="http://schemas.openxmlformats.org/drawingml/2006/main">
               <a:ext uri="{FF2B5EF4-FFF2-40B4-BE49-F238E27FC236}">
-                <a16:creationId xmlns:a16="http://schemas.microsoft.com/office/drawing/2014/main" id="{4DB1BCBD-9AAF-4E2D-A2CF-EB1838EF81F9}"/>
+                <a16:creationId xmlns:a16="http://schemas.microsoft.com/office/drawing/2014/main" id="{108AD476-9BB0-4461-90D3-5546F5F4D158}"/>
               </a:ext>
             </a:extLst>
           </p:cNvPr>
@@ -12805,7 +12669,7 @@
                 <a:ea typeface="Noto Sans SC"/>
                 <a:cs typeface="Noto Sans SC"/>
               </a:rPr>
-              <a:t>再开放预售</a:t>
+              <a:t>渠道准备</a:t>
             </a:r>
           </a:p>
         </p:txBody>
@@ -12815,7 +12679,7 @@
           <p:cNvPr id="7" name="row-body-1">
             <a:extLst xmlns:a="http://schemas.openxmlformats.org/drawingml/2006/main">
               <a:ext uri="{FF2B5EF4-FFF2-40B4-BE49-F238E27FC236}">
-                <a16:creationId xmlns:a16="http://schemas.microsoft.com/office/drawing/2014/main" id="{E776EC66-1F32-4F33-812F-9F7C4D4DB3CC}"/>
+                <a16:creationId xmlns:a16="http://schemas.microsoft.com/office/drawing/2014/main" id="{B240E0AB-0D72-4DEB-A76F-630F1AE27B42}"/>
               </a:ext>
             </a:extLst>
           </p:cNvPr>
@@ -12873,7 +12737,7 @@
                 <a:ea typeface="Noto Sans SC"/>
                 <a:cs typeface="Noto Sans SC"/>
               </a:rPr>
-              <a:t>样机与交付方案明确后，上架国内可用的预售／众筹平台。</a:t>
+              <a:t>评估国内预售平台及品牌授权店，明确收款、结算与售后安排。</a:t>
             </a:r>
           </a:p>
         </p:txBody>
@@ -12883,7 +12747,7 @@
           <p:cNvPr id="8" name="row-label-2">
             <a:extLst xmlns:a="http://schemas.openxmlformats.org/drawingml/2006/main">
               <a:ext uri="{FF2B5EF4-FFF2-40B4-BE49-F238E27FC236}">
-                <a16:creationId xmlns:a16="http://schemas.microsoft.com/office/drawing/2014/main" id="{B67D34FA-D570-4D54-B820-9F19A2A09C4E}"/>
+                <a16:creationId xmlns:a16="http://schemas.microsoft.com/office/drawing/2014/main" id="{22A59177-CF08-4BDF-8916-F015CD46106B}"/>
               </a:ext>
             </a:extLst>
           </p:cNvPr>
@@ -12941,7 +12805,7 @@
                 <a:ea typeface="Noto Sans SC"/>
                 <a:cs typeface="Noto Sans SC"/>
               </a:rPr>
-              <a:t>授权店路径</a:t>
+              <a:t>小规模预售</a:t>
             </a:r>
           </a:p>
         </p:txBody>
@@ -12951,7 +12815,7 @@
           <p:cNvPr id="9" name="row-body-2">
             <a:extLst xmlns:a="http://schemas.openxmlformats.org/drawingml/2006/main">
               <a:ext uri="{FF2B5EF4-FFF2-40B4-BE49-F238E27FC236}">
-                <a16:creationId xmlns:a16="http://schemas.microsoft.com/office/drawing/2014/main" id="{E6EF6ABE-3E0D-4F5A-B116-FA67B5474B85}"/>
+                <a16:creationId xmlns:a16="http://schemas.microsoft.com/office/drawing/2014/main" id="{5B8710F1-8A16-4CB8-BDBC-528CAA3B1592}"/>
               </a:ext>
             </a:extLst>
           </p:cNvPr>
@@ -13009,7 +12873,7 @@
                 <a:ea typeface="Noto Sans SC"/>
                 <a:cs typeface="Noto Sans SC"/>
               </a:rPr>
-              <a:t>若影石同意授权，确认品牌、店铺运营、收款与售后各由谁负责。</a:t>
+              <a:t>在样机、定价和交付方案明确后，启动限量预售。</a:t>
             </a:r>
           </a:p>
         </p:txBody>
@@ -13019,7 +12883,7 @@
           <p:cNvPr id="10" name="row-label-3">
             <a:extLst xmlns:a="http://schemas.openxmlformats.org/drawingml/2006/main">
               <a:ext uri="{FF2B5EF4-FFF2-40B4-BE49-F238E27FC236}">
-                <a16:creationId xmlns:a16="http://schemas.microsoft.com/office/drawing/2014/main" id="{A0490B86-D2D5-4C1E-BBDD-D4874D5D2318}"/>
+                <a16:creationId xmlns:a16="http://schemas.microsoft.com/office/drawing/2014/main" id="{81EC9D78-9AF9-4FA1-B55E-A94A3330F0CB}"/>
               </a:ext>
             </a:extLst>
           </p:cNvPr>
@@ -13077,7 +12941,7 @@
                 <a:ea typeface="Noto Sans SC"/>
                 <a:cs typeface="Noto Sans SC"/>
               </a:rPr>
-              <a:t>依据订单生产</a:t>
+              <a:t>生产与交付</a:t>
             </a:r>
           </a:p>
         </p:txBody>
@@ -13087,7 +12951,7 @@
           <p:cNvPr id="11" name="row-body-3">
             <a:extLst xmlns:a="http://schemas.openxmlformats.org/drawingml/2006/main">
               <a:ext uri="{FF2B5EF4-FFF2-40B4-BE49-F238E27FC236}">
-                <a16:creationId xmlns:a16="http://schemas.microsoft.com/office/drawing/2014/main" id="{3943A515-9541-4240-9F8C-F19E4667C111}"/>
+                <a16:creationId xmlns:a16="http://schemas.microsoft.com/office/drawing/2014/main" id="{B4C43423-EA58-4391-87DA-3DE99AA27FE0}"/>
               </a:ext>
             </a:extLst>
           </p:cNvPr>
@@ -13145,7 +13009,7 @@
                 <a:ea typeface="Noto Sans SC"/>
                 <a:cs typeface="Noto Sans SC"/>
               </a:rPr>
-              <a:t>按有效订单、退款情况和实际可用资金，决定首批数量。</a:t>
+              <a:t>依据有效订单和可用资金安排首批数量，完成质检与交付。</a:t>
             </a:r>
           </a:p>
         </p:txBody>
@@ -13155,7 +13019,7 @@
           <p:cNvPr id="12" name="takeaway">
             <a:extLst xmlns:a="http://schemas.openxmlformats.org/drawingml/2006/main">
               <a:ext uri="{FF2B5EF4-FFF2-40B4-BE49-F238E27FC236}">
-                <a16:creationId xmlns:a16="http://schemas.microsoft.com/office/drawing/2014/main" id="{7220E958-AE5B-4447-8D47-23FBB33B3772}"/>
+                <a16:creationId xmlns:a16="http://schemas.microsoft.com/office/drawing/2014/main" id="{BA637964-C463-4E98-B904-F957AC19F5CA}"/>
               </a:ext>
             </a:extLst>
           </p:cNvPr>
@@ -13213,7 +13077,7 @@
                 <a:ea typeface="Noto Sans SC"/>
                 <a:cs typeface="Noto Sans SC"/>
               </a:rPr>
-              <a:t>先核验平台准入、费用与结算时间；订单预付款与股权投资分开核算。</a:t>
+              <a:t>预售形成订单与预付款，股权投资按独立的融资安排推进。</a:t>
             </a:r>
           </a:p>
         </p:txBody>
@@ -13223,7 +13087,7 @@
           <p:cNvPr id="13" name="page">
             <a:extLst xmlns:a="http://schemas.openxmlformats.org/drawingml/2006/main">
               <a:ext uri="{FF2B5EF4-FFF2-40B4-BE49-F238E27FC236}">
-                <a16:creationId xmlns:a16="http://schemas.microsoft.com/office/drawing/2014/main" id="{E8776B96-F608-47AE-B69D-C876C8B94BD0}"/>
+                <a16:creationId xmlns:a16="http://schemas.microsoft.com/office/drawing/2014/main" id="{AB280D51-B706-4FA0-8B5E-46CFC9C1D2E6}"/>
               </a:ext>
             </a:extLst>
           </p:cNvPr>
@@ -13291,7 +13155,7 @@
           <p:cNvPr id="14" name="source-label">
             <a:extLst xmlns:a="http://schemas.openxmlformats.org/drawingml/2006/main">
               <a:ext uri="{FF2B5EF4-FFF2-40B4-BE49-F238E27FC236}">
-                <a16:creationId xmlns:a16="http://schemas.microsoft.com/office/drawing/2014/main" id="{2AA17C6C-8B18-45A6-AE07-40DDB3CF47A1}"/>
+                <a16:creationId xmlns:a16="http://schemas.microsoft.com/office/drawing/2014/main" id="{40DDB494-5D97-4B81-A7D8-AB487E4E7A25}"/>
               </a:ext>
             </a:extLst>
           </p:cNvPr>
@@ -13359,7 +13223,7 @@
           <p:cNvPr id="15" name="source-U3">
             <a:extLst xmlns:a="http://schemas.openxmlformats.org/drawingml/2006/main">
               <a:ext uri="{FF2B5EF4-FFF2-40B4-BE49-F238E27FC236}">
-                <a16:creationId xmlns:a16="http://schemas.microsoft.com/office/drawing/2014/main" id="{673B9FAD-8D3E-45C6-821C-B6DD885A152D}"/>
+                <a16:creationId xmlns:a16="http://schemas.microsoft.com/office/drawing/2014/main" id="{FF7260E9-7FAE-4A9A-8611-A492A939E46D}"/>
               </a:ext>
             </a:extLst>
           </p:cNvPr>
@@ -13425,7 +13289,7 @@
     </p:spTree>
     <p:extLst>
       <p:ext uri="{BB962C8B-B14F-4D97-AF65-F5344CB8AC3E}">
-        <p14:creationId xmlns:p14="http://schemas.microsoft.com/office/powerpoint/2010/main" val="1109408702"/>
+        <p14:creationId xmlns:p14="http://schemas.microsoft.com/office/powerpoint/2010/main" val="722909657"/>
       </p:ext>
     </p:extLst>
   </p:cSld>
@@ -13456,7 +13320,7 @@
           <p:cNvPr id="16" name="section">
             <a:extLst xmlns:a="http://schemas.openxmlformats.org/drawingml/2006/main">
               <a:ext uri="{FF2B5EF4-FFF2-40B4-BE49-F238E27FC236}">
-                <a16:creationId xmlns:a16="http://schemas.microsoft.com/office/drawing/2014/main" id="{C661F402-7282-4373-AAD8-C7852A13A812}"/>
+                <a16:creationId xmlns:a16="http://schemas.microsoft.com/office/drawing/2014/main" id="{6021E59E-3CD7-44F4-960F-9D5C35B5D1E2}"/>
               </a:ext>
             </a:extLst>
           </p:cNvPr>
@@ -13524,7 +13388,7 @@
           <p:cNvPr id="2" name="title">
             <a:extLst xmlns:a="http://schemas.openxmlformats.org/drawingml/2006/main">
               <a:ext uri="{FF2B5EF4-FFF2-40B4-BE49-F238E27FC236}">
-                <a16:creationId xmlns:a16="http://schemas.microsoft.com/office/drawing/2014/main" id="{574F09CB-EAF4-4ACB-9650-31FE51B0AAF9}"/>
+                <a16:creationId xmlns:a16="http://schemas.microsoft.com/office/drawing/2014/main" id="{6430AD99-A7FD-4026-9985-D5C56FF060AE}"/>
               </a:ext>
             </a:extLst>
           </p:cNvPr>
@@ -13582,7 +13446,7 @@
                 <a:ea typeface="Noto Sans SC"/>
                 <a:cs typeface="Noto Sans SC"/>
               </a:rPr>
-              <a:t>市场方案 B｜公益采购与试点</a:t>
+              <a:t>公益采购与试点</a:t>
             </a:r>
           </a:p>
         </p:txBody>
@@ -13592,7 +13456,7 @@
           <p:cNvPr id="3" name="lead">
             <a:extLst xmlns:a="http://schemas.openxmlformats.org/drawingml/2006/main">
               <a:ext uri="{FF2B5EF4-FFF2-40B4-BE49-F238E27FC236}">
-                <a16:creationId xmlns:a16="http://schemas.microsoft.com/office/drawing/2014/main" id="{1E80F159-A768-40F5-8182-BA543F174D60}"/>
+                <a16:creationId xmlns:a16="http://schemas.microsoft.com/office/drawing/2014/main" id="{BB4DED6F-8351-4C7B-82A4-731B80FF94BC}"/>
               </a:ext>
             </a:extLst>
           </p:cNvPr>
@@ -13650,7 +13514,7 @@
                 <a:ea typeface="Noto Sans SC"/>
                 <a:cs typeface="Noto Sans SC"/>
               </a:rPr>
-              <a:t>资金方按约定成本采购，合作组织协助定向赠送与使用支持。</a:t>
+              <a:t>由公益资金方或企业采购设备，合作组织协助定向赠送与服务。</a:t>
             </a:r>
           </a:p>
         </p:txBody>
@@ -13660,7 +13524,7 @@
           <p:cNvPr id="4" name="col-0-title">
             <a:extLst xmlns:a="http://schemas.openxmlformats.org/drawingml/2006/main">
               <a:ext uri="{FF2B5EF4-FFF2-40B4-BE49-F238E27FC236}">
-                <a16:creationId xmlns:a16="http://schemas.microsoft.com/office/drawing/2014/main" id="{4C70F19D-8509-437B-AECF-35639243E7E6}"/>
+                <a16:creationId xmlns:a16="http://schemas.microsoft.com/office/drawing/2014/main" id="{63B7A017-B7DC-4878-ADB0-4CF4528E7333}"/>
               </a:ext>
             </a:extLst>
           </p:cNvPr>
@@ -13718,7 +13582,7 @@
                 <a:ea typeface="Noto Sans SC"/>
                 <a:cs typeface="Noto Sans SC"/>
               </a:rPr>
-              <a:t>合作怎样运转</a:t>
+              <a:t>实施方式</a:t>
             </a:r>
           </a:p>
         </p:txBody>
@@ -13728,7 +13592,7 @@
           <p:cNvPr id="5" name="col-0-0">
             <a:extLst xmlns:a="http://schemas.openxmlformats.org/drawingml/2006/main">
               <a:ext uri="{FF2B5EF4-FFF2-40B4-BE49-F238E27FC236}">
-                <a16:creationId xmlns:a16="http://schemas.microsoft.com/office/drawing/2014/main" id="{94DC654B-060C-4A0E-9C64-4703AFD9004D}"/>
+                <a16:creationId xmlns:a16="http://schemas.microsoft.com/office/drawing/2014/main" id="{C24C92A6-F93E-4A3D-8CE7-491651BDD0B6}"/>
               </a:ext>
             </a:extLst>
           </p:cNvPr>
@@ -13786,30 +13650,7 @@
                 <a:ea typeface="Noto Sans SC"/>
                 <a:cs typeface="Noto Sans SC"/>
               </a:rPr>
-              <a:t>对接公益机构、企业公益预算方或社区合作</a:t>
-            </a:r>
-          </a:p>
-          <a:p xmlns:a="http://schemas.openxmlformats.org/drawingml/2006/main">
-            <a:pPr>
-              <a:defRPr sz="1875" b="0">
-                <a:solidFill>
-                  <a:srgbClr val="17364E"/>
-                </a:solidFill>
-                <a:latin typeface="Noto Sans SC"/>
-                <a:ea typeface="Noto Sans SC"/>
-                <a:cs typeface="Noto Sans SC"/>
-              </a:defRPr>
-            </a:pPr>
-            <a:r>
-              <a:rPr sz="1875" b="0">
-                <a:solidFill>
-                  <a:srgbClr val="17364E"/>
-                </a:solidFill>
-                <a:latin typeface="Noto Sans SC"/>
-                <a:ea typeface="Noto Sans SC"/>
-                <a:cs typeface="Noto Sans SC"/>
-              </a:rPr>
-              <a:t>方。</a:t>
+              <a:t>对接公益机构、企业公益项目或社区。</a:t>
             </a:r>
           </a:p>
         </p:txBody>
@@ -13819,7 +13660,7 @@
           <p:cNvPr id="6" name="col-0-1">
             <a:extLst xmlns:a="http://schemas.openxmlformats.org/drawingml/2006/main">
               <a:ext uri="{FF2B5EF4-FFF2-40B4-BE49-F238E27FC236}">
-                <a16:creationId xmlns:a16="http://schemas.microsoft.com/office/drawing/2014/main" id="{C223F2DD-DFEB-4138-90A2-4D8B1B3582EA}"/>
+                <a16:creationId xmlns:a16="http://schemas.microsoft.com/office/drawing/2014/main" id="{1C65FA4D-615C-44A8-8426-A21249C4F2F1}"/>
               </a:ext>
             </a:extLst>
           </p:cNvPr>
@@ -13877,7 +13718,7 @@
                 <a:ea typeface="Noto Sans SC"/>
                 <a:cs typeface="Noto Sans SC"/>
               </a:rPr>
-              <a:t>我们提出设备、安装、服务的完整成本；由</a:t>
+              <a:t>按约定成本核算设备、安装和服务，由资金</a:t>
             </a:r>
           </a:p>
           <a:p xmlns:a="http://schemas.openxmlformats.org/drawingml/2006/main">
@@ -13900,7 +13741,7 @@
                 <a:ea typeface="Noto Sans SC"/>
                 <a:cs typeface="Noto Sans SC"/>
               </a:rPr>
-              <a:t>资金方承担。</a:t>
+              <a:t>方承担采购。</a:t>
             </a:r>
           </a:p>
         </p:txBody>
@@ -13910,7 +13751,7 @@
           <p:cNvPr id="7" name="col-0-2">
             <a:extLst xmlns:a="http://schemas.openxmlformats.org/drawingml/2006/main">
               <a:ext uri="{FF2B5EF4-FFF2-40B4-BE49-F238E27FC236}">
-                <a16:creationId xmlns:a16="http://schemas.microsoft.com/office/drawing/2014/main" id="{B90F2515-207C-4605-917C-02B5BC184909}"/>
+                <a16:creationId xmlns:a16="http://schemas.microsoft.com/office/drawing/2014/main" id="{172C2CA7-B211-4453-9982-D8495E989C98}"/>
               </a:ext>
             </a:extLst>
           </p:cNvPr>
@@ -13968,7 +13809,7 @@
                 <a:ea typeface="Noto Sans SC"/>
                 <a:cs typeface="Noto Sans SC"/>
               </a:rPr>
-              <a:t>合作方组织受赠与使用，我们承担约定的培</a:t>
+              <a:t>团队交付设备，合作组织协调受赠与使用支</a:t>
             </a:r>
           </a:p>
           <a:p xmlns:a="http://schemas.openxmlformats.org/drawingml/2006/main">
@@ -13991,7 +13832,7 @@
                 <a:ea typeface="Noto Sans SC"/>
                 <a:cs typeface="Noto Sans SC"/>
               </a:rPr>
-              <a:t>训与售后。</a:t>
+              <a:t>持。</a:t>
             </a:r>
           </a:p>
         </p:txBody>
@@ -14001,7 +13842,7 @@
           <p:cNvPr id="8" name="col-1-title">
             <a:extLst xmlns:a="http://schemas.openxmlformats.org/drawingml/2006/main">
               <a:ext uri="{FF2B5EF4-FFF2-40B4-BE49-F238E27FC236}">
-                <a16:creationId xmlns:a16="http://schemas.microsoft.com/office/drawing/2014/main" id="{F27AB80C-99A1-4EB7-A2E7-861581DAD474}"/>
+                <a16:creationId xmlns:a16="http://schemas.microsoft.com/office/drawing/2014/main" id="{6FE80115-8E35-45D4-8D51-0BF325F87BC7}"/>
               </a:ext>
             </a:extLst>
           </p:cNvPr>
@@ -14059,7 +13900,7 @@
                 <a:ea typeface="Noto Sans SC"/>
                 <a:cs typeface="Noto Sans SC"/>
               </a:rPr>
-              <a:t>产生什么证据</a:t>
+              <a:t>预期成果</a:t>
             </a:r>
           </a:p>
         </p:txBody>
@@ -14069,7 +13910,7 @@
           <p:cNvPr id="9" name="col-1-0">
             <a:extLst xmlns:a="http://schemas.openxmlformats.org/drawingml/2006/main">
               <a:ext uri="{FF2B5EF4-FFF2-40B4-BE49-F238E27FC236}">
-                <a16:creationId xmlns:a16="http://schemas.microsoft.com/office/drawing/2014/main" id="{677E92DB-80FB-4E7E-8A12-17BD1997D55F}"/>
+                <a16:creationId xmlns:a16="http://schemas.microsoft.com/office/drawing/2014/main" id="{6167E8BB-BBEF-41C7-8113-BEBE90028EA7}"/>
               </a:ext>
             </a:extLst>
           </p:cNvPr>
@@ -14127,30 +13968,7 @@
                 <a:ea typeface="Noto Sans SC"/>
                 <a:cs typeface="Noto Sans SC"/>
               </a:rPr>
-              <a:t>观察设备能否改善真实家庭的观看、讲述和</a:t>
-            </a:r>
-          </a:p>
-          <a:p xmlns:a="http://schemas.openxmlformats.org/drawingml/2006/main">
-            <a:pPr>
-              <a:defRPr sz="1875" b="0">
-                <a:solidFill>
-                  <a:srgbClr val="17364E"/>
-                </a:solidFill>
-                <a:latin typeface="Noto Sans SC"/>
-                <a:ea typeface="Noto Sans SC"/>
-                <a:cs typeface="Noto Sans SC"/>
-              </a:defRPr>
-            </a:pPr>
-            <a:r>
-              <a:rPr sz="1875" b="0">
-                <a:solidFill>
-                  <a:srgbClr val="17364E"/>
-                </a:solidFill>
-                <a:latin typeface="Noto Sans SC"/>
-                <a:ea typeface="Noto Sans SC"/>
-                <a:cs typeface="Noto Sans SC"/>
-              </a:rPr>
-              <a:t>沟通体验。</a:t>
+              <a:t>了解真实家庭的观看、讲述和沟通体验。</a:t>
             </a:r>
           </a:p>
         </p:txBody>
@@ -14160,7 +13978,7 @@
           <p:cNvPr id="10" name="col-1-1">
             <a:extLst xmlns:a="http://schemas.openxmlformats.org/drawingml/2006/main">
               <a:ext uri="{FF2B5EF4-FFF2-40B4-BE49-F238E27FC236}">
-                <a16:creationId xmlns:a16="http://schemas.microsoft.com/office/drawing/2014/main" id="{37951B15-316C-469C-A3D4-C81E949F2ECD}"/>
+                <a16:creationId xmlns:a16="http://schemas.microsoft.com/office/drawing/2014/main" id="{0EC7B727-1011-4B31-A0E5-42DAD186C377}"/>
               </a:ext>
             </a:extLst>
           </p:cNvPr>
@@ -14218,7 +14036,7 @@
                 <a:ea typeface="Noto Sans SC"/>
                 <a:cs typeface="Noto Sans SC"/>
               </a:rPr>
-              <a:t>经当事人同意记录案例；受助不以出镜或宣</a:t>
+              <a:t>经参与者同意，形成可复用的案例与演示内</a:t>
             </a:r>
           </a:p>
           <a:p xmlns:a="http://schemas.openxmlformats.org/drawingml/2006/main">
@@ -14241,7 +14059,7 @@
                 <a:ea typeface="Noto Sans SC"/>
                 <a:cs typeface="Noto Sans SC"/>
               </a:rPr>
-              <a:t>传为条件。</a:t>
+              <a:t>容。</a:t>
             </a:r>
           </a:p>
         </p:txBody>
@@ -14251,7 +14069,7 @@
           <p:cNvPr id="11" name="col-1-2">
             <a:extLst xmlns:a="http://schemas.openxmlformats.org/drawingml/2006/main">
               <a:ext uri="{FF2B5EF4-FFF2-40B4-BE49-F238E27FC236}">
-                <a16:creationId xmlns:a16="http://schemas.microsoft.com/office/drawing/2014/main" id="{4D2707C1-5094-4CC9-8F55-3322B9D30BD0}"/>
+                <a16:creationId xmlns:a16="http://schemas.microsoft.com/office/drawing/2014/main" id="{BB95D6F8-5FEC-479C-BC28-78D6C715E2D8}"/>
               </a:ext>
             </a:extLst>
           </p:cNvPr>
@@ -14309,7 +14127,7 @@
                 <a:ea typeface="Noto Sans SC"/>
                 <a:cs typeface="Noto Sans SC"/>
               </a:rPr>
-              <a:t>合作名称与背书须另行约定；试点结果与 C</a:t>
+              <a:t>以使用反馈评估产品价值，以服务记录完善</a:t>
             </a:r>
           </a:p>
           <a:p xmlns:a="http://schemas.openxmlformats.org/drawingml/2006/main">
@@ -14332,7 +14150,7 @@
                 <a:ea typeface="Noto Sans SC"/>
                 <a:cs typeface="Noto Sans SC"/>
               </a:rPr>
-              <a:t> 端付费分开统计。</a:t>
+              <a:t>交付方案。</a:t>
             </a:r>
           </a:p>
         </p:txBody>
@@ -14342,7 +14160,7 @@
           <p:cNvPr id="12" name="takeaway">
             <a:extLst xmlns:a="http://schemas.openxmlformats.org/drawingml/2006/main">
               <a:ext uri="{FF2B5EF4-FFF2-40B4-BE49-F238E27FC236}">
-                <a16:creationId xmlns:a16="http://schemas.microsoft.com/office/drawing/2014/main" id="{B3E53DA8-109D-4CEE-9694-9638432F7B9D}"/>
+                <a16:creationId xmlns:a16="http://schemas.microsoft.com/office/drawing/2014/main" id="{47FB85C6-32FB-4867-92F5-8465FA52EDC2}"/>
               </a:ext>
             </a:extLst>
           </p:cNvPr>
@@ -14400,7 +14218,7 @@
                 <a:ea typeface="Noto Sans SC"/>
                 <a:cs typeface="Noto Sans SC"/>
               </a:rPr>
-              <a:t>公益可验证价值与服务能力；不能直接替代消费者自费购买的证据。</a:t>
+              <a:t>机构采购与消费者自费订单分别统计，合作名称及背书按协议使用。</a:t>
             </a:r>
           </a:p>
         </p:txBody>
@@ -14410,7 +14228,7 @@
           <p:cNvPr id="13" name="page">
             <a:extLst xmlns:a="http://schemas.openxmlformats.org/drawingml/2006/main">
               <a:ext uri="{FF2B5EF4-FFF2-40B4-BE49-F238E27FC236}">
-                <a16:creationId xmlns:a16="http://schemas.microsoft.com/office/drawing/2014/main" id="{8C9E6483-A385-4D2B-846B-C5CDDB10AC8B}"/>
+                <a16:creationId xmlns:a16="http://schemas.microsoft.com/office/drawing/2014/main" id="{F478C026-5B46-4B46-B7AF-244CA256EB39}"/>
               </a:ext>
             </a:extLst>
           </p:cNvPr>
@@ -14478,7 +14296,7 @@
           <p:cNvPr id="14" name="source-label">
             <a:extLst xmlns:a="http://schemas.openxmlformats.org/drawingml/2006/main">
               <a:ext uri="{FF2B5EF4-FFF2-40B4-BE49-F238E27FC236}">
-                <a16:creationId xmlns:a16="http://schemas.microsoft.com/office/drawing/2014/main" id="{BF44D9EB-0F47-4F83-94D2-078E38A13FB8}"/>
+                <a16:creationId xmlns:a16="http://schemas.microsoft.com/office/drawing/2014/main" id="{81418284-5FCD-477C-8903-B85A580601D5}"/>
               </a:ext>
             </a:extLst>
           </p:cNvPr>
@@ -14546,7 +14364,7 @@
           <p:cNvPr id="15" name="source-U3">
             <a:extLst xmlns:a="http://schemas.openxmlformats.org/drawingml/2006/main">
               <a:ext uri="{FF2B5EF4-FFF2-40B4-BE49-F238E27FC236}">
-                <a16:creationId xmlns:a16="http://schemas.microsoft.com/office/drawing/2014/main" id="{60233049-F30A-4BEA-8F8D-0A1E36291A86}"/>
+                <a16:creationId xmlns:a16="http://schemas.microsoft.com/office/drawing/2014/main" id="{5D655022-8F87-4385-9C48-6CCE01CC7BA1}"/>
               </a:ext>
             </a:extLst>
           </p:cNvPr>
@@ -14612,7 +14430,7 @@
     </p:spTree>
     <p:extLst>
       <p:ext uri="{BB962C8B-B14F-4D97-AF65-F5344CB8AC3E}">
-        <p14:creationId xmlns:p14="http://schemas.microsoft.com/office/powerpoint/2010/main" val="570328801"/>
+        <p14:creationId xmlns:p14="http://schemas.microsoft.com/office/powerpoint/2010/main" val="311116624"/>
       </p:ext>
     </p:extLst>
   </p:cSld>
@@ -14643,7 +14461,7 @@
           <p:cNvPr id="16" name="section">
             <a:extLst xmlns:a="http://schemas.openxmlformats.org/drawingml/2006/main">
               <a:ext uri="{FF2B5EF4-FFF2-40B4-BE49-F238E27FC236}">
-                <a16:creationId xmlns:a16="http://schemas.microsoft.com/office/drawing/2014/main" id="{98158362-0B23-4A29-86E0-33EF481CE168}"/>
+                <a16:creationId xmlns:a16="http://schemas.microsoft.com/office/drawing/2014/main" id="{B976D4C2-1ECF-4F54-B00A-5CB8653EAFF3}"/>
               </a:ext>
             </a:extLst>
           </p:cNvPr>
@@ -14711,7 +14529,7 @@
           <p:cNvPr id="2" name="title">
             <a:extLst xmlns:a="http://schemas.openxmlformats.org/drawingml/2006/main">
               <a:ext uri="{FF2B5EF4-FFF2-40B4-BE49-F238E27FC236}">
-                <a16:creationId xmlns:a16="http://schemas.microsoft.com/office/drawing/2014/main" id="{D3E55BA8-2E34-421C-9A6E-512584C32008}"/>
+                <a16:creationId xmlns:a16="http://schemas.microsoft.com/office/drawing/2014/main" id="{41AB1FFE-B080-4CFC-B3E0-6B11557F207A}"/>
               </a:ext>
             </a:extLst>
           </p:cNvPr>
@@ -14769,7 +14587,7 @@
                 <a:ea typeface="Noto Sans SC"/>
                 <a:cs typeface="Noto Sans SC"/>
               </a:rPr>
-              <a:t>市场方案 C｜海外需求测试</a:t>
+              <a:t>海外需求验证</a:t>
             </a:r>
           </a:p>
         </p:txBody>
@@ -14779,7 +14597,7 @@
           <p:cNvPr id="3" name="lead">
             <a:extLst xmlns:a="http://schemas.openxmlformats.org/drawingml/2006/main">
               <a:ext uri="{FF2B5EF4-FFF2-40B4-BE49-F238E27FC236}">
-                <a16:creationId xmlns:a16="http://schemas.microsoft.com/office/drawing/2014/main" id="{D3BA2DF5-D73A-45E6-AD1E-A732F9CC36BD}"/>
+                <a16:creationId xmlns:a16="http://schemas.microsoft.com/office/drawing/2014/main" id="{CF3C51EC-761D-458C-8595-C4DD20CE821C}"/>
               </a:ext>
             </a:extLst>
           </p:cNvPr>
@@ -14837,7 +14655,7 @@
                 <a:ea typeface="Noto Sans SC"/>
                 <a:cs typeface="Noto Sans SC"/>
               </a:rPr>
-              <a:t>先选择一个团队能够触达的市场，用小规模测试判断投入价值。</a:t>
+              <a:t>选择团队能够触达的市场，先用小规模测试评估需求。</a:t>
             </a:r>
           </a:p>
         </p:txBody>
@@ -14847,7 +14665,7 @@
           <p:cNvPr id="4" name="col-0-title">
             <a:extLst xmlns:a="http://schemas.openxmlformats.org/drawingml/2006/main">
               <a:ext uri="{FF2B5EF4-FFF2-40B4-BE49-F238E27FC236}">
-                <a16:creationId xmlns:a16="http://schemas.microsoft.com/office/drawing/2014/main" id="{6191E612-3ED5-48DF-B24C-B61FE75DC6E7}"/>
+                <a16:creationId xmlns:a16="http://schemas.microsoft.com/office/drawing/2014/main" id="{F0AD83F6-5BE3-47AD-8245-DA3610FF437B}"/>
               </a:ext>
             </a:extLst>
           </p:cNvPr>
@@ -14905,7 +14723,7 @@
                 <a:ea typeface="Noto Sans SC"/>
                 <a:cs typeface="Noto Sans SC"/>
               </a:rPr>
-              <a:t>现在可并行做</a:t>
+              <a:t>需求测试</a:t>
             </a:r>
           </a:p>
         </p:txBody>
@@ -14915,7 +14733,7 @@
           <p:cNvPr id="5" name="col-0-0">
             <a:extLst xmlns:a="http://schemas.openxmlformats.org/drawingml/2006/main">
               <a:ext uri="{FF2B5EF4-FFF2-40B4-BE49-F238E27FC236}">
-                <a16:creationId xmlns:a16="http://schemas.microsoft.com/office/drawing/2014/main" id="{82FD8D77-AD67-412A-AC24-FD635AD46FE5}"/>
+                <a16:creationId xmlns:a16="http://schemas.microsoft.com/office/drawing/2014/main" id="{A5C6B877-F6EC-4E4B-A639-5F377785138E}"/>
               </a:ext>
             </a:extLst>
           </p:cNvPr>
@@ -14973,30 +14791,7 @@
                 <a:ea typeface="Noto Sans SC"/>
                 <a:cs typeface="Noto Sans SC"/>
               </a:rPr>
-              <a:t>将真实演示制作成目标语言版本，测试用途</a:t>
-            </a:r>
-          </a:p>
-          <a:p xmlns:a="http://schemas.openxmlformats.org/drawingml/2006/main">
-            <a:pPr>
-              <a:defRPr sz="1875" b="0">
-                <a:solidFill>
-                  <a:srgbClr val="17364E"/>
-                </a:solidFill>
-                <a:latin typeface="Noto Sans SC"/>
-                <a:ea typeface="Noto Sans SC"/>
-                <a:cs typeface="Noto Sans SC"/>
-              </a:defRPr>
-            </a:pPr>
-            <a:r>
-              <a:rPr sz="1875" b="0">
-                <a:solidFill>
-                  <a:srgbClr val="17364E"/>
-                </a:solidFill>
-                <a:latin typeface="Noto Sans SC"/>
-                <a:ea typeface="Noto Sans SC"/>
-                <a:cs typeface="Noto Sans SC"/>
-              </a:rPr>
-              <a:t>和价格接受度。</a:t>
+              <a:t>制作目标语言的产品演示。</a:t>
             </a:r>
           </a:p>
         </p:txBody>
@@ -15006,7 +14801,7 @@
           <p:cNvPr id="6" name="col-0-1">
             <a:extLst xmlns:a="http://schemas.openxmlformats.org/drawingml/2006/main">
               <a:ext uri="{FF2B5EF4-FFF2-40B4-BE49-F238E27FC236}">
-                <a16:creationId xmlns:a16="http://schemas.microsoft.com/office/drawing/2014/main" id="{4BA174EA-3EAA-4561-9353-A93E9B5CF112}"/>
+                <a16:creationId xmlns:a16="http://schemas.microsoft.com/office/drawing/2014/main" id="{14A294CA-345B-470F-8D9F-A933A5B99D62}"/>
               </a:ext>
             </a:extLst>
           </p:cNvPr>
@@ -15064,7 +14859,7 @@
                 <a:ea typeface="Noto Sans SC"/>
                 <a:cs typeface="Noto Sans SC"/>
               </a:rPr>
-              <a:t>建立独立意向页，记录流量来源、有效咨询</a:t>
+              <a:t>建立意向页，记录咨询、使用场景与价格反</a:t>
             </a:r>
           </a:p>
           <a:p xmlns:a="http://schemas.openxmlformats.org/drawingml/2006/main">
@@ -15087,7 +14882,7 @@
                 <a:ea typeface="Noto Sans SC"/>
                 <a:cs typeface="Noto Sans SC"/>
               </a:rPr>
-              <a:t>和等待名单。</a:t>
+              <a:t>馈。</a:t>
             </a:r>
           </a:p>
         </p:txBody>
@@ -15097,7 +14892,7 @@
           <p:cNvPr id="7" name="col-0-2">
             <a:extLst xmlns:a="http://schemas.openxmlformats.org/drawingml/2006/main">
               <a:ext uri="{FF2B5EF4-FFF2-40B4-BE49-F238E27FC236}">
-                <a16:creationId xmlns:a16="http://schemas.microsoft.com/office/drawing/2014/main" id="{57CE4AAB-F83B-4468-9DDF-0826A72390A0}"/>
+                <a16:creationId xmlns:a16="http://schemas.microsoft.com/office/drawing/2014/main" id="{AEA3381B-F261-4A1F-AF00-01C6C51CBA69}"/>
               </a:ext>
             </a:extLst>
           </p:cNvPr>
@@ -15155,30 +14950,7 @@
                 <a:ea typeface="Noto Sans SC"/>
                 <a:cs typeface="Noto Sans SC"/>
               </a:rPr>
-              <a:t>优先找可直接服务的试用家庭，减少跨境履</a:t>
-            </a:r>
-          </a:p>
-          <a:p xmlns:a="http://schemas.openxmlformats.org/drawingml/2006/main">
-            <a:pPr>
-              <a:defRPr sz="1875" b="0">
-                <a:solidFill>
-                  <a:srgbClr val="17364E"/>
-                </a:solidFill>
-                <a:latin typeface="Noto Sans SC"/>
-                <a:ea typeface="Noto Sans SC"/>
-                <a:cs typeface="Noto Sans SC"/>
-              </a:defRPr>
-            </a:pPr>
-            <a:r>
-              <a:rPr sz="1875" b="0">
-                <a:solidFill>
-                  <a:srgbClr val="17364E"/>
-                </a:solidFill>
-                <a:latin typeface="Noto Sans SC"/>
-                <a:ea typeface="Noto Sans SC"/>
-                <a:cs typeface="Noto Sans SC"/>
-              </a:rPr>
-              <a:t>约复杂度。</a:t>
+              <a:t>优先安排能够直接支持的家庭试用。</a:t>
             </a:r>
           </a:p>
         </p:txBody>
@@ -15188,7 +14960,7 @@
           <p:cNvPr id="8" name="col-1-title">
             <a:extLst xmlns:a="http://schemas.openxmlformats.org/drawingml/2006/main">
               <a:ext uri="{FF2B5EF4-FFF2-40B4-BE49-F238E27FC236}">
-                <a16:creationId xmlns:a16="http://schemas.microsoft.com/office/drawing/2014/main" id="{88D6F7D5-640B-4B35-9366-4F2241E3AA77}"/>
+                <a16:creationId xmlns:a16="http://schemas.microsoft.com/office/drawing/2014/main" id="{B6F53797-F158-4583-9379-F8CB91E29327}"/>
               </a:ext>
             </a:extLst>
           </p:cNvPr>
@@ -15246,7 +15018,7 @@
                 <a:ea typeface="Noto Sans SC"/>
                 <a:cs typeface="Noto Sans SC"/>
               </a:rPr>
-              <a:t>收到钱之前要补齐</a:t>
+              <a:t>商业化准备</a:t>
             </a:r>
           </a:p>
         </p:txBody>
@@ -15256,7 +15028,7 @@
           <p:cNvPr id="9" name="col-1-0">
             <a:extLst xmlns:a="http://schemas.openxmlformats.org/drawingml/2006/main">
               <a:ext uri="{FF2B5EF4-FFF2-40B4-BE49-F238E27FC236}">
-                <a16:creationId xmlns:a16="http://schemas.microsoft.com/office/drawing/2014/main" id="{5BABF772-8624-4064-A832-FA2C3914CC11}"/>
+                <a16:creationId xmlns:a16="http://schemas.microsoft.com/office/drawing/2014/main" id="{41D74B61-7E23-47E6-A31C-1DE2EA7D1056}"/>
               </a:ext>
             </a:extLst>
           </p:cNvPr>
@@ -15314,30 +15086,7 @@
                 <a:ea typeface="Noto Sans SC"/>
                 <a:cs typeface="Noto Sans SC"/>
               </a:rPr>
-              <a:t>确认支付、物流、售后和该市场适用的产品</a:t>
-            </a:r>
-          </a:p>
-          <a:p xmlns:a="http://schemas.openxmlformats.org/drawingml/2006/main">
-            <a:pPr>
-              <a:defRPr sz="1875" b="0">
-                <a:solidFill>
-                  <a:srgbClr val="17364E"/>
-                </a:solidFill>
-                <a:latin typeface="Noto Sans SC"/>
-                <a:ea typeface="Noto Sans SC"/>
-                <a:cs typeface="Noto Sans SC"/>
-              </a:defRPr>
-            </a:pPr>
-            <a:r>
-              <a:rPr sz="1875" b="0">
-                <a:solidFill>
-                  <a:srgbClr val="17364E"/>
-                </a:solidFill>
-                <a:latin typeface="Noto Sans SC"/>
-                <a:ea typeface="Noto Sans SC"/>
-                <a:cs typeface="Noto Sans SC"/>
-              </a:rPr>
-              <a:t>要求。</a:t>
+              <a:t>核算物流、税费、支付与售后成本。</a:t>
             </a:r>
           </a:p>
         </p:txBody>
@@ -15347,7 +15096,7 @@
           <p:cNvPr id="10" name="col-1-1">
             <a:extLst xmlns:a="http://schemas.openxmlformats.org/drawingml/2006/main">
               <a:ext uri="{FF2B5EF4-FFF2-40B4-BE49-F238E27FC236}">
-                <a16:creationId xmlns:a16="http://schemas.microsoft.com/office/drawing/2014/main" id="{E70F3058-ED12-4615-8003-1BE2AB64EB83}"/>
+                <a16:creationId xmlns:a16="http://schemas.microsoft.com/office/drawing/2014/main" id="{D0B2E884-CFF6-400B-AC90-5511F8085ED1}"/>
               </a:ext>
             </a:extLst>
           </p:cNvPr>
@@ -15405,7 +15154,7 @@
                 <a:ea typeface="Noto Sans SC"/>
                 <a:cs typeface="Noto Sans SC"/>
               </a:rPr>
-              <a:t>算清到岸成本、平台费用、退款与返修预算。</a:t>
+              <a:t>确认当地产品要求与服务方式。</a:t>
             </a:r>
           </a:p>
         </p:txBody>
@@ -15415,7 +15164,7 @@
           <p:cNvPr id="11" name="col-1-2">
             <a:extLst xmlns:a="http://schemas.openxmlformats.org/drawingml/2006/main">
               <a:ext uri="{FF2B5EF4-FFF2-40B4-BE49-F238E27FC236}">
-                <a16:creationId xmlns:a16="http://schemas.microsoft.com/office/drawing/2014/main" id="{5D4B7D9E-1046-422B-948A-54765490E34B}"/>
+                <a16:creationId xmlns:a16="http://schemas.microsoft.com/office/drawing/2014/main" id="{0FD12D76-388A-4F44-98AD-E42EA2A4B2C0}"/>
               </a:ext>
             </a:extLst>
           </p:cNvPr>
@@ -15473,7 +15222,7 @@
                 <a:ea typeface="Noto Sans SC"/>
                 <a:cs typeface="Noto Sans SC"/>
               </a:rPr>
-              <a:t>国内产品稳定后，再决定当地合作渠道或预</a:t>
+              <a:t>结合国内验证结果，评估当地渠道和预售方</a:t>
             </a:r>
           </a:p>
           <a:p xmlns:a="http://schemas.openxmlformats.org/drawingml/2006/main">
@@ -15496,7 +15245,7 @@
                 <a:ea typeface="Noto Sans SC"/>
                 <a:cs typeface="Noto Sans SC"/>
               </a:rPr>
-              <a:t>售方式。</a:t>
+              <a:t>案。</a:t>
             </a:r>
           </a:p>
         </p:txBody>
@@ -15506,7 +15255,7 @@
           <p:cNvPr id="12" name="takeaway">
             <a:extLst xmlns:a="http://schemas.openxmlformats.org/drawingml/2006/main">
               <a:ext uri="{FF2B5EF4-FFF2-40B4-BE49-F238E27FC236}">
-                <a16:creationId xmlns:a16="http://schemas.microsoft.com/office/drawing/2014/main" id="{3BEBD303-8D0D-4EB6-BA3E-3EBB35289594}"/>
+                <a16:creationId xmlns:a16="http://schemas.microsoft.com/office/drawing/2014/main" id="{3B840F67-A166-412A-9408-A8253742EDDD}"/>
               </a:ext>
             </a:extLst>
           </p:cNvPr>
@@ -15564,7 +15313,7 @@
                 <a:ea typeface="Noto Sans SC"/>
                 <a:cs typeface="Noto Sans SC"/>
               </a:rPr>
-              <a:t>海外兴趣数据单独看；目前不把海外市场作为首批量产的确定资金来源。</a:t>
+              <a:t>先形成目标市场的需求证据，再确定投入规模与上线安排。</a:t>
             </a:r>
           </a:p>
         </p:txBody>
@@ -15574,7 +15323,7 @@
           <p:cNvPr id="13" name="page">
             <a:extLst xmlns:a="http://schemas.openxmlformats.org/drawingml/2006/main">
               <a:ext uri="{FF2B5EF4-FFF2-40B4-BE49-F238E27FC236}">
-                <a16:creationId xmlns:a16="http://schemas.microsoft.com/office/drawing/2014/main" id="{E38BB37C-80DC-40B5-BC9D-F02D9415EF4C}"/>
+                <a16:creationId xmlns:a16="http://schemas.microsoft.com/office/drawing/2014/main" id="{B0D14461-4445-4DFD-87A7-3ACEAB9D18F0}"/>
               </a:ext>
             </a:extLst>
           </p:cNvPr>
@@ -15642,7 +15391,7 @@
           <p:cNvPr id="14" name="source-label">
             <a:extLst xmlns:a="http://schemas.openxmlformats.org/drawingml/2006/main">
               <a:ext uri="{FF2B5EF4-FFF2-40B4-BE49-F238E27FC236}">
-                <a16:creationId xmlns:a16="http://schemas.microsoft.com/office/drawing/2014/main" id="{EE6B1A96-D621-4EF7-9444-F46803418955}"/>
+                <a16:creationId xmlns:a16="http://schemas.microsoft.com/office/drawing/2014/main" id="{0F656769-D546-4E4D-B568-AF6F0A5E09D0}"/>
               </a:ext>
             </a:extLst>
           </p:cNvPr>
@@ -15710,7 +15459,7 @@
           <p:cNvPr id="15" name="source-U3">
             <a:extLst xmlns:a="http://schemas.openxmlformats.org/drawingml/2006/main">
               <a:ext uri="{FF2B5EF4-FFF2-40B4-BE49-F238E27FC236}">
-                <a16:creationId xmlns:a16="http://schemas.microsoft.com/office/drawing/2014/main" id="{676AFE2C-FDFC-47A3-A364-86B871608963}"/>
+                <a16:creationId xmlns:a16="http://schemas.microsoft.com/office/drawing/2014/main" id="{1D4FA32D-B424-4B16-B92D-4AB5CC332BA1}"/>
               </a:ext>
             </a:extLst>
           </p:cNvPr>
@@ -15776,7 +15525,7 @@
     </p:spTree>
     <p:extLst>
       <p:ext uri="{BB962C8B-B14F-4D97-AF65-F5344CB8AC3E}">
-        <p14:creationId xmlns:p14="http://schemas.microsoft.com/office/powerpoint/2010/main" val="2039299891"/>
+        <p14:creationId xmlns:p14="http://schemas.microsoft.com/office/powerpoint/2010/main" val="2029066369"/>
       </p:ext>
     </p:extLst>
   </p:cSld>
@@ -15804,10 +15553,10 @@
       </p:grpSpPr>
       <p:sp>
         <p:nvSpPr>
-          <p:cNvPr id="10" name="section">
-            <a:extLst xmlns:a="http://schemas.openxmlformats.org/drawingml/2006/main">
-              <a:ext uri="{FF2B5EF4-FFF2-40B4-BE49-F238E27FC236}">
-                <a16:creationId xmlns:a16="http://schemas.microsoft.com/office/drawing/2014/main" id="{76828331-0489-43FE-9506-F869D40C883A}"/>
+          <p:cNvPr id="9" name="section">
+            <a:extLst xmlns:a="http://schemas.openxmlformats.org/drawingml/2006/main">
+              <a:ext uri="{FF2B5EF4-FFF2-40B4-BE49-F238E27FC236}">
+                <a16:creationId xmlns:a16="http://schemas.microsoft.com/office/drawing/2014/main" id="{E75B0A6B-C269-4963-BA43-3B00377DFFF4}"/>
               </a:ext>
             </a:extLst>
           </p:cNvPr>
@@ -15865,7 +15614,7 @@
                 <a:ea typeface="Noto Sans SC"/>
                 <a:cs typeface="Noto Sans SC"/>
               </a:rPr>
-              <a:t>与影石合作 · 3 分钟</a:t>
+              <a:t>合作路径 · 3 分钟</a:t>
             </a:r>
           </a:p>
         </p:txBody>
@@ -15875,7 +15624,7 @@
           <p:cNvPr id="2" name="title">
             <a:extLst xmlns:a="http://schemas.openxmlformats.org/drawingml/2006/main">
               <a:ext uri="{FF2B5EF4-FFF2-40B4-BE49-F238E27FC236}">
-                <a16:creationId xmlns:a16="http://schemas.microsoft.com/office/drawing/2014/main" id="{0594CB24-4EBF-4A83-80E9-2D342B3539E1}"/>
+                <a16:creationId xmlns:a16="http://schemas.microsoft.com/office/drawing/2014/main" id="{E6663055-ED04-420C-9ADA-67A3C0440365}"/>
               </a:ext>
             </a:extLst>
           </p:cNvPr>
@@ -15933,7 +15682,7 @@
                 <a:ea typeface="Noto Sans SC"/>
                 <a:cs typeface="Noto Sans SC"/>
               </a:rPr>
-              <a:t>合作模式：共创、孵化或独立推进</a:t>
+              <a:t>合作模式</a:t>
             </a:r>
           </a:p>
         </p:txBody>
@@ -15943,7 +15692,7 @@
           <p:cNvPr id="3" name="lead">
             <a:extLst xmlns:a="http://schemas.openxmlformats.org/drawingml/2006/main">
               <a:ext uri="{FF2B5EF4-FFF2-40B4-BE49-F238E27FC236}">
-                <a16:creationId xmlns:a16="http://schemas.microsoft.com/office/drawing/2014/main" id="{1B021F2E-13AD-4C12-BA7C-D76562CA0EC9}"/>
+                <a16:creationId xmlns:a16="http://schemas.microsoft.com/office/drawing/2014/main" id="{1F0B8ECE-C65C-4B45-94A1-C06460D18071}"/>
               </a:ext>
             </a:extLst>
           </p:cNvPr>
@@ -16001,7 +15750,7 @@
                 <a:ea typeface="Noto Sans SC"/>
                 <a:cs typeface="Noto Sans SC"/>
               </a:rPr>
-              <a:t>先选择一个可执行的合作方式，再确定产品与资金责任。</a:t>
+              <a:t>不同资源对应不同合作方式，按阶段约定投入与成果。</a:t>
             </a:r>
           </a:p>
         </p:txBody>
@@ -16011,7 +15760,7 @@
           <p:cNvPr id="4" name="">
             <a:extLst xmlns:a="http://schemas.openxmlformats.org/drawingml/2006/main">
               <a:ext uri="{FF2B5EF4-FFF2-40B4-BE49-F238E27FC236}">
-                <a16:creationId xmlns:a16="http://schemas.microsoft.com/office/drawing/2014/main" id="{63586183-B23B-4A48-B745-8675413ECF3E}"/>
+                <a16:creationId xmlns:a16="http://schemas.microsoft.com/office/drawing/2014/main" id="{CE0398CB-79B8-4AD3-828B-A8B810F199CA}"/>
               </a:ext>
             </a:extLst>
           </p:cNvPr>
@@ -16048,7 +15797,7 @@
                           <a:ea typeface="Noto Sans SC"/>
                           <a:cs typeface="Noto Sans SC"/>
                         </a:rPr>
-                        <a:t>模式</a:t>
+                        <a:t>合作方式</a:t>
                       </a:r>
                     </a:p>
                   </a:txBody>
@@ -16074,7 +15823,7 @@
                           <a:ea typeface="Noto Sans SC"/>
                           <a:cs typeface="Noto Sans SC"/>
                         </a:rPr>
-                        <a:t>双方分工（讨论方案）</a:t>
+                        <a:t>支持内容</a:t>
                       </a:r>
                     </a:p>
                   </a:txBody>
@@ -16100,7 +15849,7 @@
                           <a:ea typeface="Noto Sans SC"/>
                           <a:cs typeface="Noto Sans SC"/>
                         </a:rPr>
-                        <a:t>资金与经营安排</a:t>
+                        <a:t>团队工作与阶段成果</a:t>
                       </a:r>
                     </a:p>
                   </a:txBody>
@@ -16154,7 +15903,7 @@
                           <a:ea typeface="Noto Sans SC"/>
                           <a:cs typeface="Noto Sans SC"/>
                         </a:rPr>
-                        <a:t>我们做体验与试用；影石协助硬件和技术对接</a:t>
+                        <a:t>工程资源、硬件方案与样机经费</a:t>
                       </a:r>
                     </a:p>
                   </a:txBody>
@@ -16180,7 +15929,7 @@
                           <a:ea typeface="Noto Sans SC"/>
                           <a:cs typeface="Noto Sans SC"/>
                         </a:rPr>
-                        <a:t>按阶段约定研发／样机预算；品牌与知识产权另定</a:t>
+                        <a:t>产品体验与试用验证，形成样机及成本依据</a:t>
                       </a:r>
                     </a:p>
                   </a:txBody>
@@ -16234,7 +15983,7 @@
                           <a:ea typeface="Noto Sans SC"/>
                           <a:cs typeface="Noto Sans SC"/>
                         </a:rPr>
-                        <a:t>团队持续运营；影石或关联机构提供资源与辅导</a:t>
+                        <a:t>设备、场地、试点经费与创业辅导</a:t>
                       </a:r>
                     </a:p>
                   </a:txBody>
@@ -16260,7 +16009,7 @@
                           <a:ea typeface="Noto Sans SC"/>
                           <a:cs typeface="Noto Sans SC"/>
                         </a:rPr>
-                        <a:t>可讨论试点经费、设备及办公支持；股权条件单列</a:t>
+                        <a:t>按里程碑推进验证，建立持续运营能力</a:t>
                       </a:r>
                     </a:p>
                   </a:txBody>
@@ -16288,7 +16037,7 @@
                           <a:ea typeface="Noto Sans SC"/>
                           <a:cs typeface="Noto Sans SC"/>
                         </a:rPr>
-                        <a:t>独立产品＋授权店</a:t>
+                        <a:t>渠道合作</a:t>
                       </a:r>
                     </a:p>
                   </a:txBody>
@@ -16314,7 +16063,7 @@
                           <a:ea typeface="Noto Sans SC"/>
                           <a:cs typeface="Noto Sans SC"/>
                         </a:rPr>
-                        <a:t>我们承担产品运营；影石授权明确的品牌／渠道范围</a:t>
+                        <a:t>销售渠道、品牌授权与推广资源</a:t>
                       </a:r>
                     </a:p>
                   </a:txBody>
@@ -16340,7 +16089,7 @@
                           <a:ea typeface="Noto Sans SC"/>
                           <a:cs typeface="Noto Sans SC"/>
                         </a:rPr>
-                        <a:t>明确店铺主体、收款分成、售后与独家期限</a:t>
+                        <a:t>配套产品和服务，形成订单及交付记录</a:t>
                       </a:r>
                     </a:p>
                   </a:txBody>
@@ -16368,7 +16117,7 @@
                           <a:ea typeface="Noto Sans SC"/>
                           <a:cs typeface="Noto Sans SC"/>
                         </a:rPr>
-                        <a:t>独立推进</a:t>
+                        <a:t>股权投资</a:t>
                       </a:r>
                     </a:p>
                   </a:txBody>
@@ -16394,7 +16143,7 @@
                           <a:ea typeface="Noto Sans SC"/>
                           <a:cs typeface="Noto Sans SC"/>
                         </a:rPr>
-                        <a:t>不依赖合作到位，继续核心样机与需求验证</a:t>
+                        <a:t>与阶段目标相匹配的资金</a:t>
                       </a:r>
                     </a:p>
                   </a:txBody>
@@ -16420,7 +16169,7 @@
                           <a:ea typeface="Noto Sans SC"/>
                           <a:cs typeface="Noto Sans SC"/>
                         </a:rPr>
-                        <a:t>投入控制在已有预算内，结果成熟后再对接融资</a:t>
+                        <a:t>按约定计划研发和拓展，定期报告经营进展</a:t>
                       </a:r>
                     </a:p>
                   </a:txBody>
@@ -16440,7 +16189,7 @@
           <p:cNvPr id="5" name="takeaway">
             <a:extLst xmlns:a="http://schemas.openxmlformats.org/drawingml/2006/main">
               <a:ext uri="{FF2B5EF4-FFF2-40B4-BE49-F238E27FC236}">
-                <a16:creationId xmlns:a16="http://schemas.microsoft.com/office/drawing/2014/main" id="{C0890356-6C94-4667-ACF3-BD3FCDC77111}"/>
+                <a16:creationId xmlns:a16="http://schemas.microsoft.com/office/drawing/2014/main" id="{11EAEE3A-27F8-4536-B2F1-B631E71152A0}"/>
               </a:ext>
             </a:extLst>
           </p:cNvPr>
@@ -16498,7 +16247,7 @@
                 <a:ea typeface="Noto Sans SC"/>
                 <a:cs typeface="Noto Sans SC"/>
               </a:rPr>
-              <a:t>建议先争取样机阶段的共创支持，再依据试用与订单证据讨论更深合作。</a:t>
+              <a:t>合作方可参与新场景验证，具体权益、品牌与知识产权安排另行约定。</a:t>
             </a:r>
           </a:p>
         </p:txBody>
@@ -16508,7 +16257,7 @@
           <p:cNvPr id="6" name="page">
             <a:extLst xmlns:a="http://schemas.openxmlformats.org/drawingml/2006/main">
               <a:ext uri="{FF2B5EF4-FFF2-40B4-BE49-F238E27FC236}">
-                <a16:creationId xmlns:a16="http://schemas.microsoft.com/office/drawing/2014/main" id="{E272B5C4-2431-4DDC-869B-DFFA84660C80}"/>
+                <a16:creationId xmlns:a16="http://schemas.microsoft.com/office/drawing/2014/main" id="{7B2BD9D0-715B-40D7-B7A1-F08712590700}"/>
               </a:ext>
             </a:extLst>
           </p:cNvPr>
@@ -16576,7 +16325,7 @@
           <p:cNvPr id="7" name="source-label">
             <a:extLst xmlns:a="http://schemas.openxmlformats.org/drawingml/2006/main">
               <a:ext uri="{FF2B5EF4-FFF2-40B4-BE49-F238E27FC236}">
-                <a16:creationId xmlns:a16="http://schemas.microsoft.com/office/drawing/2014/main" id="{BA68DAEF-1B31-4ED7-BE07-DCEC9AFFDB2A}"/>
+                <a16:creationId xmlns:a16="http://schemas.microsoft.com/office/drawing/2014/main" id="{FAD95DE8-3930-4D76-B834-580E1E1821A5}"/>
               </a:ext>
             </a:extLst>
           </p:cNvPr>
@@ -16644,7 +16393,7 @@
           <p:cNvPr id="8" name="source-U3">
             <a:extLst xmlns:a="http://schemas.openxmlformats.org/drawingml/2006/main">
               <a:ext uri="{FF2B5EF4-FFF2-40B4-BE49-F238E27FC236}">
-                <a16:creationId xmlns:a16="http://schemas.microsoft.com/office/drawing/2014/main" id="{1EDFC0AA-4CBE-415B-86F7-68DA08DF45A9}"/>
+                <a16:creationId xmlns:a16="http://schemas.microsoft.com/office/drawing/2014/main" id="{FA287D9F-D683-4602-B49A-CE103670155D}"/>
               </a:ext>
             </a:extLst>
           </p:cNvPr>
@@ -16707,79 +16456,10 @@
           </a:p>
         </p:txBody>
       </p:sp>
-      <p:sp>
-        <p:nvSpPr>
-          <p:cNvPr id="9" name="source-A1">
-            <a:extLst xmlns:a="http://schemas.openxmlformats.org/drawingml/2006/main">
-              <a:ext uri="{FF2B5EF4-FFF2-40B4-BE49-F238E27FC236}">
-                <a16:creationId xmlns:a16="http://schemas.microsoft.com/office/drawing/2014/main" id="{38FED888-EFBD-4E44-BE0E-7379F8FE0491}"/>
-              </a:ext>
-            </a:extLst>
-          </p:cNvPr>
-          <p:cNvSpPr>
-            <a:spLocks xmlns:a="http://schemas.openxmlformats.org/drawingml/2006/main" noGrp="1"/>
-          </p:cNvSpPr>
-          <p:nvPr/>
-        </p:nvSpPr>
-        <p:spPr>
-          <a:xfrm xmlns:a="http://schemas.openxmlformats.org/drawingml/2006/main">
-            <a:off x="1657350" y="6457950"/>
-            <a:ext cx="647700" cy="190500"/>
-          </a:xfrm>
-          <a:prstGeom xmlns:a="http://schemas.openxmlformats.org/drawingml/2006/main" prst="rect">
-            <a:avLst/>
-          </a:prstGeom>
-          <a:noFill xmlns:a="http://schemas.openxmlformats.org/drawingml/2006/main"/>
-          <a:ln xmlns:a="http://schemas.openxmlformats.org/drawingml/2006/main" w="0">
-            <a:noFill/>
-          </a:ln>
-        </p:spPr>
-        <p:txBody>
-          <a:bodyPr xmlns:a="http://schemas.openxmlformats.org/drawingml/2006/main" wrap="square" lIns="0" tIns="0" rIns="0" bIns="0" anchor="t">
-            <a:noAutofit/>
-          </a:bodyPr>
-          <a:lstStyle xmlns:a="http://schemas.openxmlformats.org/drawingml/2006/main">
-            <a:defPPr>
-              <a:defRPr sz="1050" b="0">
-                <a:solidFill>
-                  <a:srgbClr val="197780"/>
-                </a:solidFill>
-                <a:latin typeface="Noto Sans SC"/>
-                <a:ea typeface="Noto Sans SC"/>
-                <a:cs typeface="Noto Sans SC"/>
-              </a:defRPr>
-            </a:defPPr>
-          </a:lstStyle>
-          <a:p xmlns:a="http://schemas.openxmlformats.org/drawingml/2006/main">
-            <a:pPr>
-              <a:defRPr sz="1050" b="0">
-                <a:solidFill>
-                  <a:srgbClr val="197780"/>
-                </a:solidFill>
-                <a:latin typeface="Noto Sans SC"/>
-                <a:ea typeface="Noto Sans SC"/>
-                <a:cs typeface="Noto Sans SC"/>
-              </a:defRPr>
-            </a:pPr>
-            <a:r>
-              <a:rPr sz="1050" b="0">
-                <a:solidFill>
-                  <a:srgbClr val="197780"/>
-                </a:solidFill>
-                <a:latin typeface="Noto Sans SC"/>
-                <a:ea typeface="Noto Sans SC"/>
-                <a:cs typeface="Noto Sans SC"/>
-                <a:hlinkClick xmlns:r="http://schemas.openxmlformats.org/officeDocument/2006/relationships" r:id="Rb252249737ba46d5"/>
-              </a:rPr>
-              <a:t>A1 ↗</a:t>
-            </a:r>
-          </a:p>
-        </p:txBody>
-      </p:sp>
     </p:spTree>
     <p:extLst>
       <p:ext uri="{BB962C8B-B14F-4D97-AF65-F5344CB8AC3E}">
-        <p14:creationId xmlns:p14="http://schemas.microsoft.com/office/powerpoint/2010/main" val="1990619996"/>
+        <p14:creationId xmlns:p14="http://schemas.microsoft.com/office/powerpoint/2010/main" val="1625938196"/>
       </p:ext>
     </p:extLst>
   </p:cSld>
@@ -16810,7 +16490,7 @@
           <p:cNvPr id="7" name="section">
             <a:extLst xmlns:a="http://schemas.openxmlformats.org/drawingml/2006/main">
               <a:ext uri="{FF2B5EF4-FFF2-40B4-BE49-F238E27FC236}">
-                <a16:creationId xmlns:a16="http://schemas.microsoft.com/office/drawing/2014/main" id="{D4C4148D-8BA9-45E9-A621-82A4E03124E7}"/>
+                <a16:creationId xmlns:a16="http://schemas.microsoft.com/office/drawing/2014/main" id="{53BA152E-F7A4-4A81-BDA3-023C32F7EB2B}"/>
               </a:ext>
             </a:extLst>
           </p:cNvPr>
@@ -16868,7 +16548,7 @@
                 <a:ea typeface="Noto Sans SC"/>
                 <a:cs typeface="Noto Sans SC"/>
               </a:rPr>
-              <a:t>产品化责任 · 2 分钟</a:t>
+              <a:t>产品化安排 · 2 分钟</a:t>
             </a:r>
           </a:p>
         </p:txBody>
@@ -16878,7 +16558,7 @@
           <p:cNvPr id="2" name="title">
             <a:extLst xmlns:a="http://schemas.openxmlformats.org/drawingml/2006/main">
               <a:ext uri="{FF2B5EF4-FFF2-40B4-BE49-F238E27FC236}">
-                <a16:creationId xmlns:a16="http://schemas.microsoft.com/office/drawing/2014/main" id="{206C30EB-11A1-4201-BB5E-AF7D081B1538}"/>
+                <a16:creationId xmlns:a16="http://schemas.microsoft.com/office/drawing/2014/main" id="{8DFBD313-A746-46A9-882C-2B98CD5E051B}"/>
               </a:ext>
             </a:extLst>
           </p:cNvPr>
@@ -16936,7 +16616,7 @@
                 <a:ea typeface="Noto Sans SC"/>
                 <a:cs typeface="Noto Sans SC"/>
               </a:rPr>
-              <a:t>如果影石支持开模，后续谁来做</a:t>
+              <a:t>工程支持与量产衔接</a:t>
             </a:r>
           </a:p>
         </p:txBody>
@@ -16946,7 +16626,7 @@
           <p:cNvPr id="3" name="lead">
             <a:extLst xmlns:a="http://schemas.openxmlformats.org/drawingml/2006/main">
               <a:ext uri="{FF2B5EF4-FFF2-40B4-BE49-F238E27FC236}">
-                <a16:creationId xmlns:a16="http://schemas.microsoft.com/office/drawing/2014/main" id="{8770C7C5-1D1F-45A0-A7B2-E2A4CD992D03}"/>
+                <a16:creationId xmlns:a16="http://schemas.microsoft.com/office/drawing/2014/main" id="{B8C91572-96C6-4C10-B145-08CE54703226}"/>
               </a:ext>
             </a:extLst>
           </p:cNvPr>
@@ -17004,7 +16684,7 @@
                 <a:ea typeface="Noto Sans SC"/>
                 <a:cs typeface="Noto Sans SC"/>
               </a:rPr>
-              <a:t>开模解决的是一部分前期投入；产品经营与首批生产仍需单独安排。</a:t>
+              <a:t>获得设计或开模支持后，可推进试产准备，并同步落实生产与服务安排。</a:t>
             </a:r>
           </a:p>
         </p:txBody>
@@ -17014,7 +16694,7 @@
           <p:cNvPr id="4" name="">
             <a:extLst xmlns:a="http://schemas.openxmlformats.org/drawingml/2006/main">
               <a:ext uri="{FF2B5EF4-FFF2-40B4-BE49-F238E27FC236}">
-                <a16:creationId xmlns:a16="http://schemas.microsoft.com/office/drawing/2014/main" id="{362BBF24-A205-4F1F-9C37-BCC4D44AA56A}"/>
+                <a16:creationId xmlns:a16="http://schemas.microsoft.com/office/drawing/2014/main" id="{94595DBE-3439-40DB-B44C-E4983D0CF734}"/>
               </a:ext>
             </a:extLst>
           </p:cNvPr>
@@ -17051,7 +16731,7 @@
                           <a:ea typeface="Noto Sans SC"/>
                           <a:cs typeface="Noto Sans SC"/>
                         </a:rPr>
-                        <a:t>需要定清</a:t>
+                        <a:t>工作环节</a:t>
                       </a:r>
                     </a:p>
                   </a:txBody>
@@ -17077,7 +16757,7 @@
                           <a:ea typeface="Noto Sans SC"/>
                           <a:cs typeface="Noto Sans SC"/>
                         </a:rPr>
-                        <a:t>具体内容</a:t>
+                        <a:t>需要明确的内容</a:t>
                       </a:r>
                     </a:p>
                   </a:txBody>
@@ -17103,7 +16783,7 @@
                           <a:ea typeface="Noto Sans SC"/>
                           <a:cs typeface="Noto Sans SC"/>
                         </a:rPr>
-                        <a:t>建议责任安排</a:t>
+                        <a:t>预期形成的成果</a:t>
                       </a:r>
                     </a:p>
                   </a:txBody>
@@ -17157,7 +16837,7 @@
                           <a:ea typeface="Noto Sans SC"/>
                           <a:cs typeface="Noto Sans SC"/>
                         </a:rPr>
-                        <a:t>模具费用、所有权、修改费用和可用工厂</a:t>
+                        <a:t>模具费用、所有权、修改与使用范围</a:t>
                       </a:r>
                     </a:p>
                   </a:txBody>
@@ -17183,7 +16863,7 @@
                           <a:ea typeface="Noto Sans SC"/>
                           <a:cs typeface="Noto Sans SC"/>
                         </a:rPr>
-                        <a:t>提供方与团队书面确认；设计验证后再冻结</a:t>
+                        <a:t>通过评审的设计与明确的模具安排</a:t>
                       </a:r>
                     </a:p>
                   </a:txBody>
@@ -17237,7 +16917,7 @@
                           <a:ea typeface="Noto Sans SC"/>
                           <a:cs typeface="Noto Sans SC"/>
                         </a:rPr>
-                        <a:t>供应商、起订量、付款节点、试产和质检</a:t>
+                        <a:t>供应商、起订量、付款节点和质检</a:t>
                       </a:r>
                     </a:p>
                   </a:txBody>
@@ -17263,7 +16943,7 @@
                           <a:ea typeface="Noto Sans SC"/>
                           <a:cs typeface="Noto Sans SC"/>
                         </a:rPr>
-                        <a:t>明确下单主体及谁支付各节点货款</a:t>
+                        <a:t>可执行的试产计划与付款计划</a:t>
                       </a:r>
                     </a:p>
                   </a:txBody>
@@ -17291,7 +16971,7 @@
                           <a:ea typeface="Noto Sans SC"/>
                           <a:cs typeface="Noto Sans SC"/>
                         </a:rPr>
-                        <a:t>店铺与订单</a:t>
+                        <a:t>渠道与订单</a:t>
                       </a:r>
                     </a:p>
                   </a:txBody>
@@ -17317,7 +16997,7 @@
                           <a:ea typeface="Noto Sans SC"/>
                           <a:cs typeface="Noto Sans SC"/>
                         </a:rPr>
-                        <a:t>品牌许可、收款、平台结算、退款和订单数据</a:t>
+                        <a:t>授权范围、收款、平台结算与退款</a:t>
                       </a:r>
                     </a:p>
                   </a:txBody>
@@ -17343,7 +17023,7 @@
                           <a:ea typeface="Noto Sans SC"/>
                           <a:cs typeface="Noto Sans SC"/>
                         </a:rPr>
-                        <a:t>明确店铺运营主体与消费者承诺方</a:t>
+                        <a:t>明确的交易主体与订单规则</a:t>
                       </a:r>
                     </a:p>
                   </a:txBody>
@@ -17397,7 +17077,7 @@
                           <a:ea typeface="Noto Sans SC"/>
                           <a:cs typeface="Noto Sans SC"/>
                         </a:rPr>
-                        <a:t>发货、退换、维修、系统更新和持续服务</a:t>
+                        <a:t>物流、退换、维修与持续服务</a:t>
                       </a:r>
                     </a:p>
                   </a:txBody>
@@ -17423,7 +17103,7 @@
                           <a:ea typeface="Noto Sans SC"/>
                           <a:cs typeface="Noto Sans SC"/>
                         </a:rPr>
-                        <a:t>指定负责方，并在预算中保留服务资金</a:t>
+                        <a:t>服务负责人及相应预算</a:t>
                       </a:r>
                     </a:p>
                   </a:txBody>
@@ -17443,7 +17123,7 @@
           <p:cNvPr id="5" name="takeaway">
             <a:extLst xmlns:a="http://schemas.openxmlformats.org/drawingml/2006/main">
               <a:ext uri="{FF2B5EF4-FFF2-40B4-BE49-F238E27FC236}">
-                <a16:creationId xmlns:a16="http://schemas.microsoft.com/office/drawing/2014/main" id="{8AC1FA99-E6B9-409B-BCD5-28FE2A4B0CD3}"/>
+                <a16:creationId xmlns:a16="http://schemas.microsoft.com/office/drawing/2014/main" id="{5C631534-CA9B-430D-A942-3105E93B8D87}"/>
               </a:ext>
             </a:extLst>
           </p:cNvPr>
@@ -17501,7 +17181,7 @@
                 <a:ea typeface="Noto Sans SC"/>
                 <a:cs typeface="Noto Sans SC"/>
               </a:rPr>
-              <a:t>能获得模具支持，并不意味着后续制造、交付和运营资金已经解决。</a:t>
+              <a:t>工程支持、首批生产与售后资金按环节核算，并对应明确的责任主体。</a:t>
             </a:r>
           </a:p>
         </p:txBody>
@@ -17511,7 +17191,7 @@
           <p:cNvPr id="6" name="page">
             <a:extLst xmlns:a="http://schemas.openxmlformats.org/drawingml/2006/main">
               <a:ext uri="{FF2B5EF4-FFF2-40B4-BE49-F238E27FC236}">
-                <a16:creationId xmlns:a16="http://schemas.microsoft.com/office/drawing/2014/main" id="{E97FC6C2-91B8-4D2E-9D21-E31D6FF12298}"/>
+                <a16:creationId xmlns:a16="http://schemas.microsoft.com/office/drawing/2014/main" id="{C5F8CEE7-79EE-47CF-B346-9E485C840AF1}"/>
               </a:ext>
             </a:extLst>
           </p:cNvPr>
@@ -17577,7 +17257,7 @@
     </p:spTree>
     <p:extLst>
       <p:ext uri="{BB962C8B-B14F-4D97-AF65-F5344CB8AC3E}">
-        <p14:creationId xmlns:p14="http://schemas.microsoft.com/office/powerpoint/2010/main" val="2069063911"/>
+        <p14:creationId xmlns:p14="http://schemas.microsoft.com/office/powerpoint/2010/main" val="801136495"/>
       </p:ext>
     </p:extLst>
   </p:cSld>

</xml_diff>